<commit_message>
Finalize demo assets and scenario consistency
</commit_message>
<xml_diff>
--- a/outputs/adherence-os-demo.pptx
+++ b/outputs/adherence-os-demo.pptx
@@ -2,22 +2,22 @@
 <file path=ppt/presentation.xml><?xml version="1.0" encoding="utf-8"?>
 <p:presentation xmlns:p="http://schemas.openxmlformats.org/presentationml/2006/main">
   <p:sldMasterIdLst>
-    <p:sldMasterId xmlns:r="http://schemas.openxmlformats.org/officeDocument/2006/relationships" id="2147483648" r:id="R9ca9b4019b9546cf"/>
+    <p:sldMasterId xmlns:r="http://schemas.openxmlformats.org/officeDocument/2006/relationships" id="2147483648" r:id="R3eb04cb578e14e25"/>
   </p:sldMasterIdLst>
   <p:notesMasterIdLst>
-    <p:notesMasterId xmlns:r="http://schemas.openxmlformats.org/officeDocument/2006/relationships" r:id="R947bf464e39d4028"/>
+    <p:notesMasterId xmlns:r="http://schemas.openxmlformats.org/officeDocument/2006/relationships" r:id="Rb1e4892aa7c04f15"/>
   </p:notesMasterIdLst>
   <p:sldIdLst>
-    <p:sldId xmlns:r="http://schemas.openxmlformats.org/officeDocument/2006/relationships" id="256" r:id="R09d4f4bf608e4867"/>
-    <p:sldId xmlns:r="http://schemas.openxmlformats.org/officeDocument/2006/relationships" id="257" r:id="R951dec8fc8394dcf"/>
-    <p:sldId xmlns:r="http://schemas.openxmlformats.org/officeDocument/2006/relationships" id="258" r:id="Rce956384713f4950"/>
-    <p:sldId xmlns:r="http://schemas.openxmlformats.org/officeDocument/2006/relationships" id="259" r:id="R0dd409ace06c4d09"/>
-    <p:sldId xmlns:r="http://schemas.openxmlformats.org/officeDocument/2006/relationships" id="260" r:id="R658675297bf741c3"/>
-    <p:sldId xmlns:r="http://schemas.openxmlformats.org/officeDocument/2006/relationships" id="261" r:id="R9a83d5496dd44d69"/>
-    <p:sldId xmlns:r="http://schemas.openxmlformats.org/officeDocument/2006/relationships" id="262" r:id="R90aa50ad3b89417b"/>
-    <p:sldId xmlns:r="http://schemas.openxmlformats.org/officeDocument/2006/relationships" id="263" r:id="Rcdf2446c132b4bf2"/>
-    <p:sldId xmlns:r="http://schemas.openxmlformats.org/officeDocument/2006/relationships" id="264" r:id="R33d59af11bf14be5"/>
-    <p:sldId xmlns:r="http://schemas.openxmlformats.org/officeDocument/2006/relationships" id="265" r:id="Rbf92e8f936af417e"/>
+    <p:sldId xmlns:r="http://schemas.openxmlformats.org/officeDocument/2006/relationships" id="256" r:id="Rfdb54c6ef4ce4263"/>
+    <p:sldId xmlns:r="http://schemas.openxmlformats.org/officeDocument/2006/relationships" id="257" r:id="R837daf82b00c4ebe"/>
+    <p:sldId xmlns:r="http://schemas.openxmlformats.org/officeDocument/2006/relationships" id="258" r:id="R5b8b0a3bc8214991"/>
+    <p:sldId xmlns:r="http://schemas.openxmlformats.org/officeDocument/2006/relationships" id="259" r:id="R03d96176f40b414f"/>
+    <p:sldId xmlns:r="http://schemas.openxmlformats.org/officeDocument/2006/relationships" id="260" r:id="Re3628317d4cb4f80"/>
+    <p:sldId xmlns:r="http://schemas.openxmlformats.org/officeDocument/2006/relationships" id="261" r:id="R5e42501e85b3480f"/>
+    <p:sldId xmlns:r="http://schemas.openxmlformats.org/officeDocument/2006/relationships" id="262" r:id="Rccb5d6cf4da94e1e"/>
+    <p:sldId xmlns:r="http://schemas.openxmlformats.org/officeDocument/2006/relationships" id="263" r:id="R5aa9bf3bf9bf4bf0"/>
+    <p:sldId xmlns:r="http://schemas.openxmlformats.org/officeDocument/2006/relationships" id="264" r:id="Ra039680760844e77"/>
+    <p:sldId xmlns:r="http://schemas.openxmlformats.org/officeDocument/2006/relationships" id="265" r:id="R3e5002c1e500442f"/>
   </p:sldIdLst>
   <p:sldSz cx="12192000" cy="6858000"/>
   <p:notesSz cx="6858000" cy="9144000"/>
@@ -1204,7 +1204,7 @@
   </p:cSld>
   <p:clrMap bg1="lt1" tx1="dk1" bg2="lt2" tx2="dk2" accent1="accent1" accent2="accent2" accent3="accent3" accent4="accent4" accent5="accent5" accent6="accent6" hlink="hlink" folHlink="folHlink"/>
   <p:sldLayoutIdLst>
-    <p:sldLayoutId xmlns:r="http://schemas.openxmlformats.org/officeDocument/2006/relationships" id="2147483649" r:id="R4342d79e321a4b23"/>
+    <p:sldLayoutId xmlns:r="http://schemas.openxmlformats.org/officeDocument/2006/relationships" id="2147483649" r:id="R4a9e621ded2c4c81"/>
   </p:sldLayoutIdLst>
   <p:txStyles>
     <p:titleStyle>
@@ -2192,28 +2192,26 @@
       </p:sp>
       <p:pic>
         <p:nvPicPr>
-          <p:cNvPr id="23" name=""/>
+          <p:cNvPr id="24" name=""/>
           <p:cNvPicPr>
             <a:picLocks xmlns:a="http://schemas.openxmlformats.org/drawingml/2006/main" noChangeAspect="1"/>
           </p:cNvPicPr>
           <p:nvPr/>
         </p:nvPicPr>
         <p:blipFill>
-          <a:blip xmlns:r="http://schemas.openxmlformats.org/officeDocument/2006/relationships" xmlns:a="http://schemas.openxmlformats.org/drawingml/2006/main" r:embed="R8026c6b84a6947d7"/>
+          <a:blip xmlns:r="http://schemas.openxmlformats.org/officeDocument/2006/relationships" xmlns:a="http://schemas.openxmlformats.org/drawingml/2006/main" r:embed="R7a21296205934954"/>
           <a:srcRect xmlns:a="http://schemas.openxmlformats.org/drawingml/2006/main" l="33" t="0" r="33" b="0"/>
           <a:stretch xmlns:a="http://schemas.openxmlformats.org/drawingml/2006/main">
             <a:fillRect l="0" t="0" r="0" b="0"/>
           </a:stretch>
         </p:blipFill>
         <p:spPr>
-          <a:xfrm xmlns:a="http://schemas.openxmlformats.org/drawingml/2006/main">
+          <a:xfrm xmlns:a="http://schemas.openxmlformats.org/drawingml/2006/main" flipH="0" flipV="0">
             <a:off x="5219700" y="971550"/>
             <a:ext cx="6362700" cy="3581400"/>
           </a:xfrm>
           <a:prstGeom xmlns:a="http://schemas.openxmlformats.org/drawingml/2006/main" prst="roundRect">
-            <a:avLst>
-              <a:gd name="adj" fmla="val 2128"/>
-            </a:avLst>
+            <a:avLst/>
           </a:prstGeom>
         </p:spPr>
       </p:pic>
@@ -2839,28 +2837,26 @@
       </p:sp>
       <p:pic>
         <p:nvPicPr>
-          <p:cNvPr id="32" name=""/>
+          <p:cNvPr id="34" name=""/>
           <p:cNvPicPr>
             <a:picLocks xmlns:a="http://schemas.openxmlformats.org/drawingml/2006/main" noChangeAspect="1"/>
           </p:cNvPicPr>
           <p:nvPr/>
         </p:nvPicPr>
         <p:blipFill>
-          <a:blip xmlns:r="http://schemas.openxmlformats.org/officeDocument/2006/relationships" xmlns:a="http://schemas.openxmlformats.org/drawingml/2006/main" r:embed="R42854ea1379c4407"/>
+          <a:blip xmlns:r="http://schemas.openxmlformats.org/officeDocument/2006/relationships" xmlns:a="http://schemas.openxmlformats.org/drawingml/2006/main" r:embed="Rab5d4f89cc924172"/>
           <a:srcRect xmlns:a="http://schemas.openxmlformats.org/drawingml/2006/main" l="0" t="41" r="0" b="41"/>
           <a:stretch xmlns:a="http://schemas.openxmlformats.org/drawingml/2006/main">
             <a:fillRect l="0" t="0" r="0" b="0"/>
           </a:stretch>
         </p:blipFill>
         <p:spPr>
-          <a:xfrm xmlns:a="http://schemas.openxmlformats.org/drawingml/2006/main">
+          <a:xfrm xmlns:a="http://schemas.openxmlformats.org/drawingml/2006/main" flipH="0" flipV="0">
             <a:off x="609600" y="1695450"/>
             <a:ext cx="5219700" cy="2933700"/>
           </a:xfrm>
           <a:prstGeom xmlns:a="http://schemas.openxmlformats.org/drawingml/2006/main" prst="roundRect">
-            <a:avLst>
-              <a:gd name="adj" fmla="val 2597"/>
-            </a:avLst>
+            <a:avLst/>
           </a:prstGeom>
         </p:spPr>
       </p:pic>
@@ -2901,28 +2897,26 @@
       </p:sp>
       <p:pic>
         <p:nvPicPr>
-          <p:cNvPr id="34" name=""/>
+          <p:cNvPr id="36" name=""/>
           <p:cNvPicPr>
             <a:picLocks xmlns:a="http://schemas.openxmlformats.org/drawingml/2006/main" noChangeAspect="1"/>
           </p:cNvPicPr>
           <p:nvPr/>
         </p:nvPicPr>
         <p:blipFill>
-          <a:blip xmlns:r="http://schemas.openxmlformats.org/officeDocument/2006/relationships" xmlns:a="http://schemas.openxmlformats.org/drawingml/2006/main" r:embed="R0f9837e9854a4d58"/>
+          <a:blip xmlns:r="http://schemas.openxmlformats.org/officeDocument/2006/relationships" xmlns:a="http://schemas.openxmlformats.org/drawingml/2006/main" r:embed="R28a14753e99b4954"/>
           <a:srcRect xmlns:a="http://schemas.openxmlformats.org/drawingml/2006/main" l="0" t="41" r="0" b="41"/>
           <a:stretch xmlns:a="http://schemas.openxmlformats.org/drawingml/2006/main">
             <a:fillRect l="0" t="0" r="0" b="0"/>
           </a:stretch>
         </p:blipFill>
         <p:spPr>
-          <a:xfrm xmlns:a="http://schemas.openxmlformats.org/drawingml/2006/main">
+          <a:xfrm xmlns:a="http://schemas.openxmlformats.org/drawingml/2006/main" flipH="0" flipV="0">
             <a:off x="6362700" y="1695450"/>
             <a:ext cx="5219700" cy="2933700"/>
           </a:xfrm>
           <a:prstGeom xmlns:a="http://schemas.openxmlformats.org/drawingml/2006/main" prst="roundRect">
-            <a:avLst>
-              <a:gd name="adj" fmla="val 2597"/>
-            </a:avLst>
+            <a:avLst/>
           </a:prstGeom>
         </p:spPr>
       </p:pic>
@@ -5321,28 +5315,26 @@
       </p:sp>
       <p:pic>
         <p:nvPicPr>
-          <p:cNvPr id="60" name=""/>
+          <p:cNvPr id="61" name=""/>
           <p:cNvPicPr>
             <a:picLocks xmlns:a="http://schemas.openxmlformats.org/drawingml/2006/main" noChangeAspect="1"/>
           </p:cNvPicPr>
           <p:nvPr/>
         </p:nvPicPr>
         <p:blipFill>
-          <a:blip xmlns:r="http://schemas.openxmlformats.org/officeDocument/2006/relationships" xmlns:a="http://schemas.openxmlformats.org/drawingml/2006/main" r:embed="R3c8fe4c09ae842d2"/>
+          <a:blip xmlns:r="http://schemas.openxmlformats.org/officeDocument/2006/relationships" xmlns:a="http://schemas.openxmlformats.org/drawingml/2006/main" r:embed="R3a38a500479c41b5"/>
           <a:srcRect xmlns:a="http://schemas.openxmlformats.org/drawingml/2006/main" l="0" t="0" r="0" b="0"/>
           <a:stretch xmlns:a="http://schemas.openxmlformats.org/drawingml/2006/main">
             <a:fillRect l="0" t="0" r="0" b="0"/>
           </a:stretch>
         </p:blipFill>
         <p:spPr>
-          <a:xfrm xmlns:a="http://schemas.openxmlformats.org/drawingml/2006/main">
+          <a:xfrm xmlns:a="http://schemas.openxmlformats.org/drawingml/2006/main" flipH="0" flipV="0">
             <a:off x="5486400" y="1695450"/>
             <a:ext cx="6096000" cy="3429000"/>
           </a:xfrm>
           <a:prstGeom xmlns:a="http://schemas.openxmlformats.org/drawingml/2006/main" prst="roundRect">
-            <a:avLst>
-              <a:gd name="adj" fmla="val 2222"/>
-            </a:avLst>
+            <a:avLst/>
           </a:prstGeom>
         </p:spPr>
       </p:pic>
@@ -6437,28 +6429,26 @@
       </p:sp>
       <p:pic>
         <p:nvPicPr>
-          <p:cNvPr id="45" name=""/>
+          <p:cNvPr id="46" name=""/>
           <p:cNvPicPr>
             <a:picLocks xmlns:a="http://schemas.openxmlformats.org/drawingml/2006/main" noChangeAspect="1"/>
           </p:cNvPicPr>
           <p:nvPr/>
         </p:nvPicPr>
         <p:blipFill>
-          <a:blip xmlns:r="http://schemas.openxmlformats.org/officeDocument/2006/relationships" xmlns:a="http://schemas.openxmlformats.org/drawingml/2006/main" r:embed="Rc8ac018d72ff4e21"/>
+          <a:blip xmlns:r="http://schemas.openxmlformats.org/officeDocument/2006/relationships" xmlns:a="http://schemas.openxmlformats.org/drawingml/2006/main" r:embed="R727b0827ca4c4c07"/>
           <a:srcRect xmlns:a="http://schemas.openxmlformats.org/drawingml/2006/main" l="0" t="28" r="0" b="28"/>
           <a:stretch xmlns:a="http://schemas.openxmlformats.org/drawingml/2006/main">
             <a:fillRect l="0" t="0" r="0" b="0"/>
           </a:stretch>
         </p:blipFill>
         <p:spPr>
-          <a:xfrm xmlns:a="http://schemas.openxmlformats.org/drawingml/2006/main">
+          <a:xfrm xmlns:a="http://schemas.openxmlformats.org/drawingml/2006/main" flipH="0" flipV="0">
             <a:off x="4076700" y="1714500"/>
             <a:ext cx="7505700" cy="4219575"/>
           </a:xfrm>
           <a:prstGeom xmlns:a="http://schemas.openxmlformats.org/drawingml/2006/main" prst="roundRect">
-            <a:avLst>
-              <a:gd name="adj" fmla="val 1806"/>
-            </a:avLst>
+            <a:avLst/>
           </a:prstGeom>
         </p:spPr>
       </p:pic>
@@ -7838,28 +7828,26 @@
       </p:sp>
       <p:pic>
         <p:nvPicPr>
-          <p:cNvPr id="42" name=""/>
+          <p:cNvPr id="43" name=""/>
           <p:cNvPicPr>
             <a:picLocks xmlns:a="http://schemas.openxmlformats.org/drawingml/2006/main" noChangeAspect="1"/>
           </p:cNvPicPr>
           <p:nvPr/>
         </p:nvPicPr>
         <p:blipFill>
-          <a:blip xmlns:r="http://schemas.openxmlformats.org/officeDocument/2006/relationships" xmlns:a="http://schemas.openxmlformats.org/drawingml/2006/main" r:embed="Rabacc7b50d78440a"/>
+          <a:blip xmlns:r="http://schemas.openxmlformats.org/officeDocument/2006/relationships" xmlns:a="http://schemas.openxmlformats.org/drawingml/2006/main" r:embed="R6512876b58cd4ebb"/>
           <a:srcRect xmlns:a="http://schemas.openxmlformats.org/drawingml/2006/main" l="44" t="0" r="44" b="0"/>
           <a:stretch xmlns:a="http://schemas.openxmlformats.org/drawingml/2006/main">
             <a:fillRect l="0" t="0" r="0" b="0"/>
           </a:stretch>
         </p:blipFill>
         <p:spPr>
-          <a:xfrm xmlns:a="http://schemas.openxmlformats.org/drawingml/2006/main">
+          <a:xfrm xmlns:a="http://schemas.openxmlformats.org/drawingml/2006/main" flipH="0" flipV="0">
             <a:off x="4324350" y="1714500"/>
             <a:ext cx="7258050" cy="4086225"/>
           </a:xfrm>
           <a:prstGeom xmlns:a="http://schemas.openxmlformats.org/drawingml/2006/main" prst="roundRect">
-            <a:avLst>
-              <a:gd name="adj" fmla="val 1865"/>
-            </a:avLst>
+            <a:avLst/>
           </a:prstGeom>
         </p:spPr>
       </p:pic>
@@ -8303,28 +8291,26 @@
       </p:sp>
       <p:pic>
         <p:nvPicPr>
-          <p:cNvPr id="26" name=""/>
+          <p:cNvPr id="27" name=""/>
           <p:cNvPicPr>
             <a:picLocks xmlns:a="http://schemas.openxmlformats.org/drawingml/2006/main" noChangeAspect="1"/>
           </p:cNvPicPr>
           <p:nvPr/>
         </p:nvPicPr>
         <p:blipFill>
-          <a:blip xmlns:r="http://schemas.openxmlformats.org/officeDocument/2006/relationships" xmlns:a="http://schemas.openxmlformats.org/drawingml/2006/main" r:embed="R092bfe489d99427b"/>
+          <a:blip xmlns:r="http://schemas.openxmlformats.org/officeDocument/2006/relationships" xmlns:a="http://schemas.openxmlformats.org/drawingml/2006/main" r:embed="Rd728c890434149e6"/>
           <a:srcRect xmlns:a="http://schemas.openxmlformats.org/drawingml/2006/main" l="0" t="23" r="0" b="23"/>
           <a:stretch xmlns:a="http://schemas.openxmlformats.org/drawingml/2006/main">
             <a:fillRect l="0" t="0" r="0" b="0"/>
           </a:stretch>
         </p:blipFill>
         <p:spPr>
-          <a:xfrm xmlns:a="http://schemas.openxmlformats.org/drawingml/2006/main">
+          <a:xfrm xmlns:a="http://schemas.openxmlformats.org/drawingml/2006/main" flipH="0" flipV="0">
             <a:off x="609600" y="1600200"/>
             <a:ext cx="9029700" cy="5076825"/>
           </a:xfrm>
           <a:prstGeom xmlns:a="http://schemas.openxmlformats.org/drawingml/2006/main" prst="roundRect">
-            <a:avLst>
-              <a:gd name="adj" fmla="val 1501"/>
-            </a:avLst>
+            <a:avLst/>
           </a:prstGeom>
         </p:spPr>
       </p:pic>
@@ -8726,7 +8712,7 @@
                 <a:ea typeface="Arial"/>
                 <a:cs typeface="Arial"/>
               </a:rPr>
-              <a:t>1.81</a:t>
+              <a:t>1.87</a:t>
             </a:r>
           </a:p>
         </p:txBody>
@@ -9181,7 +9167,7 @@
                 <a:ea typeface="Arial"/>
                 <a:cs typeface="Arial"/>
               </a:rPr>
-              <a:t>At 12% ML risk, red flags still override the model.</a:t>
+              <a:t>At 21% ML risk, red flags still override the model.</a:t>
             </a:r>
           </a:p>
         </p:txBody>
@@ -9378,28 +9364,26 @@
       </p:sp>
       <p:pic>
         <p:nvPicPr>
-          <p:cNvPr id="24" name=""/>
+          <p:cNvPr id="25" name=""/>
           <p:cNvPicPr>
             <a:picLocks xmlns:a="http://schemas.openxmlformats.org/drawingml/2006/main" noChangeAspect="1"/>
           </p:cNvPicPr>
           <p:nvPr/>
         </p:nvPicPr>
         <p:blipFill>
-          <a:blip xmlns:r="http://schemas.openxmlformats.org/officeDocument/2006/relationships" xmlns:a="http://schemas.openxmlformats.org/drawingml/2006/main" r:embed="R15d033d73cdf4cb2"/>
+          <a:blip xmlns:r="http://schemas.openxmlformats.org/officeDocument/2006/relationships" xmlns:a="http://schemas.openxmlformats.org/drawingml/2006/main" r:embed="R3122e743a77b4a1f"/>
           <a:srcRect xmlns:a="http://schemas.openxmlformats.org/drawingml/2006/main" l="0" t="23" r="0" b="23"/>
           <a:stretch xmlns:a="http://schemas.openxmlformats.org/drawingml/2006/main">
             <a:fillRect l="0" t="0" r="0" b="0"/>
           </a:stretch>
         </p:blipFill>
         <p:spPr>
-          <a:xfrm xmlns:a="http://schemas.openxmlformats.org/drawingml/2006/main">
+          <a:xfrm xmlns:a="http://schemas.openxmlformats.org/drawingml/2006/main" flipH="0" flipV="0">
             <a:off x="609600" y="1600200"/>
             <a:ext cx="9029700" cy="5076825"/>
           </a:xfrm>
           <a:prstGeom xmlns:a="http://schemas.openxmlformats.org/drawingml/2006/main" prst="roundRect">
-            <a:avLst>
-              <a:gd name="adj" fmla="val 1501"/>
-            </a:avLst>
+            <a:avLst/>
           </a:prstGeom>
         </p:spPr>
       </p:pic>
@@ -9586,7 +9570,7 @@
                 <a:ea typeface="Arial"/>
                 <a:cs typeface="Arial"/>
               </a:rPr>
-              <a:t>12%</a:t>
+              <a:t>21%</a:t>
             </a:r>
           </a:p>
         </p:txBody>
@@ -10331,28 +10315,26 @@
       </p:sp>
       <p:pic>
         <p:nvPicPr>
-          <p:cNvPr id="27" name=""/>
+          <p:cNvPr id="28" name=""/>
           <p:cNvPicPr>
             <a:picLocks xmlns:a="http://schemas.openxmlformats.org/drawingml/2006/main" noChangeAspect="1"/>
           </p:cNvPicPr>
           <p:nvPr/>
         </p:nvPicPr>
         <p:blipFill>
-          <a:blip xmlns:r="http://schemas.openxmlformats.org/officeDocument/2006/relationships" xmlns:a="http://schemas.openxmlformats.org/drawingml/2006/main" r:embed="Rafd3d2b709944092"/>
+          <a:blip xmlns:r="http://schemas.openxmlformats.org/officeDocument/2006/relationships" xmlns:a="http://schemas.openxmlformats.org/drawingml/2006/main" r:embed="R8c4d62052b9548e8"/>
           <a:srcRect xmlns:a="http://schemas.openxmlformats.org/drawingml/2006/main" l="0" t="13" r="0" b="13"/>
           <a:stretch xmlns:a="http://schemas.openxmlformats.org/drawingml/2006/main">
             <a:fillRect l="0" t="0" r="0" b="0"/>
           </a:stretch>
         </p:blipFill>
         <p:spPr>
-          <a:xfrm xmlns:a="http://schemas.openxmlformats.org/drawingml/2006/main">
+          <a:xfrm xmlns:a="http://schemas.openxmlformats.org/drawingml/2006/main" flipH="0" flipV="0">
             <a:off x="609600" y="1619250"/>
             <a:ext cx="8096250" cy="4552950"/>
           </a:xfrm>
           <a:prstGeom xmlns:a="http://schemas.openxmlformats.org/drawingml/2006/main" prst="roundRect">
-            <a:avLst>
-              <a:gd name="adj" fmla="val 1674"/>
-            </a:avLst>
+            <a:avLst/>
           </a:prstGeom>
         </p:spPr>
       </p:pic>
@@ -11414,28 +11396,26 @@
       </p:sp>
       <p:pic>
         <p:nvPicPr>
-          <p:cNvPr id="29" name=""/>
+          <p:cNvPr id="30" name=""/>
           <p:cNvPicPr>
             <a:picLocks xmlns:a="http://schemas.openxmlformats.org/drawingml/2006/main" noChangeAspect="1"/>
           </p:cNvPicPr>
           <p:nvPr/>
         </p:nvPicPr>
         <p:blipFill>
-          <a:blip xmlns:r="http://schemas.openxmlformats.org/officeDocument/2006/relationships" xmlns:a="http://schemas.openxmlformats.org/drawingml/2006/main" r:embed="R722b5cd013504067"/>
+          <a:blip xmlns:r="http://schemas.openxmlformats.org/officeDocument/2006/relationships" xmlns:a="http://schemas.openxmlformats.org/drawingml/2006/main" r:embed="R3475a159953b414a"/>
           <a:srcRect xmlns:a="http://schemas.openxmlformats.org/drawingml/2006/main" l="0" t="0" r="0" b="0"/>
           <a:stretch xmlns:a="http://schemas.openxmlformats.org/drawingml/2006/main">
             <a:fillRect l="0" t="0" r="0" b="0"/>
           </a:stretch>
         </p:blipFill>
         <p:spPr>
-          <a:xfrm xmlns:a="http://schemas.openxmlformats.org/drawingml/2006/main">
+          <a:xfrm xmlns:a="http://schemas.openxmlformats.org/drawingml/2006/main" flipH="0" flipV="0">
             <a:off x="609600" y="1619250"/>
             <a:ext cx="6858000" cy="3857625"/>
           </a:xfrm>
           <a:prstGeom xmlns:a="http://schemas.openxmlformats.org/drawingml/2006/main" prst="roundRect">
-            <a:avLst>
-              <a:gd name="adj" fmla="val 1975"/>
-            </a:avLst>
+            <a:avLst/>
           </a:prstGeom>
         </p:spPr>
       </p:pic>
@@ -12565,28 +12545,26 @@
       </p:sp>
       <p:pic>
         <p:nvPicPr>
-          <p:cNvPr id="29" name=""/>
+          <p:cNvPr id="30" name=""/>
           <p:cNvPicPr>
             <a:picLocks xmlns:a="http://schemas.openxmlformats.org/drawingml/2006/main" noChangeAspect="1"/>
           </p:cNvPicPr>
           <p:nvPr/>
         </p:nvPicPr>
         <p:blipFill>
-          <a:blip xmlns:r="http://schemas.openxmlformats.org/officeDocument/2006/relationships" xmlns:a="http://schemas.openxmlformats.org/drawingml/2006/main" r:embed="R7e43c11a80ba4fd2"/>
+          <a:blip xmlns:r="http://schemas.openxmlformats.org/officeDocument/2006/relationships" xmlns:a="http://schemas.openxmlformats.org/drawingml/2006/main" r:embed="Rccbe6dfc899b4f7d"/>
           <a:srcRect xmlns:a="http://schemas.openxmlformats.org/drawingml/2006/main" l="0" t="0" r="0" b="0"/>
           <a:stretch xmlns:a="http://schemas.openxmlformats.org/drawingml/2006/main">
             <a:fillRect l="0" t="0" r="0" b="0"/>
           </a:stretch>
         </p:blipFill>
         <p:spPr>
-          <a:xfrm xmlns:a="http://schemas.openxmlformats.org/drawingml/2006/main">
+          <a:xfrm xmlns:a="http://schemas.openxmlformats.org/drawingml/2006/main" flipH="0" flipV="0">
             <a:off x="609600" y="1619250"/>
             <a:ext cx="6858000" cy="3857625"/>
           </a:xfrm>
           <a:prstGeom xmlns:a="http://schemas.openxmlformats.org/drawingml/2006/main" prst="roundRect">
-            <a:avLst>
-              <a:gd name="adj" fmla="val 1975"/>
-            </a:avLst>
+            <a:avLst/>
           </a:prstGeom>
         </p:spPr>
       </p:pic>

</xml_diff>

<commit_message>
Ship commercial decision flow and release assets
</commit_message>
<xml_diff>
--- a/outputs/adherence-os-demo.pptx
+++ b/outputs/adherence-os-demo.pptx
@@ -2,22 +2,22 @@
 <file path=ppt/presentation.xml><?xml version="1.0" encoding="utf-8"?>
 <p:presentation xmlns:p="http://schemas.openxmlformats.org/presentationml/2006/main">
   <p:sldMasterIdLst>
-    <p:sldMasterId xmlns:r="http://schemas.openxmlformats.org/officeDocument/2006/relationships" id="2147483648" r:id="R3eb04cb578e14e25"/>
+    <p:sldMasterId xmlns:r="http://schemas.openxmlformats.org/officeDocument/2006/relationships" id="2147483648" r:id="Rc8be972abf3e4890"/>
   </p:sldMasterIdLst>
   <p:notesMasterIdLst>
-    <p:notesMasterId xmlns:r="http://schemas.openxmlformats.org/officeDocument/2006/relationships" r:id="Rb1e4892aa7c04f15"/>
+    <p:notesMasterId xmlns:r="http://schemas.openxmlformats.org/officeDocument/2006/relationships" r:id="R1a9b123028484c3e"/>
   </p:notesMasterIdLst>
   <p:sldIdLst>
-    <p:sldId xmlns:r="http://schemas.openxmlformats.org/officeDocument/2006/relationships" id="256" r:id="Rfdb54c6ef4ce4263"/>
-    <p:sldId xmlns:r="http://schemas.openxmlformats.org/officeDocument/2006/relationships" id="257" r:id="R837daf82b00c4ebe"/>
-    <p:sldId xmlns:r="http://schemas.openxmlformats.org/officeDocument/2006/relationships" id="258" r:id="R5b8b0a3bc8214991"/>
-    <p:sldId xmlns:r="http://schemas.openxmlformats.org/officeDocument/2006/relationships" id="259" r:id="R03d96176f40b414f"/>
-    <p:sldId xmlns:r="http://schemas.openxmlformats.org/officeDocument/2006/relationships" id="260" r:id="Re3628317d4cb4f80"/>
-    <p:sldId xmlns:r="http://schemas.openxmlformats.org/officeDocument/2006/relationships" id="261" r:id="R5e42501e85b3480f"/>
-    <p:sldId xmlns:r="http://schemas.openxmlformats.org/officeDocument/2006/relationships" id="262" r:id="Rccb5d6cf4da94e1e"/>
-    <p:sldId xmlns:r="http://schemas.openxmlformats.org/officeDocument/2006/relationships" id="263" r:id="R5aa9bf3bf9bf4bf0"/>
-    <p:sldId xmlns:r="http://schemas.openxmlformats.org/officeDocument/2006/relationships" id="264" r:id="Ra039680760844e77"/>
-    <p:sldId xmlns:r="http://schemas.openxmlformats.org/officeDocument/2006/relationships" id="265" r:id="R3e5002c1e500442f"/>
+    <p:sldId xmlns:r="http://schemas.openxmlformats.org/officeDocument/2006/relationships" id="256" r:id="Ra4c0bf74ff5e4692"/>
+    <p:sldId xmlns:r="http://schemas.openxmlformats.org/officeDocument/2006/relationships" id="257" r:id="R837bb29e8e684638"/>
+    <p:sldId xmlns:r="http://schemas.openxmlformats.org/officeDocument/2006/relationships" id="258" r:id="R6918979b1cd34c38"/>
+    <p:sldId xmlns:r="http://schemas.openxmlformats.org/officeDocument/2006/relationships" id="259" r:id="R26a265b0de9a49a9"/>
+    <p:sldId xmlns:r="http://schemas.openxmlformats.org/officeDocument/2006/relationships" id="260" r:id="R4606d1805909401f"/>
+    <p:sldId xmlns:r="http://schemas.openxmlformats.org/officeDocument/2006/relationships" id="261" r:id="R5b3c61b9584f4dff"/>
+    <p:sldId xmlns:r="http://schemas.openxmlformats.org/officeDocument/2006/relationships" id="262" r:id="Ra853cc12d8b94f78"/>
+    <p:sldId xmlns:r="http://schemas.openxmlformats.org/officeDocument/2006/relationships" id="263" r:id="R0f5cc6c5c6654010"/>
+    <p:sldId xmlns:r="http://schemas.openxmlformats.org/officeDocument/2006/relationships" id="264" r:id="Rb5355f949ff140c9"/>
+    <p:sldId xmlns:r="http://schemas.openxmlformats.org/officeDocument/2006/relationships" id="265" r:id="R0d34de05df61461b"/>
   </p:sldIdLst>
   <p:sldSz cx="12192000" cy="6858000"/>
   <p:notesSz cx="6858000" cy="9144000"/>
@@ -1204,7 +1204,7 @@
   </p:cSld>
   <p:clrMap bg1="lt1" tx1="dk1" bg2="lt2" tx2="dk2" accent1="accent1" accent2="accent2" accent3="accent3" accent4="accent4" accent5="accent5" accent6="accent6" hlink="hlink" folHlink="folHlink"/>
   <p:sldLayoutIdLst>
-    <p:sldLayoutId xmlns:r="http://schemas.openxmlformats.org/officeDocument/2006/relationships" id="2147483649" r:id="R4a9e621ded2c4c81"/>
+    <p:sldLayoutId xmlns:r="http://schemas.openxmlformats.org/officeDocument/2006/relationships" id="2147483649" r:id="Rb531be1d2548441a"/>
   </p:sldLayoutIdLst>
   <p:txStyles>
     <p:titleStyle>
@@ -2199,7 +2199,7 @@
           <p:nvPr/>
         </p:nvPicPr>
         <p:blipFill>
-          <a:blip xmlns:r="http://schemas.openxmlformats.org/officeDocument/2006/relationships" xmlns:a="http://schemas.openxmlformats.org/drawingml/2006/main" r:embed="R7a21296205934954"/>
+          <a:blip xmlns:r="http://schemas.openxmlformats.org/officeDocument/2006/relationships" xmlns:a="http://schemas.openxmlformats.org/drawingml/2006/main" r:embed="R2dc97ba25480409a"/>
           <a:srcRect xmlns:a="http://schemas.openxmlformats.org/drawingml/2006/main" l="33" t="0" r="33" b="0"/>
           <a:stretch xmlns:a="http://schemas.openxmlformats.org/drawingml/2006/main">
             <a:fillRect l="0" t="0" r="0" b="0"/>
@@ -2613,7 +2613,7 @@
         </p:spPr>
         <p:txBody>
           <a:bodyPr xmlns:a="http://schemas.openxmlformats.org/drawingml/2006/main" lIns="0" tIns="0" rIns="0" bIns="0" anchor="t">
-            <a:normAutofit fontScale="88664"/>
+            <a:normAutofit fontScale="83557"/>
           </a:bodyPr>
           <a:lstStyle xmlns:a="http://schemas.openxmlformats.org/drawingml/2006/main"/>
           <a:p xmlns:a="http://schemas.openxmlformats.org/drawingml/2006/main">
@@ -2640,7 +2640,7 @@
                 <a:ea typeface="Arial"/>
                 <a:cs typeface="Arial"/>
               </a:rPr>
-              <a:t>Predict the drop-off. Explain the driver. Hand off before harm.</a:t>
+              <a:t>Predict the interruption. Explain the driver. Hand off before harm.</a:t>
             </a:r>
           </a:p>
         </p:txBody>
@@ -2844,7 +2844,7 @@
           <p:nvPr/>
         </p:nvPicPr>
         <p:blipFill>
-          <a:blip xmlns:r="http://schemas.openxmlformats.org/officeDocument/2006/relationships" xmlns:a="http://schemas.openxmlformats.org/drawingml/2006/main" r:embed="Rab5d4f89cc924172"/>
+          <a:blip xmlns:r="http://schemas.openxmlformats.org/officeDocument/2006/relationships" xmlns:a="http://schemas.openxmlformats.org/drawingml/2006/main" r:embed="R7f55c8c70e1c4c30"/>
           <a:srcRect xmlns:a="http://schemas.openxmlformats.org/drawingml/2006/main" l="0" t="41" r="0" b="41"/>
           <a:stretch xmlns:a="http://schemas.openxmlformats.org/drawingml/2006/main">
             <a:fillRect l="0" t="0" r="0" b="0"/>
@@ -2904,7 +2904,7 @@
           <p:nvPr/>
         </p:nvPicPr>
         <p:blipFill>
-          <a:blip xmlns:r="http://schemas.openxmlformats.org/officeDocument/2006/relationships" xmlns:a="http://schemas.openxmlformats.org/drawingml/2006/main" r:embed="R28a14753e99b4954"/>
+          <a:blip xmlns:r="http://schemas.openxmlformats.org/officeDocument/2006/relationships" xmlns:a="http://schemas.openxmlformats.org/drawingml/2006/main" r:embed="R098919e8cf854bf1"/>
           <a:srcRect xmlns:a="http://schemas.openxmlformats.org/drawingml/2006/main" l="0" t="41" r="0" b="41"/>
           <a:stretch xmlns:a="http://schemas.openxmlformats.org/drawingml/2006/main">
             <a:fillRect l="0" t="0" r="0" b="0"/>
@@ -3384,7 +3384,7 @@
                 <a:ea typeface="Arial"/>
                 <a:cs typeface="Arial"/>
               </a:rPr>
-              <a:t>Agentic dual-track intelligence</a:t>
+              <a:t>Dual-track ML + safety</a:t>
             </a:r>
           </a:p>
         </p:txBody>
@@ -5322,7 +5322,7 @@
           <p:nvPr/>
         </p:nvPicPr>
         <p:blipFill>
-          <a:blip xmlns:r="http://schemas.openxmlformats.org/officeDocument/2006/relationships" xmlns:a="http://schemas.openxmlformats.org/drawingml/2006/main" r:embed="R3a38a500479c41b5"/>
+          <a:blip xmlns:r="http://schemas.openxmlformats.org/officeDocument/2006/relationships" xmlns:a="http://schemas.openxmlformats.org/drawingml/2006/main" r:embed="R5682860a215a45bd"/>
           <a:srcRect xmlns:a="http://schemas.openxmlformats.org/drawingml/2006/main" l="0" t="0" r="0" b="0"/>
           <a:stretch xmlns:a="http://schemas.openxmlformats.org/drawingml/2006/main">
             <a:fillRect l="0" t="0" r="0" b="0"/>
@@ -6170,7 +6170,7 @@
                 <a:ea typeface="Arial"/>
                 <a:cs typeface="Arial"/>
               </a:rPr>
-              <a:t>Local ML ranks 7-day adherence risk; graph analytics exposes the active rescue route.</a:t>
+              <a:t>Local ML ranks next-week interruption risk; the evidence map exposes the active support route.</a:t>
             </a:r>
           </a:p>
         </p:txBody>
@@ -6387,7 +6387,7 @@
                 <a:ea typeface="Arial"/>
                 <a:cs typeface="Arial"/>
               </a:rPr>
-              <a:t>A bounded care moment is allowed only while deterministic rules keep the patient inside coaching space.</a:t>
+              <a:t>A bounded support route is shown only while deterministic rules keep the patient inside coaching space.</a:t>
             </a:r>
           </a:p>
         </p:txBody>
@@ -6436,7 +6436,7 @@
           <p:nvPr/>
         </p:nvPicPr>
         <p:blipFill>
-          <a:blip xmlns:r="http://schemas.openxmlformats.org/officeDocument/2006/relationships" xmlns:a="http://schemas.openxmlformats.org/drawingml/2006/main" r:embed="R727b0827ca4c4c07"/>
+          <a:blip xmlns:r="http://schemas.openxmlformats.org/officeDocument/2006/relationships" xmlns:a="http://schemas.openxmlformats.org/drawingml/2006/main" r:embed="R8d0f374b2f6846c8"/>
           <a:srcRect xmlns:a="http://schemas.openxmlformats.org/drawingml/2006/main" l="0" t="28" r="0" b="28"/>
           <a:stretch xmlns:a="http://schemas.openxmlformats.org/drawingml/2006/main">
             <a:fillRect l="0" t="0" r="0" b="0"/>
@@ -6794,7 +6794,7 @@
                 <a:ea typeface="Arial"/>
                 <a:cs typeface="Arial"/>
               </a:rPr>
-              <a:t>Optional structured AI output / deterministic fallback</a:t>
+              <a:t>Optional provider validation / deterministic plan</a:t>
             </a:r>
           </a:p>
         </p:txBody>
@@ -7290,7 +7290,7 @@
                 <a:ea typeface="Arial"/>
                 <a:cs typeface="Arial"/>
               </a:rPr>
-              <a:t>2%</a:t>
+              <a:t>5%</a:t>
             </a:r>
           </a:p>
         </p:txBody>
@@ -7352,7 +7352,7 @@
                 <a:ea typeface="Arial"/>
                 <a:cs typeface="Arial"/>
               </a:rPr>
-              <a:t>7-day dropout risk</a:t>
+              <a:t>next-week interruption risk</a:t>
             </a:r>
           </a:p>
         </p:txBody>
@@ -7445,7 +7445,7 @@
                 <a:ea typeface="Arial"/>
                 <a:cs typeface="Arial"/>
               </a:rPr>
-              <a:t>93%</a:t>
+              <a:t>100%</a:t>
             </a:r>
           </a:p>
         </p:txBody>
@@ -7600,7 +7600,7 @@
                 <a:ea typeface="Arial"/>
                 <a:cs typeface="Arial"/>
               </a:rPr>
-              <a:t>-2%</a:t>
+              <a:t>-2 pp</a:t>
             </a:r>
           </a:p>
         </p:txBody>
@@ -7662,7 +7662,7 @@
                 <a:ea typeface="Arial"/>
                 <a:cs typeface="Arial"/>
               </a:rPr>
-              <a:t>modelled reminder effect</a:t>
+              <a:t>bounded scenario change</a:t>
             </a:r>
           </a:p>
         </p:txBody>
@@ -7786,7 +7786,7 @@
                 <a:ea typeface="Arial"/>
                 <a:cs typeface="Arial"/>
               </a:rPr>
-              <a:t>Keep today's routine. Repeat the same reminder tomorrow and log side effects.</a:t>
+              <a:t>Keep today's routine. Add one fluid cue before midday and log side effects.</a:t>
             </a:r>
           </a:p>
         </p:txBody>
@@ -7835,7 +7835,7 @@
           <p:nvPr/>
         </p:nvPicPr>
         <p:blipFill>
-          <a:blip xmlns:r="http://schemas.openxmlformats.org/officeDocument/2006/relationships" xmlns:a="http://schemas.openxmlformats.org/drawingml/2006/main" r:embed="R6512876b58cd4ebb"/>
+          <a:blip xmlns:r="http://schemas.openxmlformats.org/officeDocument/2006/relationships" xmlns:a="http://schemas.openxmlformats.org/drawingml/2006/main" r:embed="R4c237ce792c3492e"/>
           <a:srcRect xmlns:a="http://schemas.openxmlformats.org/drawingml/2006/main" l="44" t="0" r="44" b="0"/>
           <a:stretch xmlns:a="http://schemas.openxmlformats.org/drawingml/2006/main">
             <a:fillRect l="0" t="0" r="0" b="0"/>
@@ -7941,7 +7941,7 @@
                 <a:ea typeface="Arial"/>
                 <a:cs typeface="Arial"/>
               </a:rPr>
-              <a:t>Check-in  &gt;  local inference  &gt;  behavioural care moment  &gt;  tomorrow's check-in</a:t>
+              <a:t>Check-in  &gt;  local inference  &gt;  bounded support route  &gt;  next check-in</a:t>
             </a:r>
           </a:p>
         </p:txBody>
@@ -8298,7 +8298,7 @@
           <p:nvPr/>
         </p:nvPicPr>
         <p:blipFill>
-          <a:blip xmlns:r="http://schemas.openxmlformats.org/officeDocument/2006/relationships" xmlns:a="http://schemas.openxmlformats.org/drawingml/2006/main" r:embed="Rd728c890434149e6"/>
+          <a:blip xmlns:r="http://schemas.openxmlformats.org/officeDocument/2006/relationships" xmlns:a="http://schemas.openxmlformats.org/drawingml/2006/main" r:embed="R27ad7f63095c4c74"/>
           <a:srcRect xmlns:a="http://schemas.openxmlformats.org/drawingml/2006/main" l="0" t="23" r="0" b="23"/>
           <a:stretch xmlns:a="http://schemas.openxmlformats.org/drawingml/2006/main">
             <a:fillRect l="0" t="0" r="0" b="0"/>
@@ -8712,7 +8712,7 @@
                 <a:ea typeface="Arial"/>
                 <a:cs typeface="Arial"/>
               </a:rPr>
-              <a:t>1.87</a:t>
+              <a:t>32%</a:t>
             </a:r>
           </a:p>
         </p:txBody>
@@ -8774,7 +8774,7 @@
                 <a:ea typeface="Arial"/>
                 <a:cs typeface="Arial"/>
               </a:rPr>
-              <a:t>driver centrality</a:t>
+              <a:t>attribution share</a:t>
             </a:r>
           </a:p>
         </p:txBody>
@@ -8871,7 +8871,7 @@
         </p:spPr>
         <p:txBody>
           <a:bodyPr xmlns:a="http://schemas.openxmlformats.org/drawingml/2006/main" lIns="0" tIns="0" rIns="0" bIns="0" anchor="t">
-            <a:normAutofit fontScale="98056"/>
+            <a:normAutofit fontScale="100000"/>
           </a:bodyPr>
           <a:lstStyle xmlns:a="http://schemas.openxmlformats.org/drawingml/2006/main"/>
           <a:p xmlns:a="http://schemas.openxmlformats.org/drawingml/2006/main">
@@ -8898,7 +8898,7 @@
                 <a:ea typeface="Arial"/>
                 <a:cs typeface="Arial"/>
               </a:rPr>
-              <a:t>Centrality</a:t>
+              <a:t>Model attribution</a:t>
             </a:r>
           </a:p>
           <a:p xmlns:a="http://schemas.openxmlformats.org/drawingml/2006/main">
@@ -8925,7 +8925,7 @@
                 <a:ea typeface="Arial"/>
                 <a:cs typeface="Arial"/>
               </a:rPr>
-              <a:t>Distance to escalation</a:t>
+              <a:t>Scenario delta</a:t>
             </a:r>
           </a:p>
           <a:p xmlns:a="http://schemas.openxmlformats.org/drawingml/2006/main">
@@ -8952,7 +8952,7 @@
                 <a:ea typeface="Arial"/>
                 <a:cs typeface="Arial"/>
               </a:rPr>
-              <a:t>Rescue path strength</a:t>
+              <a:t>Safety route state</a:t>
             </a:r>
           </a:p>
         </p:txBody>
@@ -9014,7 +9014,7 @@
                 <a:ea typeface="Arial"/>
                 <a:cs typeface="Arial"/>
               </a:rPr>
-              <a:t>Graph links are explanatory associations, not causal evidence.</a:t>
+              <a:t>Graph routes are authored associations, not causal evidence.</a:t>
             </a:r>
           </a:p>
         </p:txBody>
@@ -9167,7 +9167,7 @@
                 <a:ea typeface="Arial"/>
                 <a:cs typeface="Arial"/>
               </a:rPr>
-              <a:t>At 21% ML risk, red flags still override the model.</a:t>
+              <a:t>When ML abstains, red flags still override the model.</a:t>
             </a:r>
           </a:p>
         </p:txBody>
@@ -9371,7 +9371,7 @@
           <p:nvPr/>
         </p:nvPicPr>
         <p:blipFill>
-          <a:blip xmlns:r="http://schemas.openxmlformats.org/officeDocument/2006/relationships" xmlns:a="http://schemas.openxmlformats.org/drawingml/2006/main" r:embed="R3122e743a77b4a1f"/>
+          <a:blip xmlns:r="http://schemas.openxmlformats.org/officeDocument/2006/relationships" xmlns:a="http://schemas.openxmlformats.org/drawingml/2006/main" r:embed="R1ae44c814401440d"/>
           <a:srcRect xmlns:a="http://schemas.openxmlformats.org/drawingml/2006/main" l="0" t="23" r="0" b="23"/>
           <a:stretch xmlns:a="http://schemas.openxmlformats.org/drawingml/2006/main">
             <a:fillRect l="0" t="0" r="0" b="0"/>
@@ -9570,7 +9570,7 @@
                 <a:ea typeface="Arial"/>
                 <a:cs typeface="Arial"/>
               </a:rPr>
-              <a:t>21%</a:t>
+              <a:t>N/A</a:t>
             </a:r>
           </a:p>
         </p:txBody>
@@ -9632,7 +9632,7 @@
                 <a:ea typeface="Arial"/>
                 <a:cs typeface="Arial"/>
               </a:rPr>
-              <a:t>ML adherence risk</a:t>
+              <a:t>ML route ranking</a:t>
             </a:r>
           </a:p>
         </p:txBody>
@@ -9667,7 +9667,7 @@
         </p:spPr>
         <p:txBody>
           <a:bodyPr xmlns:a="http://schemas.openxmlformats.org/drawingml/2006/main" lIns="0" tIns="0" rIns="0" bIns="0" anchor="t">
-            <a:normAutofit fontScale="95165"/>
+            <a:normAutofit fontScale="91692"/>
           </a:bodyPr>
           <a:lstStyle xmlns:a="http://schemas.openxmlformats.org/drawingml/2006/main"/>
           <a:p xmlns:a="http://schemas.openxmlformats.org/drawingml/2006/main">
@@ -9694,7 +9694,7 @@
                 <a:ea typeface="Arial"/>
                 <a:cs typeface="Arial"/>
               </a:rPr>
-              <a:t>Low model risk does not mean low medical risk.</a:t>
+              <a:t>Outside support does not disable deterministic safety.</a:t>
             </a:r>
           </a:p>
         </p:txBody>
@@ -9965,7 +9965,7 @@
                 <a:ea typeface="Arial"/>
                 <a:cs typeface="Arial"/>
               </a:rPr>
-              <a:t>Result: clinical handoff, not another nudge.</a:t>
+              <a:t>Result: urgent draft, not another nudge.</a:t>
             </a:r>
           </a:p>
         </p:txBody>
@@ -10091,7 +10091,7 @@
         </p:spPr>
         <p:txBody>
           <a:bodyPr xmlns:a="http://schemas.openxmlformats.org/drawingml/2006/main" lIns="0" tIns="0" rIns="0" bIns="0" anchor="t">
-            <a:normAutofit fontScale="85680"/>
+            <a:normAutofit fontScale="86150"/>
           </a:bodyPr>
           <a:lstStyle xmlns:a="http://schemas.openxmlformats.org/drawingml/2006/main"/>
           <a:p xmlns:a="http://schemas.openxmlformats.org/drawingml/2006/main">
@@ -10118,7 +10118,7 @@
                 <a:ea typeface="Arial"/>
                 <a:cs typeface="Arial"/>
               </a:rPr>
-              <a:t>One queue item arrives with the reasoning already compressed.</a:t>
+              <a:t>One review draft arrives with the evidence already compressed.</a:t>
             </a:r>
           </a:p>
         </p:txBody>
@@ -10322,7 +10322,7 @@
           <p:nvPr/>
         </p:nvPicPr>
         <p:blipFill>
-          <a:blip xmlns:r="http://schemas.openxmlformats.org/officeDocument/2006/relationships" xmlns:a="http://schemas.openxmlformats.org/drawingml/2006/main" r:embed="R8c4d62052b9548e8"/>
+          <a:blip xmlns:r="http://schemas.openxmlformats.org/officeDocument/2006/relationships" xmlns:a="http://schemas.openxmlformats.org/drawingml/2006/main" r:embed="R2a7e83377baa4e48"/>
           <a:srcRect xmlns:a="http://schemas.openxmlformats.org/drawingml/2006/main" l="0" t="13" r="0" b="13"/>
           <a:stretch xmlns:a="http://schemas.openxmlformats.org/drawingml/2006/main">
             <a:fillRect l="0" t="0" r="0" b="0"/>
@@ -11046,7 +11046,7 @@
                 <a:ea typeface="Arial"/>
                 <a:cs typeface="Arial"/>
               </a:rPr>
-              <a:t>The care team receives a summary, never an automated clinical decision.</a:t>
+              <a:t>The care team receives a draft; nothing is assigned or sent automatically.</a:t>
             </a:r>
           </a:p>
         </p:txBody>
@@ -11199,7 +11199,7 @@
                 <a:ea typeface="Arial"/>
                 <a:cs typeface="Arial"/>
               </a:rPr>
-              <a:t>Real ML runs locally; its limits are explicit.</a:t>
+              <a:t>Prospective ML runs locally; its limits are explicit.</a:t>
             </a:r>
           </a:p>
         </p:txBody>
@@ -11403,7 +11403,7 @@
           <p:nvPr/>
         </p:nvPicPr>
         <p:blipFill>
-          <a:blip xmlns:r="http://schemas.openxmlformats.org/officeDocument/2006/relationships" xmlns:a="http://schemas.openxmlformats.org/drawingml/2006/main" r:embed="R3475a159953b414a"/>
+          <a:blip xmlns:r="http://schemas.openxmlformats.org/officeDocument/2006/relationships" xmlns:a="http://schemas.openxmlformats.org/drawingml/2006/main" r:embed="Reed662c8974c4647"/>
           <a:srcRect xmlns:a="http://schemas.openxmlformats.org/drawingml/2006/main" l="0" t="0" r="0" b="0"/>
           <a:stretch xmlns:a="http://schemas.openxmlformats.org/drawingml/2006/main">
             <a:fillRect l="0" t="0" r="0" b="0"/>
@@ -11633,7 +11633,7 @@
                 <a:ea typeface="Arial"/>
                 <a:cs typeface="Arial"/>
               </a:rPr>
-              <a:t>14 local features</a:t>
+              <a:t>14 prospective features</a:t>
             </a:r>
           </a:p>
         </p:txBody>
@@ -11788,7 +11788,7 @@
                 <a:ea typeface="Arial"/>
                 <a:cs typeface="Arial"/>
               </a:rPr>
-              <a:t>Exported JSON logistic model</a:t>
+              <a:t>16-bootstrap JSON model</a:t>
             </a:r>
           </a:p>
         </p:txBody>
@@ -11850,7 +11850,7 @@
                 <a:ea typeface="Arial"/>
                 <a:cs typeface="Arial"/>
               </a:rPr>
-              <a:t>Browser-side inference works without an external model service.</a:t>
+              <a:t>Held-out AUPRC .501 / recall 80% / Brier skill 21%.</a:t>
             </a:r>
           </a:p>
         </p:txBody>
@@ -12552,7 +12552,7 @@
           <p:nvPr/>
         </p:nvPicPr>
         <p:blipFill>
-          <a:blip xmlns:r="http://schemas.openxmlformats.org/officeDocument/2006/relationships" xmlns:a="http://schemas.openxmlformats.org/drawingml/2006/main" r:embed="Rccbe6dfc899b4f7d"/>
+          <a:blip xmlns:r="http://schemas.openxmlformats.org/officeDocument/2006/relationships" xmlns:a="http://schemas.openxmlformats.org/drawingml/2006/main" r:embed="R5bd34fb2d4764010"/>
           <a:srcRect xmlns:a="http://schemas.openxmlformats.org/drawingml/2006/main" l="0" t="0" r="0" b="0"/>
           <a:stretch xmlns:a="http://schemas.openxmlformats.org/drawingml/2006/main">
             <a:fillRect l="0" t="0" r="0" b="0"/>
@@ -12997,7 +12997,7 @@
                 <a:ea typeface="Arial"/>
                 <a:cs typeface="Arial"/>
               </a:rPr>
-              <a:t>Optional OpenAI reasoning</a:t>
+              <a:t>Optional provider validation</a:t>
             </a:r>
           </a:p>
         </p:txBody>
@@ -13059,7 +13059,7 @@
                 <a:ea typeface="Arial"/>
                 <a:cs typeface="Arial"/>
               </a:rPr>
-              <a:t>The route can generate a bounded care moment; local fallback stays visible.</a:t>
+              <a:t>Structured output is validated; the deterministic plan is recomputed.</a:t>
             </a:r>
           </a:p>
         </p:txBody>
@@ -13276,7 +13276,7 @@
                 <a:ea typeface="Arial"/>
                 <a:cs typeface="Arial"/>
               </a:rPr>
-              <a:t>Unsafe medication language and urgent symptoms are blocked before the UI.</a:t>
+              <a:t>Medication boundaries and urgent symptoms govern every returned field.</a:t>
             </a:r>
           </a:p>
         </p:txBody>

</xml_diff>

<commit_message>
Refresh final demo assets
</commit_message>
<xml_diff>
--- a/outputs/adherence-os-demo.pptx
+++ b/outputs/adherence-os-demo.pptx
@@ -2,22 +2,22 @@
 <file path=ppt/presentation.xml><?xml version="1.0" encoding="utf-8"?>
 <p:presentation xmlns:p="http://schemas.openxmlformats.org/presentationml/2006/main">
   <p:sldMasterIdLst>
-    <p:sldMasterId xmlns:r="http://schemas.openxmlformats.org/officeDocument/2006/relationships" id="2147483648" r:id="R870de1b0a1a54ce6"/>
+    <p:sldMasterId xmlns:r="http://schemas.openxmlformats.org/officeDocument/2006/relationships" id="2147483648" r:id="Rca191bade1694248"/>
   </p:sldMasterIdLst>
   <p:notesMasterIdLst>
-    <p:notesMasterId xmlns:r="http://schemas.openxmlformats.org/officeDocument/2006/relationships" r:id="Rabd8632b0a5d4709"/>
+    <p:notesMasterId xmlns:r="http://schemas.openxmlformats.org/officeDocument/2006/relationships" r:id="Rdc6cdbc9dfd047ad"/>
   </p:notesMasterIdLst>
   <p:sldIdLst>
-    <p:sldId xmlns:r="http://schemas.openxmlformats.org/officeDocument/2006/relationships" id="256" r:id="R8cf9d9beb0434c34"/>
-    <p:sldId xmlns:r="http://schemas.openxmlformats.org/officeDocument/2006/relationships" id="257" r:id="R30a211986dfa41ea"/>
-    <p:sldId xmlns:r="http://schemas.openxmlformats.org/officeDocument/2006/relationships" id="258" r:id="R4ad4ba118604405e"/>
-    <p:sldId xmlns:r="http://schemas.openxmlformats.org/officeDocument/2006/relationships" id="259" r:id="R34aa3fff5389402b"/>
-    <p:sldId xmlns:r="http://schemas.openxmlformats.org/officeDocument/2006/relationships" id="260" r:id="Rc9cac23ceed44806"/>
-    <p:sldId xmlns:r="http://schemas.openxmlformats.org/officeDocument/2006/relationships" id="261" r:id="R10a043ad35764b2b"/>
-    <p:sldId xmlns:r="http://schemas.openxmlformats.org/officeDocument/2006/relationships" id="262" r:id="Rf593c1d2bfee4d7f"/>
-    <p:sldId xmlns:r="http://schemas.openxmlformats.org/officeDocument/2006/relationships" id="263" r:id="R110bc313970f489c"/>
-    <p:sldId xmlns:r="http://schemas.openxmlformats.org/officeDocument/2006/relationships" id="264" r:id="R47697ddc8add492d"/>
-    <p:sldId xmlns:r="http://schemas.openxmlformats.org/officeDocument/2006/relationships" id="265" r:id="R41bdc38963f44c85"/>
+    <p:sldId xmlns:r="http://schemas.openxmlformats.org/officeDocument/2006/relationships" id="256" r:id="R52840e5951e8418d"/>
+    <p:sldId xmlns:r="http://schemas.openxmlformats.org/officeDocument/2006/relationships" id="257" r:id="Rab88047a1fd14cf8"/>
+    <p:sldId xmlns:r="http://schemas.openxmlformats.org/officeDocument/2006/relationships" id="258" r:id="R488781ec707c42f6"/>
+    <p:sldId xmlns:r="http://schemas.openxmlformats.org/officeDocument/2006/relationships" id="259" r:id="R321c864f0977488f"/>
+    <p:sldId xmlns:r="http://schemas.openxmlformats.org/officeDocument/2006/relationships" id="260" r:id="R400f4d56287c4a85"/>
+    <p:sldId xmlns:r="http://schemas.openxmlformats.org/officeDocument/2006/relationships" id="261" r:id="R8ceff450a6844972"/>
+    <p:sldId xmlns:r="http://schemas.openxmlformats.org/officeDocument/2006/relationships" id="262" r:id="R7f46e7b8b5e146fd"/>
+    <p:sldId xmlns:r="http://schemas.openxmlformats.org/officeDocument/2006/relationships" id="263" r:id="R093da656b1db426e"/>
+    <p:sldId xmlns:r="http://schemas.openxmlformats.org/officeDocument/2006/relationships" id="264" r:id="R4c91be24fabb4399"/>
+    <p:sldId xmlns:r="http://schemas.openxmlformats.org/officeDocument/2006/relationships" id="265" r:id="R7f044dd9f3364997"/>
   </p:sldIdLst>
   <p:sldSz cx="12192000" cy="6858000"/>
   <p:notesSz cx="6858000" cy="9144000"/>
@@ -1204,7 +1204,7 @@
   </p:cSld>
   <p:clrMap bg1="lt1" tx1="dk1" bg2="lt2" tx2="dk2" accent1="accent1" accent2="accent2" accent3="accent3" accent4="accent4" accent5="accent5" accent6="accent6" hlink="hlink" folHlink="folHlink"/>
   <p:sldLayoutIdLst>
-    <p:sldLayoutId xmlns:r="http://schemas.openxmlformats.org/officeDocument/2006/relationships" id="2147483649" r:id="R3a73254f807946c9"/>
+    <p:sldLayoutId xmlns:r="http://schemas.openxmlformats.org/officeDocument/2006/relationships" id="2147483649" r:id="R8b0bb7d274004702"/>
   </p:sldLayoutIdLst>
   <p:txStyles>
     <p:titleStyle>
@@ -1755,7 +1755,7 @@
           <p:cNvPr id="1" name="">
             <a:extLst xmlns:a="http://schemas.openxmlformats.org/drawingml/2006/main">
               <a:ext uri="{FF2B5EF4-FFF2-40B4-BE49-F238E27FC236}">
-                <a16:creationId xmlns:a16="http://schemas.microsoft.com/office/drawing/2014/main" id="{6D7F20EE-286E-4973-8F34-4912DA947E45}"/>
+                <a16:creationId xmlns:a16="http://schemas.microsoft.com/office/drawing/2014/main" id="{EBA6AE1C-0D53-4FA9-8623-386352D4EA3F}"/>
               </a:ext>
             </a:extLst>
           </p:cNvPr>
@@ -1788,7 +1788,7 @@
           <p:cNvPr id="2" name="">
             <a:extLst xmlns:a="http://schemas.openxmlformats.org/drawingml/2006/main">
               <a:ext uri="{FF2B5EF4-FFF2-40B4-BE49-F238E27FC236}">
-                <a16:creationId xmlns:a16="http://schemas.microsoft.com/office/drawing/2014/main" id="{8226220C-20CB-47D9-B9B2-1B8C75E1FCA2}"/>
+                <a16:creationId xmlns:a16="http://schemas.microsoft.com/office/drawing/2014/main" id="{42A655CC-8CCC-4175-B927-44A86F69B74B}"/>
               </a:ext>
             </a:extLst>
           </p:cNvPr>
@@ -1840,7 +1840,7 @@
           <p:cNvPr id="3" name="">
             <a:extLst xmlns:a="http://schemas.openxmlformats.org/drawingml/2006/main">
               <a:ext uri="{FF2B5EF4-FFF2-40B4-BE49-F238E27FC236}">
-                <a16:creationId xmlns:a16="http://schemas.microsoft.com/office/drawing/2014/main" id="{DAFA224A-BD50-49A1-A30B-C4E64BD9F8DA}"/>
+                <a16:creationId xmlns:a16="http://schemas.microsoft.com/office/drawing/2014/main" id="{E65ACFFE-E1DF-42FA-9370-FC3F4F38BC25}"/>
               </a:ext>
             </a:extLst>
           </p:cNvPr>
@@ -1892,7 +1892,7 @@
           <p:cNvPr id="4" name="">
             <a:extLst xmlns:a="http://schemas.openxmlformats.org/drawingml/2006/main">
               <a:ext uri="{FF2B5EF4-FFF2-40B4-BE49-F238E27FC236}">
-                <a16:creationId xmlns:a16="http://schemas.microsoft.com/office/drawing/2014/main" id="{5C45A7AC-C90B-45A1-94F7-C5A9ED0E528B}"/>
+                <a16:creationId xmlns:a16="http://schemas.microsoft.com/office/drawing/2014/main" id="{E0ADED4B-8BAF-40AF-9BD9-E481A9639AED}"/>
               </a:ext>
             </a:extLst>
           </p:cNvPr>
@@ -1944,7 +1944,7 @@
           <p:cNvPr id="5" name="">
             <a:extLst xmlns:a="http://schemas.openxmlformats.org/drawingml/2006/main">
               <a:ext uri="{FF2B5EF4-FFF2-40B4-BE49-F238E27FC236}">
-                <a16:creationId xmlns:a16="http://schemas.microsoft.com/office/drawing/2014/main" id="{4CF460A2-94FB-4ADB-A7DD-2DFBAF8B1920}"/>
+                <a16:creationId xmlns:a16="http://schemas.microsoft.com/office/drawing/2014/main" id="{5E413D4B-5143-4D6B-8A8C-73965DD79CAB}"/>
               </a:ext>
             </a:extLst>
           </p:cNvPr>
@@ -1996,7 +1996,7 @@
           <p:cNvPr id="6" name="">
             <a:extLst xmlns:a="http://schemas.openxmlformats.org/drawingml/2006/main">
               <a:ext uri="{FF2B5EF4-FFF2-40B4-BE49-F238E27FC236}">
-                <a16:creationId xmlns:a16="http://schemas.microsoft.com/office/drawing/2014/main" id="{1BCFD177-9E87-4C4B-92B6-6E788FD06B09}"/>
+                <a16:creationId xmlns:a16="http://schemas.microsoft.com/office/drawing/2014/main" id="{51B293AF-A4A6-480A-808D-FE808515B019}"/>
               </a:ext>
             </a:extLst>
           </p:cNvPr>
@@ -2029,7 +2029,7 @@
           <p:cNvPr id="7" name="">
             <a:extLst xmlns:a="http://schemas.openxmlformats.org/drawingml/2006/main">
               <a:ext uri="{FF2B5EF4-FFF2-40B4-BE49-F238E27FC236}">
-                <a16:creationId xmlns:a16="http://schemas.microsoft.com/office/drawing/2014/main" id="{E9FBB794-5121-48F3-810E-8E3C3DFB98AB}"/>
+                <a16:creationId xmlns:a16="http://schemas.microsoft.com/office/drawing/2014/main" id="{59A24EE9-9BD8-4CE3-AF5A-61C304BE9316}"/>
               </a:ext>
             </a:extLst>
           </p:cNvPr>
@@ -2081,7 +2081,7 @@
           <p:cNvPr id="8" name="">
             <a:extLst xmlns:a="http://schemas.openxmlformats.org/drawingml/2006/main">
               <a:ext uri="{FF2B5EF4-FFF2-40B4-BE49-F238E27FC236}">
-                <a16:creationId xmlns:a16="http://schemas.microsoft.com/office/drawing/2014/main" id="{9A74DAAB-5EE7-42AE-98A5-7C8028AF740D}"/>
+                <a16:creationId xmlns:a16="http://schemas.microsoft.com/office/drawing/2014/main" id="{DCB6B701-BC8A-48F3-99D7-58B70657698D}"/>
               </a:ext>
             </a:extLst>
           </p:cNvPr>
@@ -2133,7 +2133,7 @@
           <p:cNvPr id="9" name="">
             <a:extLst xmlns:a="http://schemas.openxmlformats.org/drawingml/2006/main">
               <a:ext uri="{FF2B5EF4-FFF2-40B4-BE49-F238E27FC236}">
-                <a16:creationId xmlns:a16="http://schemas.microsoft.com/office/drawing/2014/main" id="{2E6A2860-B78B-442A-AC48-7B7B47DDB464}"/>
+                <a16:creationId xmlns:a16="http://schemas.microsoft.com/office/drawing/2014/main" id="{62C1CD24-755B-48EF-BC4A-8569CA901E48}"/>
               </a:ext>
             </a:extLst>
           </p:cNvPr>
@@ -2185,7 +2185,7 @@
           <p:cNvPr id="10" name="">
             <a:extLst xmlns:a="http://schemas.openxmlformats.org/drawingml/2006/main">
               <a:ext uri="{FF2B5EF4-FFF2-40B4-BE49-F238E27FC236}">
-                <a16:creationId xmlns:a16="http://schemas.microsoft.com/office/drawing/2014/main" id="{60C67F84-E733-4F7E-8D21-0EFE4932C2DC}"/>
+                <a16:creationId xmlns:a16="http://schemas.microsoft.com/office/drawing/2014/main" id="{CBA0492E-3252-4E3C-8BF9-917C00BB95F9}"/>
               </a:ext>
             </a:extLst>
           </p:cNvPr>
@@ -2237,7 +2237,7 @@
           <p:cNvPr id="11" name="">
             <a:extLst xmlns:a="http://schemas.openxmlformats.org/drawingml/2006/main">
               <a:ext uri="{FF2B5EF4-FFF2-40B4-BE49-F238E27FC236}">
-                <a16:creationId xmlns:a16="http://schemas.microsoft.com/office/drawing/2014/main" id="{1A7F0EC2-5FF0-4790-AE4B-BF6C6504C671}"/>
+                <a16:creationId xmlns:a16="http://schemas.microsoft.com/office/drawing/2014/main" id="{2B15CF98-93E3-40A3-9348-306988D82F37}"/>
               </a:ext>
             </a:extLst>
           </p:cNvPr>
@@ -2289,7 +2289,7 @@
           <p:cNvPr id="12" name="">
             <a:extLst xmlns:a="http://schemas.openxmlformats.org/drawingml/2006/main">
               <a:ext uri="{FF2B5EF4-FFF2-40B4-BE49-F238E27FC236}">
-                <a16:creationId xmlns:a16="http://schemas.microsoft.com/office/drawing/2014/main" id="{D90960FD-A8BB-4B23-83DB-A5AF58C6AB69}"/>
+                <a16:creationId xmlns:a16="http://schemas.microsoft.com/office/drawing/2014/main" id="{AC58FBCF-F5E1-4213-87D3-91DF85464CC6}"/>
               </a:ext>
             </a:extLst>
           </p:cNvPr>
@@ -2331,7 +2331,7 @@
                   <a:srgbClr val="171918"/>
                 </a:solidFill>
               </a:rPr>
-              <a:t>SIMULATE</a:t>
+              <a:t>TEST</a:t>
             </a:r>
           </a:p>
         </p:txBody>
@@ -2341,7 +2341,7 @@
           <p:cNvPr id="13" name="">
             <a:extLst xmlns:a="http://schemas.openxmlformats.org/drawingml/2006/main">
               <a:ext uri="{FF2B5EF4-FFF2-40B4-BE49-F238E27FC236}">
-                <a16:creationId xmlns:a16="http://schemas.microsoft.com/office/drawing/2014/main" id="{7F5A158C-0C67-49D9-9B0A-FA697C64A1AB}"/>
+                <a16:creationId xmlns:a16="http://schemas.microsoft.com/office/drawing/2014/main" id="{CB54AC58-9929-449C-93F6-C67B2133F7C9}"/>
               </a:ext>
             </a:extLst>
           </p:cNvPr>
@@ -2393,7 +2393,7 @@
           <p:cNvPr id="14" name="">
             <a:extLst xmlns:a="http://schemas.openxmlformats.org/drawingml/2006/main">
               <a:ext uri="{FF2B5EF4-FFF2-40B4-BE49-F238E27FC236}">
-                <a16:creationId xmlns:a16="http://schemas.microsoft.com/office/drawing/2014/main" id="{DEE248AF-24D8-40AB-9DA3-C73148A8A101}"/>
+                <a16:creationId xmlns:a16="http://schemas.microsoft.com/office/drawing/2014/main" id="{2FAAE3EC-3782-4880-8214-FFDD8BAA8242}"/>
               </a:ext>
             </a:extLst>
           </p:cNvPr>
@@ -2445,7 +2445,7 @@
           <p:cNvPr id="15" name="">
             <a:extLst xmlns:a="http://schemas.openxmlformats.org/drawingml/2006/main">
               <a:ext uri="{FF2B5EF4-FFF2-40B4-BE49-F238E27FC236}">
-                <a16:creationId xmlns:a16="http://schemas.microsoft.com/office/drawing/2014/main" id="{128CAF59-84F9-4F3A-87A8-EAC06DB035A2}"/>
+                <a16:creationId xmlns:a16="http://schemas.microsoft.com/office/drawing/2014/main" id="{1A5744EC-A354-456B-855F-1D7B6FE9AC4A}"/>
               </a:ext>
             </a:extLst>
           </p:cNvPr>
@@ -2487,7 +2487,7 @@
                   <a:srgbClr val="606662"/>
                 </a:solidFill>
               </a:rPr>
-              <a:t>Local ML + typed evidence graph + deterministic safety</a:t>
+              <a:t>Local ML + typed evidence map + deterministic safety</a:t>
             </a:r>
           </a:p>
         </p:txBody>
@@ -2497,7 +2497,7 @@
           <p:cNvPr id="16" name="">
             <a:extLst xmlns:a="http://schemas.openxmlformats.org/drawingml/2006/main">
               <a:ext uri="{FF2B5EF4-FFF2-40B4-BE49-F238E27FC236}">
-                <a16:creationId xmlns:a16="http://schemas.microsoft.com/office/drawing/2014/main" id="{4B994686-5D64-4542-8399-9997C44A6D3C}"/>
+                <a16:creationId xmlns:a16="http://schemas.microsoft.com/office/drawing/2014/main" id="{E104932A-09CF-4283-8AD0-633C845E83CC}"/>
               </a:ext>
             </a:extLst>
           </p:cNvPr>
@@ -2530,7 +2530,7 @@
           <p:cNvPr id="17" name="">
             <a:extLst xmlns:a="http://schemas.openxmlformats.org/drawingml/2006/main">
               <a:ext uri="{FF2B5EF4-FFF2-40B4-BE49-F238E27FC236}">
-                <a16:creationId xmlns:a16="http://schemas.microsoft.com/office/drawing/2014/main" id="{CCB4DACC-7772-44D2-8FDD-DE4E3ED64707}"/>
+                <a16:creationId xmlns:a16="http://schemas.microsoft.com/office/drawing/2014/main" id="{2DC141D8-D39F-481A-91C4-4F5E2186F93B}"/>
               </a:ext>
             </a:extLst>
           </p:cNvPr>
@@ -2582,7 +2582,7 @@
           <p:cNvPr id="18" name="">
             <a:extLst xmlns:a="http://schemas.openxmlformats.org/drawingml/2006/main">
               <a:ext uri="{FF2B5EF4-FFF2-40B4-BE49-F238E27FC236}">
-                <a16:creationId xmlns:a16="http://schemas.microsoft.com/office/drawing/2014/main" id="{D7884D88-1D3B-4F38-860F-CCDF03CC6A69}"/>
+                <a16:creationId xmlns:a16="http://schemas.microsoft.com/office/drawing/2014/main" id="{900EBFA5-B485-4B5A-B4C2-F04C9F8F34B2}"/>
               </a:ext>
             </a:extLst>
           </p:cNvPr>
@@ -2632,7 +2632,7 @@
     </p:spTree>
     <p:extLst>
       <p:ext uri="{BB962C8B-B14F-4D97-AF65-F5344CB8AC3E}">
-        <p14:creationId xmlns:p14="http://schemas.microsoft.com/office/powerpoint/2010/main" val="1742089923"/>
+        <p14:creationId xmlns:p14="http://schemas.microsoft.com/office/powerpoint/2010/main" val="1173157763"/>
       </p:ext>
     </p:extLst>
   </p:cSld>
@@ -2663,7 +2663,7 @@
           <p:cNvPr id="1" name="">
             <a:extLst xmlns:a="http://schemas.openxmlformats.org/drawingml/2006/main">
               <a:ext uri="{FF2B5EF4-FFF2-40B4-BE49-F238E27FC236}">
-                <a16:creationId xmlns:a16="http://schemas.microsoft.com/office/drawing/2014/main" id="{CBEE00C9-9C91-476D-B708-8A717891A641}"/>
+                <a16:creationId xmlns:a16="http://schemas.microsoft.com/office/drawing/2014/main" id="{1D86644E-5A63-4AF4-AB3D-441716B3A5A5}"/>
               </a:ext>
             </a:extLst>
           </p:cNvPr>
@@ -2715,7 +2715,7 @@
           <p:cNvPr id="2" name="">
             <a:extLst xmlns:a="http://schemas.openxmlformats.org/drawingml/2006/main">
               <a:ext uri="{FF2B5EF4-FFF2-40B4-BE49-F238E27FC236}">
-                <a16:creationId xmlns:a16="http://schemas.microsoft.com/office/drawing/2014/main" id="{A3E7AE70-431B-4CDB-A303-A2615B4033B3}"/>
+                <a16:creationId xmlns:a16="http://schemas.microsoft.com/office/drawing/2014/main" id="{BB5E23FF-CA2E-4EED-9B78-633F63AF579A}"/>
               </a:ext>
             </a:extLst>
           </p:cNvPr>
@@ -2767,7 +2767,7 @@
           <p:cNvPr id="3" name="">
             <a:extLst xmlns:a="http://schemas.openxmlformats.org/drawingml/2006/main">
               <a:ext uri="{FF2B5EF4-FFF2-40B4-BE49-F238E27FC236}">
-                <a16:creationId xmlns:a16="http://schemas.microsoft.com/office/drawing/2014/main" id="{66AE9DC2-1791-427E-8D9B-69AA00229AB4}"/>
+                <a16:creationId xmlns:a16="http://schemas.microsoft.com/office/drawing/2014/main" id="{729976A6-A956-418C-81AE-5F3833B733E7}"/>
               </a:ext>
             </a:extLst>
           </p:cNvPr>
@@ -2800,7 +2800,7 @@
           <p:cNvPr id="4" name="">
             <a:extLst xmlns:a="http://schemas.openxmlformats.org/drawingml/2006/main">
               <a:ext uri="{FF2B5EF4-FFF2-40B4-BE49-F238E27FC236}">
-                <a16:creationId xmlns:a16="http://schemas.microsoft.com/office/drawing/2014/main" id="{C862AAD4-3BF8-4542-83E6-85B8A11C16A3}"/>
+                <a16:creationId xmlns:a16="http://schemas.microsoft.com/office/drawing/2014/main" id="{0720B1DB-DEAD-4339-A0B2-935B0EC39925}"/>
               </a:ext>
             </a:extLst>
           </p:cNvPr>
@@ -2852,7 +2852,7 @@
           <p:cNvPr id="5" name="">
             <a:extLst xmlns:a="http://schemas.openxmlformats.org/drawingml/2006/main">
               <a:ext uri="{FF2B5EF4-FFF2-40B4-BE49-F238E27FC236}">
-                <a16:creationId xmlns:a16="http://schemas.microsoft.com/office/drawing/2014/main" id="{7245D821-8D73-4E3E-AF70-F5186FD46810}"/>
+                <a16:creationId xmlns:a16="http://schemas.microsoft.com/office/drawing/2014/main" id="{E1D8CFCE-A8E2-4D5C-9D1E-42EE4341F016}"/>
               </a:ext>
             </a:extLst>
           </p:cNvPr>
@@ -2904,7 +2904,7 @@
           <p:cNvPr id="6" name="">
             <a:extLst xmlns:a="http://schemas.openxmlformats.org/drawingml/2006/main">
               <a:ext uri="{FF2B5EF4-FFF2-40B4-BE49-F238E27FC236}">
-                <a16:creationId xmlns:a16="http://schemas.microsoft.com/office/drawing/2014/main" id="{956E3F81-B39F-4E20-853A-D21325789A5E}"/>
+                <a16:creationId xmlns:a16="http://schemas.microsoft.com/office/drawing/2014/main" id="{8E1CE015-5BB6-4D6B-B78C-AD5E44BAD5A1}"/>
               </a:ext>
             </a:extLst>
           </p:cNvPr>
@@ -2937,7 +2937,7 @@
           <p:cNvPr id="7" name="">
             <a:extLst xmlns:a="http://schemas.openxmlformats.org/drawingml/2006/main">
               <a:ext uri="{FF2B5EF4-FFF2-40B4-BE49-F238E27FC236}">
-                <a16:creationId xmlns:a16="http://schemas.microsoft.com/office/drawing/2014/main" id="{8FBA89E4-3BBF-4981-A99B-ECC5299A70B1}"/>
+                <a16:creationId xmlns:a16="http://schemas.microsoft.com/office/drawing/2014/main" id="{8A7A5BD5-EF47-4151-A480-0B53F652B097}"/>
               </a:ext>
             </a:extLst>
           </p:cNvPr>
@@ -2989,7 +2989,7 @@
           <p:cNvPr id="8" name="">
             <a:extLst xmlns:a="http://schemas.openxmlformats.org/drawingml/2006/main">
               <a:ext uri="{FF2B5EF4-FFF2-40B4-BE49-F238E27FC236}">
-                <a16:creationId xmlns:a16="http://schemas.microsoft.com/office/drawing/2014/main" id="{EF1ED675-4AC3-4CFF-8E94-B221C6429476}"/>
+                <a16:creationId xmlns:a16="http://schemas.microsoft.com/office/drawing/2014/main" id="{7447C027-7F16-47F1-AD02-6A0A9978CE85}"/>
               </a:ext>
             </a:extLst>
           </p:cNvPr>
@@ -3031,7 +3031,7 @@
                   <a:srgbClr val="171918"/>
                 </a:solidFill>
               </a:rPr>
-              <a:t>Combine prospective edge ML, evidence graphs, and independent safety.</a:t>
+              <a:t>Combine prospective edge ML, an evidence map, and independent safety.</a:t>
             </a:r>
           </a:p>
         </p:txBody>
@@ -3041,7 +3041,7 @@
           <p:cNvPr id="9" name="">
             <a:extLst xmlns:a="http://schemas.openxmlformats.org/drawingml/2006/main">
               <a:ext uri="{FF2B5EF4-FFF2-40B4-BE49-F238E27FC236}">
-                <a16:creationId xmlns:a16="http://schemas.microsoft.com/office/drawing/2014/main" id="{8A4E612C-0513-4D91-AC63-AE6833434970}"/>
+                <a16:creationId xmlns:a16="http://schemas.microsoft.com/office/drawing/2014/main" id="{C69E9C2E-7C49-4A22-AEE1-9328E21C13E8}"/>
               </a:ext>
             </a:extLst>
           </p:cNvPr>
@@ -3074,7 +3074,7 @@
           <p:cNvPr id="10" name="">
             <a:extLst xmlns:a="http://schemas.openxmlformats.org/drawingml/2006/main">
               <a:ext uri="{FF2B5EF4-FFF2-40B4-BE49-F238E27FC236}">
-                <a16:creationId xmlns:a16="http://schemas.microsoft.com/office/drawing/2014/main" id="{17587133-E66D-43E5-811C-D06EE19D00F5}"/>
+                <a16:creationId xmlns:a16="http://schemas.microsoft.com/office/drawing/2014/main" id="{DA2668D2-0A93-4830-BB88-743C105FB1F1}"/>
               </a:ext>
             </a:extLst>
           </p:cNvPr>
@@ -3126,7 +3126,7 @@
           <p:cNvPr id="11" name="">
             <a:extLst xmlns:a="http://schemas.openxmlformats.org/drawingml/2006/main">
               <a:ext uri="{FF2B5EF4-FFF2-40B4-BE49-F238E27FC236}">
-                <a16:creationId xmlns:a16="http://schemas.microsoft.com/office/drawing/2014/main" id="{91514A53-955C-4FFB-8784-00472C6CFDFC}"/>
+                <a16:creationId xmlns:a16="http://schemas.microsoft.com/office/drawing/2014/main" id="{F5BB7B9A-E6F6-4B25-A102-71E61D43D5E7}"/>
               </a:ext>
             </a:extLst>
           </p:cNvPr>
@@ -3178,7 +3178,7 @@
           <p:cNvPr id="12" name="">
             <a:extLst xmlns:a="http://schemas.openxmlformats.org/drawingml/2006/main">
               <a:ext uri="{FF2B5EF4-FFF2-40B4-BE49-F238E27FC236}">
-                <a16:creationId xmlns:a16="http://schemas.microsoft.com/office/drawing/2014/main" id="{579E778F-14F1-4998-8573-A66648D6C94C}"/>
+                <a16:creationId xmlns:a16="http://schemas.microsoft.com/office/drawing/2014/main" id="{48485E79-E570-49EB-BB72-BDBF4244B975}"/>
               </a:ext>
             </a:extLst>
           </p:cNvPr>
@@ -3211,7 +3211,7 @@
           <p:cNvPr id="13" name="">
             <a:extLst xmlns:a="http://schemas.openxmlformats.org/drawingml/2006/main">
               <a:ext uri="{FF2B5EF4-FFF2-40B4-BE49-F238E27FC236}">
-                <a16:creationId xmlns:a16="http://schemas.microsoft.com/office/drawing/2014/main" id="{F4877194-DF9B-451D-B388-D47D53638FA2}"/>
+                <a16:creationId xmlns:a16="http://schemas.microsoft.com/office/drawing/2014/main" id="{53482DC9-AC28-4054-9198-9EF030CE0A1E}"/>
               </a:ext>
             </a:extLst>
           </p:cNvPr>
@@ -3263,7 +3263,7 @@
           <p:cNvPr id="14" name="">
             <a:extLst xmlns:a="http://schemas.openxmlformats.org/drawingml/2006/main">
               <a:ext uri="{FF2B5EF4-FFF2-40B4-BE49-F238E27FC236}">
-                <a16:creationId xmlns:a16="http://schemas.microsoft.com/office/drawing/2014/main" id="{13367A6F-2F25-4B85-B0F1-0426B624DC0E}"/>
+                <a16:creationId xmlns:a16="http://schemas.microsoft.com/office/drawing/2014/main" id="{05F8514E-974D-4A9D-8C3F-BA8725C0E38D}"/>
               </a:ext>
             </a:extLst>
           </p:cNvPr>
@@ -3305,7 +3305,7 @@
                   <a:srgbClr val="171918"/>
                 </a:solidFill>
               </a:rPr>
-              <a:t>Switch from reversible coaching to a human-owned handoff in one click.</a:t>
+              <a:t>Switch from a coaching path to a human-owned handoff in one click.</a:t>
             </a:r>
           </a:p>
         </p:txBody>
@@ -3315,7 +3315,7 @@
           <p:cNvPr id="15" name="">
             <a:extLst xmlns:a="http://schemas.openxmlformats.org/drawingml/2006/main">
               <a:ext uri="{FF2B5EF4-FFF2-40B4-BE49-F238E27FC236}">
-                <a16:creationId xmlns:a16="http://schemas.microsoft.com/office/drawing/2014/main" id="{772E7641-3015-49A7-96FB-0EA59C3174CF}"/>
+                <a16:creationId xmlns:a16="http://schemas.microsoft.com/office/drawing/2014/main" id="{4EC33DD4-819B-4845-B225-5902486427D0}"/>
               </a:ext>
             </a:extLst>
           </p:cNvPr>
@@ -3352,7 +3352,7 @@
           <p:nvPr/>
         </p:nvPicPr>
         <p:blipFill>
-          <a:blip xmlns:r="http://schemas.openxmlformats.org/officeDocument/2006/relationships" xmlns:a="http://schemas.openxmlformats.org/drawingml/2006/main" r:embed="R6898ad09cbf0475d"/>
+          <a:blip xmlns:r="http://schemas.openxmlformats.org/officeDocument/2006/relationships" xmlns:a="http://schemas.openxmlformats.org/drawingml/2006/main" r:embed="R59e895e74eef4911"/>
           <a:stretch xmlns:a="http://schemas.openxmlformats.org/drawingml/2006/main"/>
         </p:blipFill>
         <p:spPr>
@@ -3370,7 +3370,7 @@
           <p:cNvPr id="17" name="">
             <a:extLst xmlns:a="http://schemas.openxmlformats.org/drawingml/2006/main">
               <a:ext uri="{FF2B5EF4-FFF2-40B4-BE49-F238E27FC236}">
-                <a16:creationId xmlns:a16="http://schemas.microsoft.com/office/drawing/2014/main" id="{D93A141C-C7E2-4249-8D4F-F8D69B9BB54B}"/>
+                <a16:creationId xmlns:a16="http://schemas.microsoft.com/office/drawing/2014/main" id="{BBC1132F-DAEC-4D33-9DCD-2E514FC71F60}"/>
               </a:ext>
             </a:extLst>
           </p:cNvPr>
@@ -3412,7 +3412,7 @@
                   <a:srgbClr val="171918"/>
                 </a:solidFill>
               </a:rPr>
-              <a:t>PREDICT → EXPLAIN → SIMULATE → HAND OFF SAFELY</a:t>
+              <a:t>PREDICT → EXPLAIN → TEST → HAND OFF SAFELY</a:t>
             </a:r>
           </a:p>
         </p:txBody>
@@ -3422,7 +3422,7 @@
           <p:cNvPr id="18" name="">
             <a:extLst xmlns:a="http://schemas.openxmlformats.org/drawingml/2006/main">
               <a:ext uri="{FF2B5EF4-FFF2-40B4-BE49-F238E27FC236}">
-                <a16:creationId xmlns:a16="http://schemas.microsoft.com/office/drawing/2014/main" id="{ECE61AB8-FB62-40AD-B9C4-16961C702A84}"/>
+                <a16:creationId xmlns:a16="http://schemas.microsoft.com/office/drawing/2014/main" id="{7EB28DC9-A5EC-4834-A1EF-6BF3D8879C27}"/>
               </a:ext>
             </a:extLst>
           </p:cNvPr>
@@ -3455,7 +3455,7 @@
           <p:cNvPr id="19" name="">
             <a:extLst xmlns:a="http://schemas.openxmlformats.org/drawingml/2006/main">
               <a:ext uri="{FF2B5EF4-FFF2-40B4-BE49-F238E27FC236}">
-                <a16:creationId xmlns:a16="http://schemas.microsoft.com/office/drawing/2014/main" id="{91E8EBA3-27C2-40F7-94B9-5E2AC2496F94}"/>
+                <a16:creationId xmlns:a16="http://schemas.microsoft.com/office/drawing/2014/main" id="{0562185E-3238-40B5-BF72-3ACD5BB3752A}"/>
               </a:ext>
             </a:extLst>
           </p:cNvPr>
@@ -3507,7 +3507,7 @@
           <p:cNvPr id="20" name="">
             <a:extLst xmlns:a="http://schemas.openxmlformats.org/drawingml/2006/main">
               <a:ext uri="{FF2B5EF4-FFF2-40B4-BE49-F238E27FC236}">
-                <a16:creationId xmlns:a16="http://schemas.microsoft.com/office/drawing/2014/main" id="{DDCAAF6A-70BF-4785-B16F-9794AC48F6FA}"/>
+                <a16:creationId xmlns:a16="http://schemas.microsoft.com/office/drawing/2014/main" id="{7746E1A8-8BBD-4AF8-8C12-62B2BE9A91A8}"/>
               </a:ext>
             </a:extLst>
           </p:cNvPr>
@@ -3557,7 +3557,7 @@
     </p:spTree>
     <p:extLst>
       <p:ext uri="{BB962C8B-B14F-4D97-AF65-F5344CB8AC3E}">
-        <p14:creationId xmlns:p14="http://schemas.microsoft.com/office/powerpoint/2010/main" val="781340172"/>
+        <p14:creationId xmlns:p14="http://schemas.microsoft.com/office/powerpoint/2010/main" val="1865249990"/>
       </p:ext>
     </p:extLst>
   </p:cSld>
@@ -3588,7 +3588,7 @@
           <p:cNvPr id="1" name="">
             <a:extLst xmlns:a="http://schemas.openxmlformats.org/drawingml/2006/main">
               <a:ext uri="{FF2B5EF4-FFF2-40B4-BE49-F238E27FC236}">
-                <a16:creationId xmlns:a16="http://schemas.microsoft.com/office/drawing/2014/main" id="{B96BC24A-7ECF-44FD-AA4D-5BA5536A6E06}"/>
+                <a16:creationId xmlns:a16="http://schemas.microsoft.com/office/drawing/2014/main" id="{884D4E73-2F09-4234-97AF-DE42C13396DD}"/>
               </a:ext>
             </a:extLst>
           </p:cNvPr>
@@ -3640,7 +3640,7 @@
           <p:cNvPr id="2" name="">
             <a:extLst xmlns:a="http://schemas.openxmlformats.org/drawingml/2006/main">
               <a:ext uri="{FF2B5EF4-FFF2-40B4-BE49-F238E27FC236}">
-                <a16:creationId xmlns:a16="http://schemas.microsoft.com/office/drawing/2014/main" id="{849D3303-4B7A-4324-92E8-55C8EEE80C54}"/>
+                <a16:creationId xmlns:a16="http://schemas.microsoft.com/office/drawing/2014/main" id="{DD79B2DD-2B9C-4598-97D5-8B2171602F95}"/>
               </a:ext>
             </a:extLst>
           </p:cNvPr>
@@ -3692,7 +3692,7 @@
           <p:cNvPr id="3" name="">
             <a:extLst xmlns:a="http://schemas.openxmlformats.org/drawingml/2006/main">
               <a:ext uri="{FF2B5EF4-FFF2-40B4-BE49-F238E27FC236}">
-                <a16:creationId xmlns:a16="http://schemas.microsoft.com/office/drawing/2014/main" id="{BAC46EC5-F3D0-4459-9006-D346EAD809CE}"/>
+                <a16:creationId xmlns:a16="http://schemas.microsoft.com/office/drawing/2014/main" id="{5EB67D3B-772D-4451-9902-EDB975A08610}"/>
               </a:ext>
             </a:extLst>
           </p:cNvPr>
@@ -3744,7 +3744,7 @@
           <p:cNvPr id="4" name="">
             <a:extLst xmlns:a="http://schemas.openxmlformats.org/drawingml/2006/main">
               <a:ext uri="{FF2B5EF4-FFF2-40B4-BE49-F238E27FC236}">
-                <a16:creationId xmlns:a16="http://schemas.microsoft.com/office/drawing/2014/main" id="{830B2C26-0A03-46D9-89A2-295DF0980F25}"/>
+                <a16:creationId xmlns:a16="http://schemas.microsoft.com/office/drawing/2014/main" id="{7A7A8144-6509-4A63-82D2-BDA8BAA8FD3A}"/>
               </a:ext>
             </a:extLst>
           </p:cNvPr>
@@ -3796,7 +3796,7 @@
           <p:cNvPr id="5" name="">
             <a:extLst xmlns:a="http://schemas.openxmlformats.org/drawingml/2006/main">
               <a:ext uri="{FF2B5EF4-FFF2-40B4-BE49-F238E27FC236}">
-                <a16:creationId xmlns:a16="http://schemas.microsoft.com/office/drawing/2014/main" id="{ACB06ACA-F0ED-4527-9EE1-D75380115052}"/>
+                <a16:creationId xmlns:a16="http://schemas.microsoft.com/office/drawing/2014/main" id="{DA64D189-4285-45BA-A0CA-FD483DE73208}"/>
               </a:ext>
             </a:extLst>
           </p:cNvPr>
@@ -3848,7 +3848,7 @@
           <p:cNvPr id="6" name="">
             <a:extLst xmlns:a="http://schemas.openxmlformats.org/drawingml/2006/main">
               <a:ext uri="{FF2B5EF4-FFF2-40B4-BE49-F238E27FC236}">
-                <a16:creationId xmlns:a16="http://schemas.microsoft.com/office/drawing/2014/main" id="{0A5DD74F-BE65-4EFB-8193-D54A27070C0E}"/>
+                <a16:creationId xmlns:a16="http://schemas.microsoft.com/office/drawing/2014/main" id="{26954FCC-CF21-4AA6-B9CA-BCC6DE29EC9D}"/>
               </a:ext>
             </a:extLst>
           </p:cNvPr>
@@ -3900,7 +3900,7 @@
           <p:cNvPr id="7" name="">
             <a:extLst xmlns:a="http://schemas.openxmlformats.org/drawingml/2006/main">
               <a:ext uri="{FF2B5EF4-FFF2-40B4-BE49-F238E27FC236}">
-                <a16:creationId xmlns:a16="http://schemas.microsoft.com/office/drawing/2014/main" id="{5405C0F8-30DE-4561-8F85-A6B01F6CDA74}"/>
+                <a16:creationId xmlns:a16="http://schemas.microsoft.com/office/drawing/2014/main" id="{0E09DC25-24CC-4839-8198-70C5FBE1B859}"/>
               </a:ext>
             </a:extLst>
           </p:cNvPr>
@@ -3952,7 +3952,7 @@
           <p:cNvPr id="8" name="">
             <a:extLst xmlns:a="http://schemas.openxmlformats.org/drawingml/2006/main">
               <a:ext uri="{FF2B5EF4-FFF2-40B4-BE49-F238E27FC236}">
-                <a16:creationId xmlns:a16="http://schemas.microsoft.com/office/drawing/2014/main" id="{62E875A9-8CA3-4562-88A5-519339990359}"/>
+                <a16:creationId xmlns:a16="http://schemas.microsoft.com/office/drawing/2014/main" id="{D5F0126C-8CF3-4789-83E0-5BE30F9786A9}"/>
               </a:ext>
             </a:extLst>
           </p:cNvPr>
@@ -4004,7 +4004,7 @@
           <p:cNvPr id="9" name="">
             <a:extLst xmlns:a="http://schemas.openxmlformats.org/drawingml/2006/main">
               <a:ext uri="{FF2B5EF4-FFF2-40B4-BE49-F238E27FC236}">
-                <a16:creationId xmlns:a16="http://schemas.microsoft.com/office/drawing/2014/main" id="{92EB455C-DF4A-4295-8D3F-EF3C20BCFFE5}"/>
+                <a16:creationId xmlns:a16="http://schemas.microsoft.com/office/drawing/2014/main" id="{72B6260B-214B-48ED-812D-F6AA2016AB81}"/>
               </a:ext>
             </a:extLst>
           </p:cNvPr>
@@ -4056,7 +4056,7 @@
           <p:cNvPr id="10" name="">
             <a:extLst xmlns:a="http://schemas.openxmlformats.org/drawingml/2006/main">
               <a:ext uri="{FF2B5EF4-FFF2-40B4-BE49-F238E27FC236}">
-                <a16:creationId xmlns:a16="http://schemas.microsoft.com/office/drawing/2014/main" id="{70E7D4FC-E9A4-4836-BA17-7A8BF30B40DF}"/>
+                <a16:creationId xmlns:a16="http://schemas.microsoft.com/office/drawing/2014/main" id="{A1315A65-9DAB-4235-A02C-5C92BCE7A698}"/>
               </a:ext>
             </a:extLst>
           </p:cNvPr>
@@ -4108,7 +4108,7 @@
           <p:cNvPr id="11" name="">
             <a:extLst xmlns:a="http://schemas.openxmlformats.org/drawingml/2006/main">
               <a:ext uri="{FF2B5EF4-FFF2-40B4-BE49-F238E27FC236}">
-                <a16:creationId xmlns:a16="http://schemas.microsoft.com/office/drawing/2014/main" id="{FDAEA7F9-E470-464A-A2DE-33D92322C3D4}"/>
+                <a16:creationId xmlns:a16="http://schemas.microsoft.com/office/drawing/2014/main" id="{97BBED0D-C12B-448A-B57B-CC47CFF1F2C9}"/>
               </a:ext>
             </a:extLst>
           </p:cNvPr>
@@ -4160,7 +4160,7 @@
           <p:cNvPr id="12" name="">
             <a:extLst xmlns:a="http://schemas.openxmlformats.org/drawingml/2006/main">
               <a:ext uri="{FF2B5EF4-FFF2-40B4-BE49-F238E27FC236}">
-                <a16:creationId xmlns:a16="http://schemas.microsoft.com/office/drawing/2014/main" id="{AA271253-1C97-42CC-8F49-4D2B883DE053}"/>
+                <a16:creationId xmlns:a16="http://schemas.microsoft.com/office/drawing/2014/main" id="{DAC2E229-544E-4616-A0BB-65FD54CA0073}"/>
               </a:ext>
             </a:extLst>
           </p:cNvPr>
@@ -4197,7 +4197,7 @@
           <p:nvPr/>
         </p:nvPicPr>
         <p:blipFill>
-          <a:blip xmlns:r="http://schemas.openxmlformats.org/officeDocument/2006/relationships" xmlns:a="http://schemas.openxmlformats.org/drawingml/2006/main" r:embed="R60f060c7b4ea4ac6"/>
+          <a:blip xmlns:r="http://schemas.openxmlformats.org/officeDocument/2006/relationships" xmlns:a="http://schemas.openxmlformats.org/drawingml/2006/main" r:embed="R7da8d69e0c264476"/>
           <a:stretch xmlns:a="http://schemas.openxmlformats.org/drawingml/2006/main"/>
         </p:blipFill>
         <p:spPr>
@@ -4215,7 +4215,7 @@
           <p:cNvPr id="14" name="">
             <a:extLst xmlns:a="http://schemas.openxmlformats.org/drawingml/2006/main">
               <a:ext uri="{FF2B5EF4-FFF2-40B4-BE49-F238E27FC236}">
-                <a16:creationId xmlns:a16="http://schemas.microsoft.com/office/drawing/2014/main" id="{2817DAEB-21D9-4C84-9A98-21B8895C8ABD}"/>
+                <a16:creationId xmlns:a16="http://schemas.microsoft.com/office/drawing/2014/main" id="{901CA42F-86AC-4645-BC1D-D83F099E1A77}"/>
               </a:ext>
             </a:extLst>
           </p:cNvPr>
@@ -4248,7 +4248,7 @@
           <p:cNvPr id="15" name="">
             <a:extLst xmlns:a="http://schemas.openxmlformats.org/drawingml/2006/main">
               <a:ext uri="{FF2B5EF4-FFF2-40B4-BE49-F238E27FC236}">
-                <a16:creationId xmlns:a16="http://schemas.microsoft.com/office/drawing/2014/main" id="{7393ADBD-C0A8-4E85-911E-E08D25291C63}"/>
+                <a16:creationId xmlns:a16="http://schemas.microsoft.com/office/drawing/2014/main" id="{D21C0D81-A9E0-42DA-87A2-097D4FCBC2C6}"/>
               </a:ext>
             </a:extLst>
           </p:cNvPr>
@@ -4300,7 +4300,7 @@
           <p:cNvPr id="16" name="">
             <a:extLst xmlns:a="http://schemas.openxmlformats.org/drawingml/2006/main">
               <a:ext uri="{FF2B5EF4-FFF2-40B4-BE49-F238E27FC236}">
-                <a16:creationId xmlns:a16="http://schemas.microsoft.com/office/drawing/2014/main" id="{4F365A23-987D-4976-8A14-3C37BFCC9CC3}"/>
+                <a16:creationId xmlns:a16="http://schemas.microsoft.com/office/drawing/2014/main" id="{59D02C4B-A873-4789-9233-E90C91B98F5D}"/>
               </a:ext>
             </a:extLst>
           </p:cNvPr>
@@ -4350,7 +4350,7 @@
     </p:spTree>
     <p:extLst>
       <p:ext uri="{BB962C8B-B14F-4D97-AF65-F5344CB8AC3E}">
-        <p14:creationId xmlns:p14="http://schemas.microsoft.com/office/powerpoint/2010/main" val="770405853"/>
+        <p14:creationId xmlns:p14="http://schemas.microsoft.com/office/powerpoint/2010/main" val="142720397"/>
       </p:ext>
     </p:extLst>
   </p:cSld>
@@ -4381,7 +4381,7 @@
           <p:cNvPr id="1" name="">
             <a:extLst xmlns:a="http://schemas.openxmlformats.org/drawingml/2006/main">
               <a:ext uri="{FF2B5EF4-FFF2-40B4-BE49-F238E27FC236}">
-                <a16:creationId xmlns:a16="http://schemas.microsoft.com/office/drawing/2014/main" id="{2AABBAD4-B62E-4A54-8C76-0256499887B3}"/>
+                <a16:creationId xmlns:a16="http://schemas.microsoft.com/office/drawing/2014/main" id="{81D4B1A4-6C74-4EF7-A68B-FF0F5C8AF9B0}"/>
               </a:ext>
             </a:extLst>
           </p:cNvPr>
@@ -4433,7 +4433,7 @@
           <p:cNvPr id="2" name="">
             <a:extLst xmlns:a="http://schemas.openxmlformats.org/drawingml/2006/main">
               <a:ext uri="{FF2B5EF4-FFF2-40B4-BE49-F238E27FC236}">
-                <a16:creationId xmlns:a16="http://schemas.microsoft.com/office/drawing/2014/main" id="{FBED03C6-9BB7-4BDC-BAA2-E4A714063409}"/>
+                <a16:creationId xmlns:a16="http://schemas.microsoft.com/office/drawing/2014/main" id="{6F6607FE-980A-4164-BAF9-4C65C63B21C7}"/>
               </a:ext>
             </a:extLst>
           </p:cNvPr>
@@ -4475,7 +4475,7 @@
                   <a:srgbClr val="171918"/>
                 </a:solidFill>
               </a:rPr>
-              <a:t>One ledger separates model judgment from clinical safety</a:t>
+              <a:t>One ledger separates model inference from clinical safety</a:t>
             </a:r>
           </a:p>
         </p:txBody>
@@ -4485,7 +4485,7 @@
           <p:cNvPr id="3" name="">
             <a:extLst xmlns:a="http://schemas.openxmlformats.org/drawingml/2006/main">
               <a:ext uri="{FF2B5EF4-FFF2-40B4-BE49-F238E27FC236}">
-                <a16:creationId xmlns:a16="http://schemas.microsoft.com/office/drawing/2014/main" id="{B44FA8D2-20EA-4147-8EC7-3EA4F009595C}"/>
+                <a16:creationId xmlns:a16="http://schemas.microsoft.com/office/drawing/2014/main" id="{EAE49798-92DD-40B8-A5D4-638B44C76DEB}"/>
               </a:ext>
             </a:extLst>
           </p:cNvPr>
@@ -4518,7 +4518,7 @@
           <p:cNvPr id="4" name="">
             <a:extLst xmlns:a="http://schemas.openxmlformats.org/drawingml/2006/main">
               <a:ext uri="{FF2B5EF4-FFF2-40B4-BE49-F238E27FC236}">
-                <a16:creationId xmlns:a16="http://schemas.microsoft.com/office/drawing/2014/main" id="{B4C5C336-038B-4D16-87E7-A7CD8FCA8D69}"/>
+                <a16:creationId xmlns:a16="http://schemas.microsoft.com/office/drawing/2014/main" id="{DA3CDA9D-0D38-4494-B62E-277CA0610C9A}"/>
               </a:ext>
             </a:extLst>
           </p:cNvPr>
@@ -4551,7 +4551,7 @@
           <p:cNvPr id="5" name="">
             <a:extLst xmlns:a="http://schemas.openxmlformats.org/drawingml/2006/main">
               <a:ext uri="{FF2B5EF4-FFF2-40B4-BE49-F238E27FC236}">
-                <a16:creationId xmlns:a16="http://schemas.microsoft.com/office/drawing/2014/main" id="{21FA5DA8-FCF9-4EB8-ACAC-C380BC1644A4}"/>
+                <a16:creationId xmlns:a16="http://schemas.microsoft.com/office/drawing/2014/main" id="{5094AB19-FE89-4274-AD77-8E2CEE453B73}"/>
               </a:ext>
             </a:extLst>
           </p:cNvPr>
@@ -4603,7 +4603,7 @@
           <p:cNvPr id="6" name="">
             <a:extLst xmlns:a="http://schemas.openxmlformats.org/drawingml/2006/main">
               <a:ext uri="{FF2B5EF4-FFF2-40B4-BE49-F238E27FC236}">
-                <a16:creationId xmlns:a16="http://schemas.microsoft.com/office/drawing/2014/main" id="{EE618461-F490-42AF-A838-EF99B680944E}"/>
+                <a16:creationId xmlns:a16="http://schemas.microsoft.com/office/drawing/2014/main" id="{B055E70A-1238-412E-B9B1-463D6345E20D}"/>
               </a:ext>
             </a:extLst>
           </p:cNvPr>
@@ -4655,7 +4655,7 @@
           <p:cNvPr id="7" name="">
             <a:extLst xmlns:a="http://schemas.openxmlformats.org/drawingml/2006/main">
               <a:ext uri="{FF2B5EF4-FFF2-40B4-BE49-F238E27FC236}">
-                <a16:creationId xmlns:a16="http://schemas.microsoft.com/office/drawing/2014/main" id="{BF9A4D6A-828E-48F2-BD24-D10411F884AD}"/>
+                <a16:creationId xmlns:a16="http://schemas.microsoft.com/office/drawing/2014/main" id="{BD6BE2CB-DC9D-41A8-9370-9480AFA96544}"/>
               </a:ext>
             </a:extLst>
           </p:cNvPr>
@@ -4707,7 +4707,7 @@
           <p:cNvPr id="8" name="">
             <a:extLst xmlns:a="http://schemas.openxmlformats.org/drawingml/2006/main">
               <a:ext uri="{FF2B5EF4-FFF2-40B4-BE49-F238E27FC236}">
-                <a16:creationId xmlns:a16="http://schemas.microsoft.com/office/drawing/2014/main" id="{79F4EBC5-DC84-4911-9167-4F1D61E3A7F3}"/>
+                <a16:creationId xmlns:a16="http://schemas.microsoft.com/office/drawing/2014/main" id="{2957C249-0B0F-46A8-A81A-F1DA6F3462F0}"/>
               </a:ext>
             </a:extLst>
           </p:cNvPr>
@@ -4759,7 +4759,7 @@
           <p:cNvPr id="9" name="">
             <a:extLst xmlns:a="http://schemas.openxmlformats.org/drawingml/2006/main">
               <a:ext uri="{FF2B5EF4-FFF2-40B4-BE49-F238E27FC236}">
-                <a16:creationId xmlns:a16="http://schemas.microsoft.com/office/drawing/2014/main" id="{1E78FA01-847D-4AA9-BC7B-E377E18768EB}"/>
+                <a16:creationId xmlns:a16="http://schemas.microsoft.com/office/drawing/2014/main" id="{F1912FB6-7ECE-4971-AE34-20A05EA8C428}"/>
               </a:ext>
             </a:extLst>
           </p:cNvPr>
@@ -4792,7 +4792,7 @@
           <p:cNvPr id="10" name="">
             <a:extLst xmlns:a="http://schemas.openxmlformats.org/drawingml/2006/main">
               <a:ext uri="{FF2B5EF4-FFF2-40B4-BE49-F238E27FC236}">
-                <a16:creationId xmlns:a16="http://schemas.microsoft.com/office/drawing/2014/main" id="{CC8B0A55-07A3-4035-9F99-37B8EB5BF823}"/>
+                <a16:creationId xmlns:a16="http://schemas.microsoft.com/office/drawing/2014/main" id="{20E47DBE-4632-41E8-B6D4-5DA4416C1791}"/>
               </a:ext>
             </a:extLst>
           </p:cNvPr>
@@ -4825,7 +4825,7 @@
           <p:cNvPr id="11" name="">
             <a:extLst xmlns:a="http://schemas.openxmlformats.org/drawingml/2006/main">
               <a:ext uri="{FF2B5EF4-FFF2-40B4-BE49-F238E27FC236}">
-                <a16:creationId xmlns:a16="http://schemas.microsoft.com/office/drawing/2014/main" id="{09E4D745-B188-4B17-A3CA-C72F8472715B}"/>
+                <a16:creationId xmlns:a16="http://schemas.microsoft.com/office/drawing/2014/main" id="{EAC58DD2-01DA-444A-99BA-264E973BEA85}"/>
               </a:ext>
             </a:extLst>
           </p:cNvPr>
@@ -4877,7 +4877,7 @@
           <p:cNvPr id="12" name="">
             <a:extLst xmlns:a="http://schemas.openxmlformats.org/drawingml/2006/main">
               <a:ext uri="{FF2B5EF4-FFF2-40B4-BE49-F238E27FC236}">
-                <a16:creationId xmlns:a16="http://schemas.microsoft.com/office/drawing/2014/main" id="{DE160391-F080-4CF5-9E5A-C7B4AB9763E6}"/>
+                <a16:creationId xmlns:a16="http://schemas.microsoft.com/office/drawing/2014/main" id="{B7D83009-05F8-43FE-AD4A-3D270D85A8BB}"/>
               </a:ext>
             </a:extLst>
           </p:cNvPr>
@@ -4929,7 +4929,7 @@
           <p:cNvPr id="13" name="">
             <a:extLst xmlns:a="http://schemas.openxmlformats.org/drawingml/2006/main">
               <a:ext uri="{FF2B5EF4-FFF2-40B4-BE49-F238E27FC236}">
-                <a16:creationId xmlns:a16="http://schemas.microsoft.com/office/drawing/2014/main" id="{349E0CE0-6ED6-40F7-8EBD-457B75048663}"/>
+                <a16:creationId xmlns:a16="http://schemas.microsoft.com/office/drawing/2014/main" id="{E38ABB3C-69FD-4ED1-98C0-877C039F2243}"/>
               </a:ext>
             </a:extLst>
           </p:cNvPr>
@@ -4981,7 +4981,7 @@
           <p:cNvPr id="14" name="">
             <a:extLst xmlns:a="http://schemas.openxmlformats.org/drawingml/2006/main">
               <a:ext uri="{FF2B5EF4-FFF2-40B4-BE49-F238E27FC236}">
-                <a16:creationId xmlns:a16="http://schemas.microsoft.com/office/drawing/2014/main" id="{E047CE87-3880-44E5-A075-AA9E3A4A1123}"/>
+                <a16:creationId xmlns:a16="http://schemas.microsoft.com/office/drawing/2014/main" id="{6A0528EF-2A47-4399-BF75-99E4C7BB66FF}"/>
               </a:ext>
             </a:extLst>
           </p:cNvPr>
@@ -5033,7 +5033,7 @@
           <p:cNvPr id="15" name="">
             <a:extLst xmlns:a="http://schemas.openxmlformats.org/drawingml/2006/main">
               <a:ext uri="{FF2B5EF4-FFF2-40B4-BE49-F238E27FC236}">
-                <a16:creationId xmlns:a16="http://schemas.microsoft.com/office/drawing/2014/main" id="{7CA8747F-7C72-4C74-83D4-2FD4EB959302}"/>
+                <a16:creationId xmlns:a16="http://schemas.microsoft.com/office/drawing/2014/main" id="{2398BBEC-FFE1-463A-AF3A-A660CE370100}"/>
               </a:ext>
             </a:extLst>
           </p:cNvPr>
@@ -5066,7 +5066,7 @@
           <p:cNvPr id="16" name="">
             <a:extLst xmlns:a="http://schemas.openxmlformats.org/drawingml/2006/main">
               <a:ext uri="{FF2B5EF4-FFF2-40B4-BE49-F238E27FC236}">
-                <a16:creationId xmlns:a16="http://schemas.microsoft.com/office/drawing/2014/main" id="{917955CF-329D-4DCB-B210-A8308E072E07}"/>
+                <a16:creationId xmlns:a16="http://schemas.microsoft.com/office/drawing/2014/main" id="{F55339A6-F587-40F8-814A-B66B7F32D92F}"/>
               </a:ext>
             </a:extLst>
           </p:cNvPr>
@@ -5099,7 +5099,7 @@
           <p:cNvPr id="17" name="">
             <a:extLst xmlns:a="http://schemas.openxmlformats.org/drawingml/2006/main">
               <a:ext uri="{FF2B5EF4-FFF2-40B4-BE49-F238E27FC236}">
-                <a16:creationId xmlns:a16="http://schemas.microsoft.com/office/drawing/2014/main" id="{F57130D8-DE50-4881-97B0-A48ADDB6C449}"/>
+                <a16:creationId xmlns:a16="http://schemas.microsoft.com/office/drawing/2014/main" id="{6573C22E-B847-413F-A1EE-652ED6DD6424}"/>
               </a:ext>
             </a:extLst>
           </p:cNvPr>
@@ -5151,7 +5151,7 @@
           <p:cNvPr id="18" name="">
             <a:extLst xmlns:a="http://schemas.openxmlformats.org/drawingml/2006/main">
               <a:ext uri="{FF2B5EF4-FFF2-40B4-BE49-F238E27FC236}">
-                <a16:creationId xmlns:a16="http://schemas.microsoft.com/office/drawing/2014/main" id="{4E1C78A4-8F59-46DE-A1F0-52C1864E3E33}"/>
+                <a16:creationId xmlns:a16="http://schemas.microsoft.com/office/drawing/2014/main" id="{515C120F-5464-4052-809E-EDF080F9AFD4}"/>
               </a:ext>
             </a:extLst>
           </p:cNvPr>
@@ -5193,7 +5193,7 @@
                   <a:srgbClr val="171918"/>
                 </a:solidFill>
               </a:rPr>
-              <a:t>Evidence graph</a:t>
+              <a:t>Evidence map</a:t>
             </a:r>
           </a:p>
         </p:txBody>
@@ -5203,7 +5203,7 @@
           <p:cNvPr id="19" name="">
             <a:extLst xmlns:a="http://schemas.openxmlformats.org/drawingml/2006/main">
               <a:ext uri="{FF2B5EF4-FFF2-40B4-BE49-F238E27FC236}">
-                <a16:creationId xmlns:a16="http://schemas.microsoft.com/office/drawing/2014/main" id="{069E856E-2CE4-4FC5-89EF-78B475ED50AE}"/>
+                <a16:creationId xmlns:a16="http://schemas.microsoft.com/office/drawing/2014/main" id="{22DD6338-8E93-4479-A3F4-9EC7DAE0936B}"/>
               </a:ext>
             </a:extLst>
           </p:cNvPr>
@@ -5245,7 +5245,7 @@
                   <a:srgbClr val="606662"/>
                 </a:solidFill>
               </a:rPr>
-              <a:t>Typed sources, selected driver, bounded route comparison</a:t>
+              <a:t>Context signal, model contributor, tested-action comparison</a:t>
             </a:r>
           </a:p>
         </p:txBody>
@@ -5255,7 +5255,7 @@
           <p:cNvPr id="20" name="">
             <a:extLst xmlns:a="http://schemas.openxmlformats.org/drawingml/2006/main">
               <a:ext uri="{FF2B5EF4-FFF2-40B4-BE49-F238E27FC236}">
-                <a16:creationId xmlns:a16="http://schemas.microsoft.com/office/drawing/2014/main" id="{4BCF1281-996B-4ADB-AB82-8D8A2611D6DA}"/>
+                <a16:creationId xmlns:a16="http://schemas.microsoft.com/office/drawing/2014/main" id="{5BBA837A-047B-4406-A7E1-3B6D067743C9}"/>
               </a:ext>
             </a:extLst>
           </p:cNvPr>
@@ -5307,7 +5307,7 @@
           <p:cNvPr id="21" name="">
             <a:extLst xmlns:a="http://schemas.openxmlformats.org/drawingml/2006/main">
               <a:ext uri="{FF2B5EF4-FFF2-40B4-BE49-F238E27FC236}">
-                <a16:creationId xmlns:a16="http://schemas.microsoft.com/office/drawing/2014/main" id="{DB11F810-C55E-4A29-94A3-C468369B250A}"/>
+                <a16:creationId xmlns:a16="http://schemas.microsoft.com/office/drawing/2014/main" id="{1E460053-A5B7-4956-8EE4-7AFD1A7C8C23}"/>
               </a:ext>
             </a:extLst>
           </p:cNvPr>
@@ -5340,7 +5340,7 @@
           <p:cNvPr id="22" name="">
             <a:extLst xmlns:a="http://schemas.openxmlformats.org/drawingml/2006/main">
               <a:ext uri="{FF2B5EF4-FFF2-40B4-BE49-F238E27FC236}">
-                <a16:creationId xmlns:a16="http://schemas.microsoft.com/office/drawing/2014/main" id="{0B263352-BF1E-4628-9D1B-53A3B268CE52}"/>
+                <a16:creationId xmlns:a16="http://schemas.microsoft.com/office/drawing/2014/main" id="{F38E4DBB-A0A1-4C1A-9FF4-7BB6D0853B4A}"/>
               </a:ext>
             </a:extLst>
           </p:cNvPr>
@@ -5373,7 +5373,7 @@
           <p:cNvPr id="23" name="">
             <a:extLst xmlns:a="http://schemas.openxmlformats.org/drawingml/2006/main">
               <a:ext uri="{FF2B5EF4-FFF2-40B4-BE49-F238E27FC236}">
-                <a16:creationId xmlns:a16="http://schemas.microsoft.com/office/drawing/2014/main" id="{B2AD9317-EED5-4595-8FBC-951CB57182A7}"/>
+                <a16:creationId xmlns:a16="http://schemas.microsoft.com/office/drawing/2014/main" id="{D9706B97-07BD-4480-B799-01EEE75BF1EB}"/>
               </a:ext>
             </a:extLst>
           </p:cNvPr>
@@ -5425,7 +5425,7 @@
           <p:cNvPr id="24" name="">
             <a:extLst xmlns:a="http://schemas.openxmlformats.org/drawingml/2006/main">
               <a:ext uri="{FF2B5EF4-FFF2-40B4-BE49-F238E27FC236}">
-                <a16:creationId xmlns:a16="http://schemas.microsoft.com/office/drawing/2014/main" id="{94DB5BE1-C1F7-4341-9051-A09F801E334B}"/>
+                <a16:creationId xmlns:a16="http://schemas.microsoft.com/office/drawing/2014/main" id="{2E8CD983-402E-4DDE-AD30-9DCAF35A3A85}"/>
               </a:ext>
             </a:extLst>
           </p:cNvPr>
@@ -5477,7 +5477,7 @@
           <p:cNvPr id="25" name="">
             <a:extLst xmlns:a="http://schemas.openxmlformats.org/drawingml/2006/main">
               <a:ext uri="{FF2B5EF4-FFF2-40B4-BE49-F238E27FC236}">
-                <a16:creationId xmlns:a16="http://schemas.microsoft.com/office/drawing/2014/main" id="{E7170B02-B3AB-4BC7-B960-BDAB0CE25014}"/>
+                <a16:creationId xmlns:a16="http://schemas.microsoft.com/office/drawing/2014/main" id="{4E9CFFB4-0730-4658-AA7E-AF650FED5932}"/>
               </a:ext>
             </a:extLst>
           </p:cNvPr>
@@ -5529,7 +5529,7 @@
           <p:cNvPr id="26" name="">
             <a:extLst xmlns:a="http://schemas.openxmlformats.org/drawingml/2006/main">
               <a:ext uri="{FF2B5EF4-FFF2-40B4-BE49-F238E27FC236}">
-                <a16:creationId xmlns:a16="http://schemas.microsoft.com/office/drawing/2014/main" id="{D5BE8F0F-1082-4CB2-B564-00E24717B652}"/>
+                <a16:creationId xmlns:a16="http://schemas.microsoft.com/office/drawing/2014/main" id="{EBA8E10F-D5C2-42B4-AD8A-57A60BE923EB}"/>
               </a:ext>
             </a:extLst>
           </p:cNvPr>
@@ -5562,7 +5562,7 @@
           <p:cNvPr id="27" name="">
             <a:extLst xmlns:a="http://schemas.openxmlformats.org/drawingml/2006/main">
               <a:ext uri="{FF2B5EF4-FFF2-40B4-BE49-F238E27FC236}">
-                <a16:creationId xmlns:a16="http://schemas.microsoft.com/office/drawing/2014/main" id="{688EB13A-617E-4721-8508-1B8CB02BDE17}"/>
+                <a16:creationId xmlns:a16="http://schemas.microsoft.com/office/drawing/2014/main" id="{87C53FD9-6084-457C-BE19-4CD689A46B9A}"/>
               </a:ext>
             </a:extLst>
           </p:cNvPr>
@@ -5614,7 +5614,7 @@
           <p:cNvPr id="28" name="">
             <a:extLst xmlns:a="http://schemas.openxmlformats.org/drawingml/2006/main">
               <a:ext uri="{FF2B5EF4-FFF2-40B4-BE49-F238E27FC236}">
-                <a16:creationId xmlns:a16="http://schemas.microsoft.com/office/drawing/2014/main" id="{4A2DA0FD-52A7-43E1-9750-78CBA80CD4EC}"/>
+                <a16:creationId xmlns:a16="http://schemas.microsoft.com/office/drawing/2014/main" id="{C4087C76-D6EC-410E-9951-63922E23363E}"/>
               </a:ext>
             </a:extLst>
           </p:cNvPr>
@@ -5639,7 +5639,7 @@
         </p:spPr>
         <p:txBody>
           <a:bodyPr xmlns:a="http://schemas.openxmlformats.org/drawingml/2006/main" wrap="square" anchor="t">
-            <a:normAutofit fontScale="85820"/>
+            <a:normAutofit fontScale="88298"/>
           </a:bodyPr>
           <a:lstStyle xmlns:a="http://schemas.openxmlformats.org/drawingml/2006/main"/>
           <a:p xmlns:a="http://schemas.openxmlformats.org/drawingml/2006/main">
@@ -5656,7 +5656,7 @@
                   <a:srgbClr val="171918"/>
                 </a:solidFill>
               </a:rPr>
-              <a:t>Red flags suppress coaching and every simulated route, even when the model abstains.</a:t>
+              <a:t>Red flags suppress coaching and every tested action, even when the model abstains.</a:t>
             </a:r>
           </a:p>
         </p:txBody>
@@ -5666,7 +5666,7 @@
           <p:cNvPr id="29" name="">
             <a:extLst xmlns:a="http://schemas.openxmlformats.org/drawingml/2006/main">
               <a:ext uri="{FF2B5EF4-FFF2-40B4-BE49-F238E27FC236}">
-                <a16:creationId xmlns:a16="http://schemas.microsoft.com/office/drawing/2014/main" id="{77A9E75B-7BB2-4D2C-9C6F-10D00EAF7DD9}"/>
+                <a16:creationId xmlns:a16="http://schemas.microsoft.com/office/drawing/2014/main" id="{DDB507B2-8CF7-46DD-8125-8E25D375220A}"/>
               </a:ext>
             </a:extLst>
           </p:cNvPr>
@@ -5699,7 +5699,7 @@
           <p:cNvPr id="30" name="">
             <a:extLst xmlns:a="http://schemas.openxmlformats.org/drawingml/2006/main">
               <a:ext uri="{FF2B5EF4-FFF2-40B4-BE49-F238E27FC236}">
-                <a16:creationId xmlns:a16="http://schemas.microsoft.com/office/drawing/2014/main" id="{1169654C-F5DE-42BE-8240-82C91DDFF9C3}"/>
+                <a16:creationId xmlns:a16="http://schemas.microsoft.com/office/drawing/2014/main" id="{C23F1FFF-5A62-4C0A-822B-AD05FFC8353A}"/>
               </a:ext>
             </a:extLst>
           </p:cNvPr>
@@ -5751,7 +5751,7 @@
           <p:cNvPr id="31" name="">
             <a:extLst xmlns:a="http://schemas.openxmlformats.org/drawingml/2006/main">
               <a:ext uri="{FF2B5EF4-FFF2-40B4-BE49-F238E27FC236}">
-                <a16:creationId xmlns:a16="http://schemas.microsoft.com/office/drawing/2014/main" id="{FFAFC5D2-2FB0-432C-AABD-C40935397241}"/>
+                <a16:creationId xmlns:a16="http://schemas.microsoft.com/office/drawing/2014/main" id="{1BC03957-67E2-44D2-979A-83AD3298A8AA}"/>
               </a:ext>
             </a:extLst>
           </p:cNvPr>
@@ -5801,7 +5801,7 @@
     </p:spTree>
     <p:extLst>
       <p:ext uri="{BB962C8B-B14F-4D97-AF65-F5344CB8AC3E}">
-        <p14:creationId xmlns:p14="http://schemas.microsoft.com/office/powerpoint/2010/main" val="1390481457"/>
+        <p14:creationId xmlns:p14="http://schemas.microsoft.com/office/powerpoint/2010/main" val="5849188"/>
       </p:ext>
     </p:extLst>
   </p:cSld>
@@ -5832,7 +5832,7 @@
           <p:cNvPr id="1" name="">
             <a:extLst xmlns:a="http://schemas.openxmlformats.org/drawingml/2006/main">
               <a:ext uri="{FF2B5EF4-FFF2-40B4-BE49-F238E27FC236}">
-                <a16:creationId xmlns:a16="http://schemas.microsoft.com/office/drawing/2014/main" id="{CD6B59B7-DDA5-4044-ABA6-665D71D73093}"/>
+                <a16:creationId xmlns:a16="http://schemas.microsoft.com/office/drawing/2014/main" id="{F5618429-1DC7-410F-94F9-72B9D708AA47}"/>
               </a:ext>
             </a:extLst>
           </p:cNvPr>
@@ -5884,7 +5884,7 @@
           <p:cNvPr id="2" name="">
             <a:extLst xmlns:a="http://schemas.openxmlformats.org/drawingml/2006/main">
               <a:ext uri="{FF2B5EF4-FFF2-40B4-BE49-F238E27FC236}">
-                <a16:creationId xmlns:a16="http://schemas.microsoft.com/office/drawing/2014/main" id="{28FF3C11-75EC-41B4-A579-FBDFD8887631}"/>
+                <a16:creationId xmlns:a16="http://schemas.microsoft.com/office/drawing/2014/main" id="{69B4D2C0-B778-45AB-842F-06D566D7C764}"/>
               </a:ext>
             </a:extLst>
           </p:cNvPr>
@@ -5936,7 +5936,7 @@
           <p:cNvPr id="3" name="">
             <a:extLst xmlns:a="http://schemas.openxmlformats.org/drawingml/2006/main">
               <a:ext uri="{FF2B5EF4-FFF2-40B4-BE49-F238E27FC236}">
-                <a16:creationId xmlns:a16="http://schemas.microsoft.com/office/drawing/2014/main" id="{D0E26CA6-5921-4E20-A75E-8AD45319A7A1}"/>
+                <a16:creationId xmlns:a16="http://schemas.microsoft.com/office/drawing/2014/main" id="{2CF62D48-84B0-4F1C-A08B-D612EED2F095}"/>
               </a:ext>
             </a:extLst>
           </p:cNvPr>
@@ -5988,7 +5988,7 @@
           <p:cNvPr id="4" name="">
             <a:extLst xmlns:a="http://schemas.openxmlformats.org/drawingml/2006/main">
               <a:ext uri="{FF2B5EF4-FFF2-40B4-BE49-F238E27FC236}">
-                <a16:creationId xmlns:a16="http://schemas.microsoft.com/office/drawing/2014/main" id="{C8B02DDD-32FB-4F52-BF47-2A0F3A08E7B2}"/>
+                <a16:creationId xmlns:a16="http://schemas.microsoft.com/office/drawing/2014/main" id="{1C76F210-7BEC-41FF-A30F-11DD551B8C7E}"/>
               </a:ext>
             </a:extLst>
           </p:cNvPr>
@@ -6021,7 +6021,7 @@
           <p:cNvPr id="5" name="">
             <a:extLst xmlns:a="http://schemas.openxmlformats.org/drawingml/2006/main">
               <a:ext uri="{FF2B5EF4-FFF2-40B4-BE49-F238E27FC236}">
-                <a16:creationId xmlns:a16="http://schemas.microsoft.com/office/drawing/2014/main" id="{411CC7F5-A3DF-472A-BABA-8EBA6F960B9E}"/>
+                <a16:creationId xmlns:a16="http://schemas.microsoft.com/office/drawing/2014/main" id="{FE6AF07F-6B9C-4661-BBC3-8192457E4D31}"/>
               </a:ext>
             </a:extLst>
           </p:cNvPr>
@@ -6073,7 +6073,7 @@
           <p:cNvPr id="6" name="">
             <a:extLst xmlns:a="http://schemas.openxmlformats.org/drawingml/2006/main">
               <a:ext uri="{FF2B5EF4-FFF2-40B4-BE49-F238E27FC236}">
-                <a16:creationId xmlns:a16="http://schemas.microsoft.com/office/drawing/2014/main" id="{53BA0011-B7EC-455D-8857-7AA4877A51C9}"/>
+                <a16:creationId xmlns:a16="http://schemas.microsoft.com/office/drawing/2014/main" id="{731B6815-450B-48C9-9764-17A6BB9C7DD0}"/>
               </a:ext>
             </a:extLst>
           </p:cNvPr>
@@ -6115,7 +6115,7 @@
                   <a:srgbClr val="606662"/>
                 </a:solidFill>
               </a:rPr>
-              <a:t>One active driver</a:t>
+              <a:t>Context signal visible</a:t>
             </a:r>
           </a:p>
         </p:txBody>
@@ -6125,7 +6125,7 @@
           <p:cNvPr id="7" name="">
             <a:extLst xmlns:a="http://schemas.openxmlformats.org/drawingml/2006/main">
               <a:ext uri="{FF2B5EF4-FFF2-40B4-BE49-F238E27FC236}">
-                <a16:creationId xmlns:a16="http://schemas.microsoft.com/office/drawing/2014/main" id="{13045617-534B-4EAC-8E71-D982D41DEE3B}"/>
+                <a16:creationId xmlns:a16="http://schemas.microsoft.com/office/drawing/2014/main" id="{91976C6B-3D3E-425D-8137-F878522198E8}"/>
               </a:ext>
             </a:extLst>
           </p:cNvPr>
@@ -6177,7 +6177,7 @@
           <p:cNvPr id="8" name="">
             <a:extLst xmlns:a="http://schemas.openxmlformats.org/drawingml/2006/main">
               <a:ext uri="{FF2B5EF4-FFF2-40B4-BE49-F238E27FC236}">
-                <a16:creationId xmlns:a16="http://schemas.microsoft.com/office/drawing/2014/main" id="{497BD3C8-4046-43B1-B4A5-7782531DB146}"/>
+                <a16:creationId xmlns:a16="http://schemas.microsoft.com/office/drawing/2014/main" id="{3FDB09F5-C41D-411F-A154-8965A00C1BD3}"/>
               </a:ext>
             </a:extLst>
           </p:cNvPr>
@@ -6214,7 +6214,7 @@
           <p:nvPr/>
         </p:nvPicPr>
         <p:blipFill>
-          <a:blip xmlns:r="http://schemas.openxmlformats.org/officeDocument/2006/relationships" xmlns:a="http://schemas.openxmlformats.org/drawingml/2006/main" r:embed="Re0bed932af2d4cef"/>
+          <a:blip xmlns:r="http://schemas.openxmlformats.org/officeDocument/2006/relationships" xmlns:a="http://schemas.openxmlformats.org/drawingml/2006/main" r:embed="Rfcd26b2a5bce4861"/>
           <a:stretch xmlns:a="http://schemas.openxmlformats.org/drawingml/2006/main"/>
         </p:blipFill>
         <p:spPr>
@@ -6230,7 +6230,7 @@
     </p:spTree>
     <p:extLst>
       <p:ext uri="{BB962C8B-B14F-4D97-AF65-F5344CB8AC3E}">
-        <p14:creationId xmlns:p14="http://schemas.microsoft.com/office/powerpoint/2010/main" val="1647908665"/>
+        <p14:creationId xmlns:p14="http://schemas.microsoft.com/office/powerpoint/2010/main" val="874135176"/>
       </p:ext>
     </p:extLst>
   </p:cSld>
@@ -6261,7 +6261,7 @@
           <p:cNvPr id="1" name="">
             <a:extLst xmlns:a="http://schemas.openxmlformats.org/drawingml/2006/main">
               <a:ext uri="{FF2B5EF4-FFF2-40B4-BE49-F238E27FC236}">
-                <a16:creationId xmlns:a16="http://schemas.microsoft.com/office/drawing/2014/main" id="{6E4B9B28-39BA-422E-9B57-62A8A6B75BCE}"/>
+                <a16:creationId xmlns:a16="http://schemas.microsoft.com/office/drawing/2014/main" id="{46261544-9A2B-46AF-937B-5B53B546B9CD}"/>
               </a:ext>
             </a:extLst>
           </p:cNvPr>
@@ -6313,7 +6313,7 @@
           <p:cNvPr id="2" name="">
             <a:extLst xmlns:a="http://schemas.openxmlformats.org/drawingml/2006/main">
               <a:ext uri="{FF2B5EF4-FFF2-40B4-BE49-F238E27FC236}">
-                <a16:creationId xmlns:a16="http://schemas.microsoft.com/office/drawing/2014/main" id="{19402B11-DCD2-476F-B929-338FB0D53448}"/>
+                <a16:creationId xmlns:a16="http://schemas.microsoft.com/office/drawing/2014/main" id="{2B7B6CC9-19F7-4BC0-8379-99A8B2083D28}"/>
               </a:ext>
             </a:extLst>
           </p:cNvPr>
@@ -6355,7 +6355,7 @@
                   <a:srgbClr val="171918"/>
                 </a:solidFill>
               </a:rPr>
-              <a:t>Every visible driver carries its evidence source</a:t>
+              <a:t>The map separates context from model contribution</a:t>
             </a:r>
           </a:p>
         </p:txBody>
@@ -6365,7 +6365,7 @@
           <p:cNvPr id="3" name="">
             <a:extLst xmlns:a="http://schemas.openxmlformats.org/drawingml/2006/main">
               <a:ext uri="{FF2B5EF4-FFF2-40B4-BE49-F238E27FC236}">
-                <a16:creationId xmlns:a16="http://schemas.microsoft.com/office/drawing/2014/main" id="{7A2AD318-EDC9-45A6-A178-704C8C744DB3}"/>
+                <a16:creationId xmlns:a16="http://schemas.microsoft.com/office/drawing/2014/main" id="{E8DC8497-1FB1-4D67-B653-85B978F173D6}"/>
               </a:ext>
             </a:extLst>
           </p:cNvPr>
@@ -6417,7 +6417,7 @@
           <p:cNvPr id="4" name="">
             <a:extLst xmlns:a="http://schemas.openxmlformats.org/drawingml/2006/main">
               <a:ext uri="{FF2B5EF4-FFF2-40B4-BE49-F238E27FC236}">
-                <a16:creationId xmlns:a16="http://schemas.microsoft.com/office/drawing/2014/main" id="{96FF6A14-C644-40C3-AFC7-E3041069FDFC}"/>
+                <a16:creationId xmlns:a16="http://schemas.microsoft.com/office/drawing/2014/main" id="{F2926969-E955-45A3-A837-173211D05379}"/>
               </a:ext>
             </a:extLst>
           </p:cNvPr>
@@ -6450,7 +6450,7 @@
           <p:cNvPr id="5" name="">
             <a:extLst xmlns:a="http://schemas.openxmlformats.org/drawingml/2006/main">
               <a:ext uri="{FF2B5EF4-FFF2-40B4-BE49-F238E27FC236}">
-                <a16:creationId xmlns:a16="http://schemas.microsoft.com/office/drawing/2014/main" id="{43255D1D-E044-4729-9144-6CA510D8E518}"/>
+                <a16:creationId xmlns:a16="http://schemas.microsoft.com/office/drawing/2014/main" id="{63A79254-C88D-41B3-8E7A-0CD7566080C8}"/>
               </a:ext>
             </a:extLst>
           </p:cNvPr>
@@ -6492,7 +6492,7 @@
                   <a:srgbClr val="171918"/>
                 </a:solidFill>
               </a:rPr>
-              <a:t>Model</a:t>
+              <a:t>Context signal</a:t>
             </a:r>
           </a:p>
         </p:txBody>
@@ -6502,7 +6502,7 @@
           <p:cNvPr id="6" name="">
             <a:extLst xmlns:a="http://schemas.openxmlformats.org/drawingml/2006/main">
               <a:ext uri="{FF2B5EF4-FFF2-40B4-BE49-F238E27FC236}">
-                <a16:creationId xmlns:a16="http://schemas.microsoft.com/office/drawing/2014/main" id="{B634C567-5681-456F-8C7B-5ED80DA8FACC}"/>
+                <a16:creationId xmlns:a16="http://schemas.microsoft.com/office/drawing/2014/main" id="{333B7124-33FB-448D-A412-D12DA356A31E}"/>
               </a:ext>
             </a:extLst>
           </p:cNvPr>
@@ -6544,7 +6544,7 @@
                   <a:srgbClr val="606662"/>
                 </a:solidFill>
               </a:rPr>
-              <a:t>Simulation</a:t>
+              <a:t>Model contributor</a:t>
             </a:r>
           </a:p>
         </p:txBody>
@@ -6554,7 +6554,7 @@
           <p:cNvPr id="7" name="">
             <a:extLst xmlns:a="http://schemas.openxmlformats.org/drawingml/2006/main">
               <a:ext uri="{FF2B5EF4-FFF2-40B4-BE49-F238E27FC236}">
-                <a16:creationId xmlns:a16="http://schemas.microsoft.com/office/drawing/2014/main" id="{EE27988A-7F2C-4A08-AD73-317D7C663306}"/>
+                <a16:creationId xmlns:a16="http://schemas.microsoft.com/office/drawing/2014/main" id="{254A6F68-49FF-4B9F-96B8-0830F61F8F1C}"/>
               </a:ext>
             </a:extLst>
           </p:cNvPr>
@@ -6596,7 +6596,7 @@
                   <a:srgbClr val="606662"/>
                 </a:solidFill>
               </a:rPr>
-              <a:t>Rule / context</a:t>
+              <a:t>Typed provenance</a:t>
             </a:r>
           </a:p>
         </p:txBody>
@@ -6606,7 +6606,7 @@
           <p:cNvPr id="8" name="">
             <a:extLst xmlns:a="http://schemas.openxmlformats.org/drawingml/2006/main">
               <a:ext uri="{FF2B5EF4-FFF2-40B4-BE49-F238E27FC236}">
-                <a16:creationId xmlns:a16="http://schemas.microsoft.com/office/drawing/2014/main" id="{BFAA491C-4F36-4699-8A37-ECCDBCDF40D2}"/>
+                <a16:creationId xmlns:a16="http://schemas.microsoft.com/office/drawing/2014/main" id="{B61F7B2A-3832-46C5-83E3-2D0B3D21EC0A}"/>
               </a:ext>
             </a:extLst>
           </p:cNvPr>
@@ -6643,7 +6643,7 @@
           <p:nvPr/>
         </p:nvPicPr>
         <p:blipFill>
-          <a:blip xmlns:r="http://schemas.openxmlformats.org/officeDocument/2006/relationships" xmlns:a="http://schemas.openxmlformats.org/drawingml/2006/main" r:embed="R3ec22b443e0446ec"/>
+          <a:blip xmlns:r="http://schemas.openxmlformats.org/officeDocument/2006/relationships" xmlns:a="http://schemas.openxmlformats.org/drawingml/2006/main" r:embed="R0430879b48054cd1"/>
           <a:stretch xmlns:a="http://schemas.openxmlformats.org/drawingml/2006/main"/>
         </p:blipFill>
         <p:spPr>
@@ -6659,7 +6659,7 @@
     </p:spTree>
     <p:extLst>
       <p:ext uri="{BB962C8B-B14F-4D97-AF65-F5344CB8AC3E}">
-        <p14:creationId xmlns:p14="http://schemas.microsoft.com/office/powerpoint/2010/main" val="705364277"/>
+        <p14:creationId xmlns:p14="http://schemas.microsoft.com/office/powerpoint/2010/main" val="663849800"/>
       </p:ext>
     </p:extLst>
   </p:cSld>
@@ -6690,7 +6690,7 @@
           <p:cNvPr id="1" name="">
             <a:extLst xmlns:a="http://schemas.openxmlformats.org/drawingml/2006/main">
               <a:ext uri="{FF2B5EF4-FFF2-40B4-BE49-F238E27FC236}">
-                <a16:creationId xmlns:a16="http://schemas.microsoft.com/office/drawing/2014/main" id="{735FD743-6248-4411-AF21-8F4A483C62A2}"/>
+                <a16:creationId xmlns:a16="http://schemas.microsoft.com/office/drawing/2014/main" id="{19274D4C-38A0-4937-80B9-D34E4DEAD0BD}"/>
               </a:ext>
             </a:extLst>
           </p:cNvPr>
@@ -6742,7 +6742,7 @@
           <p:cNvPr id="2" name="">
             <a:extLst xmlns:a="http://schemas.openxmlformats.org/drawingml/2006/main">
               <a:ext uri="{FF2B5EF4-FFF2-40B4-BE49-F238E27FC236}">
-                <a16:creationId xmlns:a16="http://schemas.microsoft.com/office/drawing/2014/main" id="{552CA062-0F9B-469E-8D90-C4A0B65FDEDC}"/>
+                <a16:creationId xmlns:a16="http://schemas.microsoft.com/office/drawing/2014/main" id="{12FBD207-1237-4828-A0BC-339859B176E6}"/>
               </a:ext>
             </a:extLst>
           </p:cNvPr>
@@ -6784,7 +6784,7 @@
                   <a:srgbClr val="171918"/>
                 </a:solidFill>
               </a:rPr>
-              <a:t>Support routes are transparent assumptions, not causal claims</a:t>
+              <a:t>Tested actions are transparent assumptions, not causal claims</a:t>
             </a:r>
           </a:p>
         </p:txBody>
@@ -6794,7 +6794,7 @@
           <p:cNvPr id="3" name="">
             <a:extLst xmlns:a="http://schemas.openxmlformats.org/drawingml/2006/main">
               <a:ext uri="{FF2B5EF4-FFF2-40B4-BE49-F238E27FC236}">
-                <a16:creationId xmlns:a16="http://schemas.microsoft.com/office/drawing/2014/main" id="{D9784881-520A-470A-9534-65F5B07169D5}"/>
+                <a16:creationId xmlns:a16="http://schemas.microsoft.com/office/drawing/2014/main" id="{97AC9D85-6127-4C2D-9E19-000942E8723F}"/>
               </a:ext>
             </a:extLst>
           </p:cNvPr>
@@ -6819,7 +6819,7 @@
         </p:spPr>
         <p:txBody>
           <a:bodyPr xmlns:a="http://schemas.openxmlformats.org/drawingml/2006/main" wrap="square" anchor="t">
-            <a:normAutofit fontScale="92308"/>
+            <a:normAutofit fontScale="78450"/>
           </a:bodyPr>
           <a:lstStyle xmlns:a="http://schemas.openxmlformats.org/drawingml/2006/main"/>
           <a:p xmlns:a="http://schemas.openxmlformats.org/drawingml/2006/main">
@@ -6836,7 +6836,7 @@
                   <a:srgbClr val="606662"/>
                 </a:solidFill>
               </a:rPr>
-              <a:t>03 / WHAT-IF</a:t>
+              <a:t>03 / TESTED ACTION</a:t>
             </a:r>
           </a:p>
         </p:txBody>
@@ -6846,7 +6846,7 @@
           <p:cNvPr id="4" name="">
             <a:extLst xmlns:a="http://schemas.openxmlformats.org/drawingml/2006/main">
               <a:ext uri="{FF2B5EF4-FFF2-40B4-BE49-F238E27FC236}">
-                <a16:creationId xmlns:a16="http://schemas.microsoft.com/office/drawing/2014/main" id="{C5DAB27B-4E63-43ED-8FA8-C0A7F33187F5}"/>
+                <a16:creationId xmlns:a16="http://schemas.microsoft.com/office/drawing/2014/main" id="{806BE59F-A382-4FCB-A1F7-3DE4785A371A}"/>
               </a:ext>
             </a:extLst>
           </p:cNvPr>
@@ -6879,7 +6879,7 @@
           <p:cNvPr id="5" name="">
             <a:extLst xmlns:a="http://schemas.openxmlformats.org/drawingml/2006/main">
               <a:ext uri="{FF2B5EF4-FFF2-40B4-BE49-F238E27FC236}">
-                <a16:creationId xmlns:a16="http://schemas.microsoft.com/office/drawing/2014/main" id="{DC1DBFBA-11D2-4968-9071-1476ADF4765A}"/>
+                <a16:creationId xmlns:a16="http://schemas.microsoft.com/office/drawing/2014/main" id="{B8CAA5B7-18E0-4383-BEB4-2F5ADD13A063}"/>
               </a:ext>
             </a:extLst>
           </p:cNvPr>
@@ -6931,7 +6931,7 @@
           <p:cNvPr id="6" name="">
             <a:extLst xmlns:a="http://schemas.openxmlformats.org/drawingml/2006/main">
               <a:ext uri="{FF2B5EF4-FFF2-40B4-BE49-F238E27FC236}">
-                <a16:creationId xmlns:a16="http://schemas.microsoft.com/office/drawing/2014/main" id="{286C8838-B2C7-490B-AAB8-439D976AB0A1}"/>
+                <a16:creationId xmlns:a16="http://schemas.microsoft.com/office/drawing/2014/main" id="{0952F35F-8359-4DD4-A304-F0CB7729B67C}"/>
               </a:ext>
             </a:extLst>
           </p:cNvPr>
@@ -6983,7 +6983,7 @@
           <p:cNvPr id="7" name="">
             <a:extLst xmlns:a="http://schemas.openxmlformats.org/drawingml/2006/main">
               <a:ext uri="{FF2B5EF4-FFF2-40B4-BE49-F238E27FC236}">
-                <a16:creationId xmlns:a16="http://schemas.microsoft.com/office/drawing/2014/main" id="{48B6619A-0CAF-407A-81AB-877AE18BBECA}"/>
+                <a16:creationId xmlns:a16="http://schemas.microsoft.com/office/drawing/2014/main" id="{EC76B25A-82FC-4B00-BA17-B710AFDB0232}"/>
               </a:ext>
             </a:extLst>
           </p:cNvPr>
@@ -7035,7 +7035,7 @@
           <p:cNvPr id="8" name="">
             <a:extLst xmlns:a="http://schemas.openxmlformats.org/drawingml/2006/main">
               <a:ext uri="{FF2B5EF4-FFF2-40B4-BE49-F238E27FC236}">
-                <a16:creationId xmlns:a16="http://schemas.microsoft.com/office/drawing/2014/main" id="{566AB94C-E8FC-436A-B1A0-42B6DCCA9004}"/>
+                <a16:creationId xmlns:a16="http://schemas.microsoft.com/office/drawing/2014/main" id="{F5C6D7F2-4A67-423F-BE0C-E4D78A60DA3A}"/>
               </a:ext>
             </a:extLst>
           </p:cNvPr>
@@ -7072,7 +7072,7 @@
           <p:nvPr/>
         </p:nvPicPr>
         <p:blipFill>
-          <a:blip xmlns:r="http://schemas.openxmlformats.org/officeDocument/2006/relationships" xmlns:a="http://schemas.openxmlformats.org/drawingml/2006/main" r:embed="R6b7c96aae7bc46a0"/>
+          <a:blip xmlns:r="http://schemas.openxmlformats.org/officeDocument/2006/relationships" xmlns:a="http://schemas.openxmlformats.org/drawingml/2006/main" r:embed="R9533b6ee3d2e44cd"/>
           <a:stretch xmlns:a="http://schemas.openxmlformats.org/drawingml/2006/main"/>
         </p:blipFill>
         <p:spPr>
@@ -7088,7 +7088,7 @@
     </p:spTree>
     <p:extLst>
       <p:ext uri="{BB962C8B-B14F-4D97-AF65-F5344CB8AC3E}">
-        <p14:creationId xmlns:p14="http://schemas.microsoft.com/office/powerpoint/2010/main" val="1498924578"/>
+        <p14:creationId xmlns:p14="http://schemas.microsoft.com/office/powerpoint/2010/main" val="564873092"/>
       </p:ext>
     </p:extLst>
   </p:cSld>
@@ -7119,7 +7119,7 @@
           <p:cNvPr id="1" name="">
             <a:extLst xmlns:a="http://schemas.openxmlformats.org/drawingml/2006/main">
               <a:ext uri="{FF2B5EF4-FFF2-40B4-BE49-F238E27FC236}">
-                <a16:creationId xmlns:a16="http://schemas.microsoft.com/office/drawing/2014/main" id="{94FFBEFB-750B-4962-B2C3-21FB3510685D}"/>
+                <a16:creationId xmlns:a16="http://schemas.microsoft.com/office/drawing/2014/main" id="{456EAD34-458D-417F-A860-71237289F896}"/>
               </a:ext>
             </a:extLst>
           </p:cNvPr>
@@ -7171,7 +7171,7 @@
           <p:cNvPr id="2" name="">
             <a:extLst xmlns:a="http://schemas.openxmlformats.org/drawingml/2006/main">
               <a:ext uri="{FF2B5EF4-FFF2-40B4-BE49-F238E27FC236}">
-                <a16:creationId xmlns:a16="http://schemas.microsoft.com/office/drawing/2014/main" id="{D8F43BC8-C76F-49F6-AFA6-DBAEAA356961}"/>
+                <a16:creationId xmlns:a16="http://schemas.microsoft.com/office/drawing/2014/main" id="{A7DB22D0-8482-4A0C-9B70-2C0D96931281}"/>
               </a:ext>
             </a:extLst>
           </p:cNvPr>
@@ -7223,7 +7223,7 @@
           <p:cNvPr id="3" name="">
             <a:extLst xmlns:a="http://schemas.openxmlformats.org/drawingml/2006/main">
               <a:ext uri="{FF2B5EF4-FFF2-40B4-BE49-F238E27FC236}">
-                <a16:creationId xmlns:a16="http://schemas.microsoft.com/office/drawing/2014/main" id="{F68E06B5-1C9C-4853-8E80-850C78E0EBDC}"/>
+                <a16:creationId xmlns:a16="http://schemas.microsoft.com/office/drawing/2014/main" id="{EB392D66-9423-40DE-8E4F-22A65A18C3F7}"/>
               </a:ext>
             </a:extLst>
           </p:cNvPr>
@@ -7275,7 +7275,7 @@
           <p:cNvPr id="4" name="">
             <a:extLst xmlns:a="http://schemas.openxmlformats.org/drawingml/2006/main">
               <a:ext uri="{FF2B5EF4-FFF2-40B4-BE49-F238E27FC236}">
-                <a16:creationId xmlns:a16="http://schemas.microsoft.com/office/drawing/2014/main" id="{802D3759-5B10-41FE-AC81-5D055E423C24}"/>
+                <a16:creationId xmlns:a16="http://schemas.microsoft.com/office/drawing/2014/main" id="{3E390E47-4A4E-404E-81F0-9ECCF7893207}"/>
               </a:ext>
             </a:extLst>
           </p:cNvPr>
@@ -7308,7 +7308,7 @@
           <p:cNvPr id="5" name="">
             <a:extLst xmlns:a="http://schemas.openxmlformats.org/drawingml/2006/main">
               <a:ext uri="{FF2B5EF4-FFF2-40B4-BE49-F238E27FC236}">
-                <a16:creationId xmlns:a16="http://schemas.microsoft.com/office/drawing/2014/main" id="{F158DC68-A2C5-4548-A6A4-0ED324D42063}"/>
+                <a16:creationId xmlns:a16="http://schemas.microsoft.com/office/drawing/2014/main" id="{95BD9BF3-C088-4F2B-B502-ADA3970DD2F8}"/>
               </a:ext>
             </a:extLst>
           </p:cNvPr>
@@ -7360,7 +7360,7 @@
           <p:cNvPr id="6" name="">
             <a:extLst xmlns:a="http://schemas.openxmlformats.org/drawingml/2006/main">
               <a:ext uri="{FF2B5EF4-FFF2-40B4-BE49-F238E27FC236}">
-                <a16:creationId xmlns:a16="http://schemas.microsoft.com/office/drawing/2014/main" id="{581A136A-DF25-4659-A79D-3F5E451FBF9E}"/>
+                <a16:creationId xmlns:a16="http://schemas.microsoft.com/office/drawing/2014/main" id="{EBCFF521-6BF8-4D60-A35E-42608CB96958}"/>
               </a:ext>
             </a:extLst>
           </p:cNvPr>
@@ -7402,7 +7402,7 @@
                   <a:srgbClr val="606662"/>
                 </a:solidFill>
               </a:rPr>
-              <a:t>Routes suppressed</a:t>
+              <a:t>Actions suppressed</a:t>
             </a:r>
           </a:p>
         </p:txBody>
@@ -7412,7 +7412,7 @@
           <p:cNvPr id="7" name="">
             <a:extLst xmlns:a="http://schemas.openxmlformats.org/drawingml/2006/main">
               <a:ext uri="{FF2B5EF4-FFF2-40B4-BE49-F238E27FC236}">
-                <a16:creationId xmlns:a16="http://schemas.microsoft.com/office/drawing/2014/main" id="{AFE90C1C-FA5B-4DA4-BA11-6B6A8F65DA5B}"/>
+                <a16:creationId xmlns:a16="http://schemas.microsoft.com/office/drawing/2014/main" id="{67713FB4-6C35-4608-899D-2B8A576EF78A}"/>
               </a:ext>
             </a:extLst>
           </p:cNvPr>
@@ -7464,7 +7464,7 @@
           <p:cNvPr id="8" name="">
             <a:extLst xmlns:a="http://schemas.openxmlformats.org/drawingml/2006/main">
               <a:ext uri="{FF2B5EF4-FFF2-40B4-BE49-F238E27FC236}">
-                <a16:creationId xmlns:a16="http://schemas.microsoft.com/office/drawing/2014/main" id="{16F6D52E-06EF-4624-A16C-258BE0CF04C0}"/>
+                <a16:creationId xmlns:a16="http://schemas.microsoft.com/office/drawing/2014/main" id="{CF7AA903-D8B3-4A80-A5F5-1ED8A4E62F43}"/>
               </a:ext>
             </a:extLst>
           </p:cNvPr>
@@ -7501,7 +7501,7 @@
           <p:nvPr/>
         </p:nvPicPr>
         <p:blipFill>
-          <a:blip xmlns:r="http://schemas.openxmlformats.org/officeDocument/2006/relationships" xmlns:a="http://schemas.openxmlformats.org/drawingml/2006/main" r:embed="R87913914d6134217"/>
+          <a:blip xmlns:r="http://schemas.openxmlformats.org/officeDocument/2006/relationships" xmlns:a="http://schemas.openxmlformats.org/drawingml/2006/main" r:embed="R006f2b4425f74f84"/>
           <a:stretch xmlns:a="http://schemas.openxmlformats.org/drawingml/2006/main"/>
         </p:blipFill>
         <p:spPr>
@@ -7517,7 +7517,7 @@
     </p:spTree>
     <p:extLst>
       <p:ext uri="{BB962C8B-B14F-4D97-AF65-F5344CB8AC3E}">
-        <p14:creationId xmlns:p14="http://schemas.microsoft.com/office/powerpoint/2010/main" val="336144334"/>
+        <p14:creationId xmlns:p14="http://schemas.microsoft.com/office/powerpoint/2010/main" val="937508986"/>
       </p:ext>
     </p:extLst>
   </p:cSld>
@@ -7548,7 +7548,7 @@
           <p:cNvPr id="1" name="">
             <a:extLst xmlns:a="http://schemas.openxmlformats.org/drawingml/2006/main">
               <a:ext uri="{FF2B5EF4-FFF2-40B4-BE49-F238E27FC236}">
-                <a16:creationId xmlns:a16="http://schemas.microsoft.com/office/drawing/2014/main" id="{E2F86901-E061-4D10-AEA3-98E94CAD1872}"/>
+                <a16:creationId xmlns:a16="http://schemas.microsoft.com/office/drawing/2014/main" id="{3C5ED79A-A2FA-47D3-8E5C-1CDCAFBA4F43}"/>
               </a:ext>
             </a:extLst>
           </p:cNvPr>
@@ -7600,7 +7600,7 @@
           <p:cNvPr id="2" name="">
             <a:extLst xmlns:a="http://schemas.openxmlformats.org/drawingml/2006/main">
               <a:ext uri="{FF2B5EF4-FFF2-40B4-BE49-F238E27FC236}">
-                <a16:creationId xmlns:a16="http://schemas.microsoft.com/office/drawing/2014/main" id="{A71ADBE1-EC0D-4B95-B80B-05023FFA3D1D}"/>
+                <a16:creationId xmlns:a16="http://schemas.microsoft.com/office/drawing/2014/main" id="{000B4729-3EE6-4B31-8290-8F9A8D0AD307}"/>
               </a:ext>
             </a:extLst>
           </p:cNvPr>
@@ -7652,7 +7652,7 @@
           <p:cNvPr id="3" name="">
             <a:extLst xmlns:a="http://schemas.openxmlformats.org/drawingml/2006/main">
               <a:ext uri="{FF2B5EF4-FFF2-40B4-BE49-F238E27FC236}">
-                <a16:creationId xmlns:a16="http://schemas.microsoft.com/office/drawing/2014/main" id="{C10E3FB5-DD13-4A84-A306-09035C08D791}"/>
+                <a16:creationId xmlns:a16="http://schemas.microsoft.com/office/drawing/2014/main" id="{BFEE8121-A47D-4A93-A41C-10811C2265D5}"/>
               </a:ext>
             </a:extLst>
           </p:cNvPr>
@@ -7704,7 +7704,7 @@
           <p:cNvPr id="4" name="">
             <a:extLst xmlns:a="http://schemas.openxmlformats.org/drawingml/2006/main">
               <a:ext uri="{FF2B5EF4-FFF2-40B4-BE49-F238E27FC236}">
-                <a16:creationId xmlns:a16="http://schemas.microsoft.com/office/drawing/2014/main" id="{66351146-6BCC-4C8B-9002-F7E41CDA5EC3}"/>
+                <a16:creationId xmlns:a16="http://schemas.microsoft.com/office/drawing/2014/main" id="{53B497DD-09C2-47AD-8D8D-26753077492F}"/>
               </a:ext>
             </a:extLst>
           </p:cNvPr>
@@ -7737,7 +7737,7 @@
           <p:cNvPr id="5" name="">
             <a:extLst xmlns:a="http://schemas.openxmlformats.org/drawingml/2006/main">
               <a:ext uri="{FF2B5EF4-FFF2-40B4-BE49-F238E27FC236}">
-                <a16:creationId xmlns:a16="http://schemas.microsoft.com/office/drawing/2014/main" id="{FDBD4EFF-C5F8-4BC3-A369-9B9B40B5422A}"/>
+                <a16:creationId xmlns:a16="http://schemas.microsoft.com/office/drawing/2014/main" id="{8405A199-902C-4B3E-8C7F-765228584129}"/>
               </a:ext>
             </a:extLst>
           </p:cNvPr>
@@ -7789,7 +7789,7 @@
           <p:cNvPr id="6" name="">
             <a:extLst xmlns:a="http://schemas.openxmlformats.org/drawingml/2006/main">
               <a:ext uri="{FF2B5EF4-FFF2-40B4-BE49-F238E27FC236}">
-                <a16:creationId xmlns:a16="http://schemas.microsoft.com/office/drawing/2014/main" id="{9EC460CA-F119-4503-9CA7-3AC74435FC5A}"/>
+                <a16:creationId xmlns:a16="http://schemas.microsoft.com/office/drawing/2014/main" id="{CD80B9C0-903A-417E-B6CF-02B79D30250C}"/>
               </a:ext>
             </a:extLst>
           </p:cNvPr>
@@ -7841,7 +7841,7 @@
           <p:cNvPr id="7" name="">
             <a:extLst xmlns:a="http://schemas.openxmlformats.org/drawingml/2006/main">
               <a:ext uri="{FF2B5EF4-FFF2-40B4-BE49-F238E27FC236}">
-                <a16:creationId xmlns:a16="http://schemas.microsoft.com/office/drawing/2014/main" id="{46B780DA-CE71-4FB5-A761-3AE473DC9311}"/>
+                <a16:creationId xmlns:a16="http://schemas.microsoft.com/office/drawing/2014/main" id="{300BA70B-5746-4C4F-9DCE-2AC9DFE30817}"/>
               </a:ext>
             </a:extLst>
           </p:cNvPr>
@@ -7893,7 +7893,7 @@
           <p:cNvPr id="8" name="">
             <a:extLst xmlns:a="http://schemas.openxmlformats.org/drawingml/2006/main">
               <a:ext uri="{FF2B5EF4-FFF2-40B4-BE49-F238E27FC236}">
-                <a16:creationId xmlns:a16="http://schemas.microsoft.com/office/drawing/2014/main" id="{5B35C839-B29F-4BC8-A8E9-D60A94AD6811}"/>
+                <a16:creationId xmlns:a16="http://schemas.microsoft.com/office/drawing/2014/main" id="{C744A0CC-C3EA-4CC0-B5F3-A4E9251F91E8}"/>
               </a:ext>
             </a:extLst>
           </p:cNvPr>
@@ -7930,7 +7930,7 @@
           <p:nvPr/>
         </p:nvPicPr>
         <p:blipFill>
-          <a:blip xmlns:r="http://schemas.openxmlformats.org/officeDocument/2006/relationships" xmlns:a="http://schemas.openxmlformats.org/drawingml/2006/main" r:embed="R93d55648854c4c0f"/>
+          <a:blip xmlns:r="http://schemas.openxmlformats.org/officeDocument/2006/relationships" xmlns:a="http://schemas.openxmlformats.org/drawingml/2006/main" r:embed="Ra32f31e0c4284685"/>
           <a:stretch xmlns:a="http://schemas.openxmlformats.org/drawingml/2006/main"/>
         </p:blipFill>
         <p:spPr>
@@ -7946,7 +7946,7 @@
     </p:spTree>
     <p:extLst>
       <p:ext uri="{BB962C8B-B14F-4D97-AF65-F5344CB8AC3E}">
-        <p14:creationId xmlns:p14="http://schemas.microsoft.com/office/powerpoint/2010/main" val="2101124959"/>
+        <p14:creationId xmlns:p14="http://schemas.microsoft.com/office/powerpoint/2010/main" val="706944503"/>
       </p:ext>
     </p:extLst>
   </p:cSld>
@@ -7977,7 +7977,7 @@
           <p:cNvPr id="1" name="">
             <a:extLst xmlns:a="http://schemas.openxmlformats.org/drawingml/2006/main">
               <a:ext uri="{FF2B5EF4-FFF2-40B4-BE49-F238E27FC236}">
-                <a16:creationId xmlns:a16="http://schemas.microsoft.com/office/drawing/2014/main" id="{6D49A724-5615-46A4-A871-855C12F54A8F}"/>
+                <a16:creationId xmlns:a16="http://schemas.microsoft.com/office/drawing/2014/main" id="{B812DEBB-247A-4299-965B-DBC51904B145}"/>
               </a:ext>
             </a:extLst>
           </p:cNvPr>
@@ -8029,7 +8029,7 @@
           <p:cNvPr id="2" name="">
             <a:extLst xmlns:a="http://schemas.openxmlformats.org/drawingml/2006/main">
               <a:ext uri="{FF2B5EF4-FFF2-40B4-BE49-F238E27FC236}">
-                <a16:creationId xmlns:a16="http://schemas.microsoft.com/office/drawing/2014/main" id="{14A073BC-8560-48D7-B0B5-FCCF04190C8C}"/>
+                <a16:creationId xmlns:a16="http://schemas.microsoft.com/office/drawing/2014/main" id="{132BF6E7-4222-44E5-9DB5-98DE59BE6E4D}"/>
               </a:ext>
             </a:extLst>
           </p:cNvPr>
@@ -8081,7 +8081,7 @@
           <p:cNvPr id="3" name="">
             <a:extLst xmlns:a="http://schemas.openxmlformats.org/drawingml/2006/main">
               <a:ext uri="{FF2B5EF4-FFF2-40B4-BE49-F238E27FC236}">
-                <a16:creationId xmlns:a16="http://schemas.microsoft.com/office/drawing/2014/main" id="{2DFF56BB-9AEC-47D0-95D5-0BC88BD88D35}"/>
+                <a16:creationId xmlns:a16="http://schemas.microsoft.com/office/drawing/2014/main" id="{4ED62CB3-0548-4414-BCB6-7F8A3867ECAF}"/>
               </a:ext>
             </a:extLst>
           </p:cNvPr>
@@ -8133,7 +8133,7 @@
           <p:cNvPr id="4" name="">
             <a:extLst xmlns:a="http://schemas.openxmlformats.org/drawingml/2006/main">
               <a:ext uri="{FF2B5EF4-FFF2-40B4-BE49-F238E27FC236}">
-                <a16:creationId xmlns:a16="http://schemas.microsoft.com/office/drawing/2014/main" id="{3F70C8C8-8C5E-42BF-9986-9A18DA779140}"/>
+                <a16:creationId xmlns:a16="http://schemas.microsoft.com/office/drawing/2014/main" id="{E5BB6869-2387-4A88-9991-57F65FA3E751}"/>
               </a:ext>
             </a:extLst>
           </p:cNvPr>
@@ -8166,7 +8166,7 @@
           <p:cNvPr id="5" name="">
             <a:extLst xmlns:a="http://schemas.openxmlformats.org/drawingml/2006/main">
               <a:ext uri="{FF2B5EF4-FFF2-40B4-BE49-F238E27FC236}">
-                <a16:creationId xmlns:a16="http://schemas.microsoft.com/office/drawing/2014/main" id="{2503DC1F-5878-4129-B060-78698044C679}"/>
+                <a16:creationId xmlns:a16="http://schemas.microsoft.com/office/drawing/2014/main" id="{0268D759-6500-467E-AE0E-B157DA39D905}"/>
               </a:ext>
             </a:extLst>
           </p:cNvPr>
@@ -8218,7 +8218,7 @@
           <p:cNvPr id="6" name="">
             <a:extLst xmlns:a="http://schemas.openxmlformats.org/drawingml/2006/main">
               <a:ext uri="{FF2B5EF4-FFF2-40B4-BE49-F238E27FC236}">
-                <a16:creationId xmlns:a16="http://schemas.microsoft.com/office/drawing/2014/main" id="{8B4871BF-8F71-4CCF-ADF5-BF45E8E19E91}"/>
+                <a16:creationId xmlns:a16="http://schemas.microsoft.com/office/drawing/2014/main" id="{30AE27E9-43E5-4ABA-96D1-49B3BA2167F1}"/>
               </a:ext>
             </a:extLst>
           </p:cNvPr>
@@ -8270,7 +8270,7 @@
           <p:cNvPr id="7" name="">
             <a:extLst xmlns:a="http://schemas.openxmlformats.org/drawingml/2006/main">
               <a:ext uri="{FF2B5EF4-FFF2-40B4-BE49-F238E27FC236}">
-                <a16:creationId xmlns:a16="http://schemas.microsoft.com/office/drawing/2014/main" id="{8685471F-E9BA-4956-A5D6-7FBFC772F853}"/>
+                <a16:creationId xmlns:a16="http://schemas.microsoft.com/office/drawing/2014/main" id="{23A27978-D103-4DCC-9271-B5C11D6992E3}"/>
               </a:ext>
             </a:extLst>
           </p:cNvPr>
@@ -8322,7 +8322,7 @@
           <p:cNvPr id="8" name="">
             <a:extLst xmlns:a="http://schemas.openxmlformats.org/drawingml/2006/main">
               <a:ext uri="{FF2B5EF4-FFF2-40B4-BE49-F238E27FC236}">
-                <a16:creationId xmlns:a16="http://schemas.microsoft.com/office/drawing/2014/main" id="{0DA7CD27-E161-4702-87CC-B9F58D46A2BD}"/>
+                <a16:creationId xmlns:a16="http://schemas.microsoft.com/office/drawing/2014/main" id="{AE41977B-364E-48AC-9160-124DE68B1872}"/>
               </a:ext>
             </a:extLst>
           </p:cNvPr>
@@ -8359,7 +8359,7 @@
           <p:nvPr/>
         </p:nvPicPr>
         <p:blipFill>
-          <a:blip xmlns:r="http://schemas.openxmlformats.org/officeDocument/2006/relationships" xmlns:a="http://schemas.openxmlformats.org/drawingml/2006/main" r:embed="Rb2088cea3a24454e"/>
+          <a:blip xmlns:r="http://schemas.openxmlformats.org/officeDocument/2006/relationships" xmlns:a="http://schemas.openxmlformats.org/drawingml/2006/main" r:embed="Rc0b4473947c54c08"/>
           <a:stretch xmlns:a="http://schemas.openxmlformats.org/drawingml/2006/main"/>
         </p:blipFill>
         <p:spPr>
@@ -8375,7 +8375,7 @@
     </p:spTree>
     <p:extLst>
       <p:ext uri="{BB962C8B-B14F-4D97-AF65-F5344CB8AC3E}">
-        <p14:creationId xmlns:p14="http://schemas.microsoft.com/office/powerpoint/2010/main" val="1436038264"/>
+        <p14:creationId xmlns:p14="http://schemas.microsoft.com/office/powerpoint/2010/main" val="2074799668"/>
       </p:ext>
     </p:extLst>
   </p:cSld>

</xml_diff>

<commit_message>
Reframe local review and refresh demo media
</commit_message>
<xml_diff>
--- a/outputs/adherence-os-demo.pptx
+++ b/outputs/adherence-os-demo.pptx
@@ -2,22 +2,22 @@
 <file path=ppt/presentation.xml><?xml version="1.0" encoding="utf-8"?>
 <p:presentation xmlns:p="http://schemas.openxmlformats.org/presentationml/2006/main">
   <p:sldMasterIdLst>
-    <p:sldMasterId xmlns:r="http://schemas.openxmlformats.org/officeDocument/2006/relationships" id="2147483648" r:id="Rca191bade1694248"/>
+    <p:sldMasterId xmlns:r="http://schemas.openxmlformats.org/officeDocument/2006/relationships" id="2147483648" r:id="R0d829058331f4295"/>
   </p:sldMasterIdLst>
   <p:notesMasterIdLst>
-    <p:notesMasterId xmlns:r="http://schemas.openxmlformats.org/officeDocument/2006/relationships" r:id="Rdc6cdbc9dfd047ad"/>
+    <p:notesMasterId xmlns:r="http://schemas.openxmlformats.org/officeDocument/2006/relationships" r:id="R039ff5c09f774ca7"/>
   </p:notesMasterIdLst>
   <p:sldIdLst>
-    <p:sldId xmlns:r="http://schemas.openxmlformats.org/officeDocument/2006/relationships" id="256" r:id="R52840e5951e8418d"/>
-    <p:sldId xmlns:r="http://schemas.openxmlformats.org/officeDocument/2006/relationships" id="257" r:id="Rab88047a1fd14cf8"/>
-    <p:sldId xmlns:r="http://schemas.openxmlformats.org/officeDocument/2006/relationships" id="258" r:id="R488781ec707c42f6"/>
-    <p:sldId xmlns:r="http://schemas.openxmlformats.org/officeDocument/2006/relationships" id="259" r:id="R321c864f0977488f"/>
-    <p:sldId xmlns:r="http://schemas.openxmlformats.org/officeDocument/2006/relationships" id="260" r:id="R400f4d56287c4a85"/>
-    <p:sldId xmlns:r="http://schemas.openxmlformats.org/officeDocument/2006/relationships" id="261" r:id="R8ceff450a6844972"/>
-    <p:sldId xmlns:r="http://schemas.openxmlformats.org/officeDocument/2006/relationships" id="262" r:id="R7f46e7b8b5e146fd"/>
-    <p:sldId xmlns:r="http://schemas.openxmlformats.org/officeDocument/2006/relationships" id="263" r:id="R093da656b1db426e"/>
-    <p:sldId xmlns:r="http://schemas.openxmlformats.org/officeDocument/2006/relationships" id="264" r:id="R4c91be24fabb4399"/>
-    <p:sldId xmlns:r="http://schemas.openxmlformats.org/officeDocument/2006/relationships" id="265" r:id="R7f044dd9f3364997"/>
+    <p:sldId xmlns:r="http://schemas.openxmlformats.org/officeDocument/2006/relationships" id="256" r:id="R73548eb4a80844fd"/>
+    <p:sldId xmlns:r="http://schemas.openxmlformats.org/officeDocument/2006/relationships" id="257" r:id="R204bb8c9252745c4"/>
+    <p:sldId xmlns:r="http://schemas.openxmlformats.org/officeDocument/2006/relationships" id="258" r:id="R9e6377fb93d04d5a"/>
+    <p:sldId xmlns:r="http://schemas.openxmlformats.org/officeDocument/2006/relationships" id="259" r:id="Rdb11769debb7462b"/>
+    <p:sldId xmlns:r="http://schemas.openxmlformats.org/officeDocument/2006/relationships" id="260" r:id="R839ccd251f924a22"/>
+    <p:sldId xmlns:r="http://schemas.openxmlformats.org/officeDocument/2006/relationships" id="261" r:id="R5014c395b73b477a"/>
+    <p:sldId xmlns:r="http://schemas.openxmlformats.org/officeDocument/2006/relationships" id="262" r:id="R45f0c5362dba4f94"/>
+    <p:sldId xmlns:r="http://schemas.openxmlformats.org/officeDocument/2006/relationships" id="263" r:id="R219a8b6c5aa64377"/>
+    <p:sldId xmlns:r="http://schemas.openxmlformats.org/officeDocument/2006/relationships" id="264" r:id="R8989c647789e4342"/>
+    <p:sldId xmlns:r="http://schemas.openxmlformats.org/officeDocument/2006/relationships" id="265" r:id="Rb8fbffdee6c540c4"/>
   </p:sldIdLst>
   <p:sldSz cx="12192000" cy="6858000"/>
   <p:notesSz cx="6858000" cy="9144000"/>
@@ -1204,7 +1204,7 @@
   </p:cSld>
   <p:clrMap bg1="lt1" tx1="dk1" bg2="lt2" tx2="dk2" accent1="accent1" accent2="accent2" accent3="accent3" accent4="accent4" accent5="accent5" accent6="accent6" hlink="hlink" folHlink="folHlink"/>
   <p:sldLayoutIdLst>
-    <p:sldLayoutId xmlns:r="http://schemas.openxmlformats.org/officeDocument/2006/relationships" id="2147483649" r:id="R8b0bb7d274004702"/>
+    <p:sldLayoutId xmlns:r="http://schemas.openxmlformats.org/officeDocument/2006/relationships" id="2147483649" r:id="Rb2da8cbf749f4585"/>
   </p:sldLayoutIdLst>
   <p:txStyles>
     <p:titleStyle>
@@ -1818,6 +1818,7 @@
           <a:lstStyle xmlns:a="http://schemas.openxmlformats.org/drawingml/2006/main"/>
           <a:p xmlns:a="http://schemas.openxmlformats.org/drawingml/2006/main">
             <a:pPr algn="ctr">
+              <a:buNone/>
               <a:defRPr sz="1500" b="1">
                 <a:solidFill>
                   <a:srgbClr val="FFFFFF"/>
@@ -1870,6 +1871,7 @@
           <a:lstStyle xmlns:a="http://schemas.openxmlformats.org/drawingml/2006/main"/>
           <a:p xmlns:a="http://schemas.openxmlformats.org/drawingml/2006/main">
             <a:pPr algn="l">
+              <a:buNone/>
               <a:defRPr sz="975" b="1">
                 <a:solidFill>
                   <a:srgbClr val="606662"/>
@@ -1922,6 +1924,7 @@
           <a:lstStyle xmlns:a="http://schemas.openxmlformats.org/drawingml/2006/main"/>
           <a:p xmlns:a="http://schemas.openxmlformats.org/drawingml/2006/main">
             <a:pPr algn="l">
+              <a:buNone/>
               <a:defRPr sz="5100" b="1">
                 <a:solidFill>
                   <a:srgbClr val="171918"/>
@@ -1974,6 +1977,7 @@
           <a:lstStyle xmlns:a="http://schemas.openxmlformats.org/drawingml/2006/main"/>
           <a:p xmlns:a="http://schemas.openxmlformats.org/drawingml/2006/main">
             <a:pPr algn="l">
+              <a:buNone/>
               <a:defRPr sz="2025" b="0">
                 <a:solidFill>
                   <a:srgbClr val="606662"/>
@@ -2059,6 +2063,7 @@
           <a:lstStyle xmlns:a="http://schemas.openxmlformats.org/drawingml/2006/main"/>
           <a:p xmlns:a="http://schemas.openxmlformats.org/drawingml/2006/main">
             <a:pPr algn="l">
+              <a:buNone/>
               <a:defRPr sz="1050" b="1">
                 <a:solidFill>
                   <a:srgbClr val="006B58"/>
@@ -2111,6 +2116,7 @@
           <a:lstStyle xmlns:a="http://schemas.openxmlformats.org/drawingml/2006/main"/>
           <a:p xmlns:a="http://schemas.openxmlformats.org/drawingml/2006/main">
             <a:pPr algn="l">
+              <a:buNone/>
               <a:defRPr sz="1425" b="1">
                 <a:solidFill>
                   <a:srgbClr val="171918"/>
@@ -2163,6 +2169,7 @@
           <a:lstStyle xmlns:a="http://schemas.openxmlformats.org/drawingml/2006/main"/>
           <a:p xmlns:a="http://schemas.openxmlformats.org/drawingml/2006/main">
             <a:pPr algn="l">
+              <a:buNone/>
               <a:defRPr sz="1050" b="1">
                 <a:solidFill>
                   <a:srgbClr val="006B58"/>
@@ -2215,6 +2222,7 @@
           <a:lstStyle xmlns:a="http://schemas.openxmlformats.org/drawingml/2006/main"/>
           <a:p xmlns:a="http://schemas.openxmlformats.org/drawingml/2006/main">
             <a:pPr algn="l">
+              <a:buNone/>
               <a:defRPr sz="1425" b="1">
                 <a:solidFill>
                   <a:srgbClr val="171918"/>
@@ -2267,6 +2275,7 @@
           <a:lstStyle xmlns:a="http://schemas.openxmlformats.org/drawingml/2006/main"/>
           <a:p xmlns:a="http://schemas.openxmlformats.org/drawingml/2006/main">
             <a:pPr algn="l">
+              <a:buNone/>
               <a:defRPr sz="1050" b="1">
                 <a:solidFill>
                   <a:srgbClr val="006B58"/>
@@ -2319,6 +2328,7 @@
           <a:lstStyle xmlns:a="http://schemas.openxmlformats.org/drawingml/2006/main"/>
           <a:p xmlns:a="http://schemas.openxmlformats.org/drawingml/2006/main">
             <a:pPr algn="l">
+              <a:buNone/>
               <a:defRPr sz="1425" b="1">
                 <a:solidFill>
                   <a:srgbClr val="171918"/>
@@ -2371,6 +2381,7 @@
           <a:lstStyle xmlns:a="http://schemas.openxmlformats.org/drawingml/2006/main"/>
           <a:p xmlns:a="http://schemas.openxmlformats.org/drawingml/2006/main">
             <a:pPr algn="l">
+              <a:buNone/>
               <a:defRPr sz="1050" b="1">
                 <a:solidFill>
                   <a:srgbClr val="B42318"/>
@@ -2423,6 +2434,7 @@
           <a:lstStyle xmlns:a="http://schemas.openxmlformats.org/drawingml/2006/main"/>
           <a:p xmlns:a="http://schemas.openxmlformats.org/drawingml/2006/main">
             <a:pPr algn="l">
+              <a:buNone/>
               <a:defRPr sz="1425" b="1">
                 <a:solidFill>
                   <a:srgbClr val="171918"/>
@@ -2435,7 +2447,7 @@
                   <a:srgbClr val="171918"/>
                 </a:solidFill>
               </a:rPr>
-              <a:t>HAND OFF</a:t>
+              <a:t>REVIEW</a:t>
             </a:r>
           </a:p>
         </p:txBody>
@@ -2475,6 +2487,7 @@
           <a:lstStyle xmlns:a="http://schemas.openxmlformats.org/drawingml/2006/main"/>
           <a:p xmlns:a="http://schemas.openxmlformats.org/drawingml/2006/main">
             <a:pPr algn="l">
+              <a:buNone/>
               <a:defRPr sz="1350" b="0">
                 <a:solidFill>
                   <a:srgbClr val="606662"/>
@@ -2560,6 +2573,7 @@
           <a:lstStyle xmlns:a="http://schemas.openxmlformats.org/drawingml/2006/main"/>
           <a:p xmlns:a="http://schemas.openxmlformats.org/drawingml/2006/main">
             <a:pPr algn="l">
+              <a:buNone/>
               <a:defRPr sz="750" b="1">
                 <a:solidFill>
                   <a:srgbClr val="606662"/>
@@ -2612,6 +2626,7 @@
           <a:lstStyle xmlns:a="http://schemas.openxmlformats.org/drawingml/2006/main"/>
           <a:p xmlns:a="http://schemas.openxmlformats.org/drawingml/2006/main">
             <a:pPr algn="r">
+              <a:buNone/>
               <a:defRPr sz="750" b="1">
                 <a:solidFill>
                   <a:srgbClr val="606662"/>
@@ -2693,6 +2708,7 @@
           <a:lstStyle xmlns:a="http://schemas.openxmlformats.org/drawingml/2006/main"/>
           <a:p xmlns:a="http://schemas.openxmlformats.org/drawingml/2006/main">
             <a:pPr algn="l">
+              <a:buNone/>
               <a:defRPr sz="975" b="1">
                 <a:solidFill>
                   <a:srgbClr val="606662"/>
@@ -2745,6 +2761,7 @@
           <a:lstStyle xmlns:a="http://schemas.openxmlformats.org/drawingml/2006/main"/>
           <a:p xmlns:a="http://schemas.openxmlformats.org/drawingml/2006/main">
             <a:pPr algn="l">
+              <a:buNone/>
               <a:defRPr sz="2850" b="1">
                 <a:solidFill>
                   <a:srgbClr val="171918"/>
@@ -2830,6 +2847,7 @@
           <a:lstStyle xmlns:a="http://schemas.openxmlformats.org/drawingml/2006/main"/>
           <a:p xmlns:a="http://schemas.openxmlformats.org/drawingml/2006/main">
             <a:pPr algn="l">
+              <a:buNone/>
               <a:defRPr sz="1050" b="1">
                 <a:solidFill>
                   <a:srgbClr val="006B58"/>
@@ -2882,6 +2900,7 @@
           <a:lstStyle xmlns:a="http://schemas.openxmlformats.org/drawingml/2006/main"/>
           <a:p xmlns:a="http://schemas.openxmlformats.org/drawingml/2006/main">
             <a:pPr algn="l">
+              <a:buNone/>
               <a:defRPr sz="1500" b="1">
                 <a:solidFill>
                   <a:srgbClr val="171918"/>
@@ -2967,6 +2986,7 @@
           <a:lstStyle xmlns:a="http://schemas.openxmlformats.org/drawingml/2006/main"/>
           <a:p xmlns:a="http://schemas.openxmlformats.org/drawingml/2006/main">
             <a:pPr algn="l">
+              <a:buNone/>
               <a:defRPr sz="1050" b="1">
                 <a:solidFill>
                   <a:srgbClr val="2457A6"/>
@@ -3019,6 +3039,7 @@
           <a:lstStyle xmlns:a="http://schemas.openxmlformats.org/drawingml/2006/main"/>
           <a:p xmlns:a="http://schemas.openxmlformats.org/drawingml/2006/main">
             <a:pPr algn="l">
+              <a:buNone/>
               <a:defRPr sz="1500" b="1">
                 <a:solidFill>
                   <a:srgbClr val="171918"/>
@@ -3104,6 +3125,7 @@
           <a:lstStyle xmlns:a="http://schemas.openxmlformats.org/drawingml/2006/main"/>
           <a:p xmlns:a="http://schemas.openxmlformats.org/drawingml/2006/main">
             <a:pPr algn="l">
+              <a:buNone/>
               <a:defRPr sz="1050" b="1">
                 <a:solidFill>
                   <a:srgbClr val="006B58"/>
@@ -3156,6 +3178,7 @@
           <a:lstStyle xmlns:a="http://schemas.openxmlformats.org/drawingml/2006/main"/>
           <a:p xmlns:a="http://schemas.openxmlformats.org/drawingml/2006/main">
             <a:pPr algn="l">
+              <a:buNone/>
               <a:defRPr sz="1500" b="1">
                 <a:solidFill>
                   <a:srgbClr val="171918"/>
@@ -3168,7 +3191,7 @@
                   <a:srgbClr val="171918"/>
                 </a:solidFill>
               </a:rPr>
-              <a:t>Run keyless with checked-in synthetic data and deterministic fallback.</a:t>
+              <a:t>Run keyless with synthetic data, local inference, and deterministic safety.</a:t>
             </a:r>
           </a:p>
         </p:txBody>
@@ -3241,6 +3264,7 @@
           <a:lstStyle xmlns:a="http://schemas.openxmlformats.org/drawingml/2006/main"/>
           <a:p xmlns:a="http://schemas.openxmlformats.org/drawingml/2006/main">
             <a:pPr algn="l">
+              <a:buNone/>
               <a:defRPr sz="1050" b="1">
                 <a:solidFill>
                   <a:srgbClr val="B42318"/>
@@ -3293,6 +3317,7 @@
           <a:lstStyle xmlns:a="http://schemas.openxmlformats.org/drawingml/2006/main"/>
           <a:p xmlns:a="http://schemas.openxmlformats.org/drawingml/2006/main">
             <a:pPr algn="l">
+              <a:buNone/>
               <a:defRPr sz="1500" b="1">
                 <a:solidFill>
                   <a:srgbClr val="171918"/>
@@ -3305,7 +3330,7 @@
                   <a:srgbClr val="171918"/>
                 </a:solidFill>
               </a:rPr>
-              <a:t>Switch from a coaching path to a human-owned handoff in one click.</a:t>
+              <a:t>Switch from coaching to a local, unsent review draft in one click.</a:t>
             </a:r>
           </a:p>
         </p:txBody>
@@ -3345,18 +3370,18 @@
       </p:sp>
       <p:pic>
         <p:nvPicPr>
-          <p:cNvPr id="36" name=""/>
+          <p:cNvPr id="37" name=""/>
           <p:cNvPicPr>
             <a:picLocks xmlns:a="http://schemas.openxmlformats.org/drawingml/2006/main" noChangeAspect="1"/>
           </p:cNvPicPr>
           <p:nvPr/>
         </p:nvPicPr>
         <p:blipFill>
-          <a:blip xmlns:r="http://schemas.openxmlformats.org/officeDocument/2006/relationships" xmlns:a="http://schemas.openxmlformats.org/drawingml/2006/main" r:embed="R59e895e74eef4911"/>
+          <a:blip xmlns:r="http://schemas.openxmlformats.org/officeDocument/2006/relationships" xmlns:a="http://schemas.openxmlformats.org/drawingml/2006/main" r:embed="R96010832befe4531"/>
           <a:stretch xmlns:a="http://schemas.openxmlformats.org/drawingml/2006/main"/>
         </p:blipFill>
         <p:spPr>
-          <a:xfrm xmlns:a="http://schemas.openxmlformats.org/drawingml/2006/main">
+          <a:xfrm xmlns:a="http://schemas.openxmlformats.org/drawingml/2006/main" flipH="0" flipV="0">
             <a:off x="8839880" y="1028700"/>
             <a:ext cx="2351314" cy="5143500"/>
           </a:xfrm>
@@ -3400,6 +3425,7 @@
           <a:lstStyle xmlns:a="http://schemas.openxmlformats.org/drawingml/2006/main"/>
           <a:p xmlns:a="http://schemas.openxmlformats.org/drawingml/2006/main">
             <a:pPr algn="l">
+              <a:buNone/>
               <a:defRPr sz="1200" b="1">
                 <a:solidFill>
                   <a:srgbClr val="171918"/>
@@ -3485,6 +3511,7 @@
           <a:lstStyle xmlns:a="http://schemas.openxmlformats.org/drawingml/2006/main"/>
           <a:p xmlns:a="http://schemas.openxmlformats.org/drawingml/2006/main">
             <a:pPr algn="l">
+              <a:buNone/>
               <a:defRPr sz="750" b="1">
                 <a:solidFill>
                   <a:srgbClr val="606662"/>
@@ -3537,6 +3564,7 @@
           <a:lstStyle xmlns:a="http://schemas.openxmlformats.org/drawingml/2006/main"/>
           <a:p xmlns:a="http://schemas.openxmlformats.org/drawingml/2006/main">
             <a:pPr algn="r">
+              <a:buNone/>
               <a:defRPr sz="750" b="1">
                 <a:solidFill>
                   <a:srgbClr val="606662"/>
@@ -3618,6 +3646,7 @@
           <a:lstStyle xmlns:a="http://schemas.openxmlformats.org/drawingml/2006/main"/>
           <a:p xmlns:a="http://schemas.openxmlformats.org/drawingml/2006/main">
             <a:pPr algn="l">
+              <a:buNone/>
               <a:defRPr sz="975" b="1">
                 <a:solidFill>
                   <a:srgbClr val="606662"/>
@@ -3670,6 +3699,7 @@
           <a:lstStyle xmlns:a="http://schemas.openxmlformats.org/drawingml/2006/main"/>
           <a:p xmlns:a="http://schemas.openxmlformats.org/drawingml/2006/main">
             <a:pPr algn="l">
+              <a:buNone/>
               <a:defRPr sz="2850" b="1">
                 <a:solidFill>
                   <a:srgbClr val="171918"/>
@@ -3722,6 +3752,7 @@
           <a:lstStyle xmlns:a="http://schemas.openxmlformats.org/drawingml/2006/main"/>
           <a:p xmlns:a="http://schemas.openxmlformats.org/drawingml/2006/main">
             <a:pPr algn="l">
+              <a:buNone/>
               <a:defRPr sz="975" b="1">
                 <a:solidFill>
                   <a:srgbClr val="006B58"/>
@@ -3774,6 +3805,7 @@
           <a:lstStyle xmlns:a="http://schemas.openxmlformats.org/drawingml/2006/main"/>
           <a:p xmlns:a="http://schemas.openxmlformats.org/drawingml/2006/main">
             <a:pPr algn="l">
+              <a:buNone/>
               <a:defRPr sz="1725" b="1">
                 <a:solidFill>
                   <a:srgbClr val="171918"/>
@@ -3826,6 +3858,7 @@
           <a:lstStyle xmlns:a="http://schemas.openxmlformats.org/drawingml/2006/main"/>
           <a:p xmlns:a="http://schemas.openxmlformats.org/drawingml/2006/main">
             <a:pPr algn="l">
+              <a:buNone/>
               <a:defRPr sz="1275" b="0">
                 <a:solidFill>
                   <a:srgbClr val="606662"/>
@@ -3878,6 +3911,7 @@
           <a:lstStyle xmlns:a="http://schemas.openxmlformats.org/drawingml/2006/main"/>
           <a:p xmlns:a="http://schemas.openxmlformats.org/drawingml/2006/main">
             <a:pPr algn="l">
+              <a:buNone/>
               <a:defRPr sz="975" b="1">
                 <a:solidFill>
                   <a:srgbClr val="006B58"/>
@@ -3930,6 +3964,7 @@
           <a:lstStyle xmlns:a="http://schemas.openxmlformats.org/drawingml/2006/main"/>
           <a:p xmlns:a="http://schemas.openxmlformats.org/drawingml/2006/main">
             <a:pPr algn="l">
+              <a:buNone/>
               <a:defRPr sz="1725" b="1">
                 <a:solidFill>
                   <a:srgbClr val="171918"/>
@@ -3982,6 +4017,7 @@
           <a:lstStyle xmlns:a="http://schemas.openxmlformats.org/drawingml/2006/main"/>
           <a:p xmlns:a="http://schemas.openxmlformats.org/drawingml/2006/main">
             <a:pPr algn="l">
+              <a:buNone/>
               <a:defRPr sz="1275" b="0">
                 <a:solidFill>
                   <a:srgbClr val="606662"/>
@@ -4034,6 +4070,7 @@
           <a:lstStyle xmlns:a="http://schemas.openxmlformats.org/drawingml/2006/main"/>
           <a:p xmlns:a="http://schemas.openxmlformats.org/drawingml/2006/main">
             <a:pPr algn="l">
+              <a:buNone/>
               <a:defRPr sz="975" b="1">
                 <a:solidFill>
                   <a:srgbClr val="006B58"/>
@@ -4086,6 +4123,7 @@
           <a:lstStyle xmlns:a="http://schemas.openxmlformats.org/drawingml/2006/main"/>
           <a:p xmlns:a="http://schemas.openxmlformats.org/drawingml/2006/main">
             <a:pPr algn="l">
+              <a:buNone/>
               <a:defRPr sz="1725" b="1">
                 <a:solidFill>
                   <a:srgbClr val="171918"/>
@@ -4138,6 +4176,7 @@
           <a:lstStyle xmlns:a="http://schemas.openxmlformats.org/drawingml/2006/main"/>
           <a:p xmlns:a="http://schemas.openxmlformats.org/drawingml/2006/main">
             <a:pPr algn="l">
+              <a:buNone/>
               <a:defRPr sz="1275" b="0">
                 <a:solidFill>
                   <a:srgbClr val="606662"/>
@@ -4150,7 +4189,7 @@
                   <a:srgbClr val="606662"/>
                 </a:solidFill>
               </a:rPr>
-              <a:t>Care teams need an asynchronous record that makes the next review task obvious.</a:t>
+              <a:t>Care teams need a concise record that makes rule-matched review evidence obvious.</a:t>
             </a:r>
           </a:p>
         </p:txBody>
@@ -4190,18 +4229,18 @@
       </p:sp>
       <p:pic>
         <p:nvPicPr>
-          <p:cNvPr id="29" name=""/>
+          <p:cNvPr id="30" name=""/>
           <p:cNvPicPr>
             <a:picLocks xmlns:a="http://schemas.openxmlformats.org/drawingml/2006/main" noChangeAspect="1"/>
           </p:cNvPicPr>
           <p:nvPr/>
         </p:nvPicPr>
         <p:blipFill>
-          <a:blip xmlns:r="http://schemas.openxmlformats.org/officeDocument/2006/relationships" xmlns:a="http://schemas.openxmlformats.org/drawingml/2006/main" r:embed="R7da8d69e0c264476"/>
+          <a:blip xmlns:r="http://schemas.openxmlformats.org/officeDocument/2006/relationships" xmlns:a="http://schemas.openxmlformats.org/drawingml/2006/main" r:embed="R6b12589f91e944a4"/>
           <a:stretch xmlns:a="http://schemas.openxmlformats.org/drawingml/2006/main"/>
         </p:blipFill>
         <p:spPr>
-          <a:xfrm xmlns:a="http://schemas.openxmlformats.org/drawingml/2006/main">
+          <a:xfrm xmlns:a="http://schemas.openxmlformats.org/drawingml/2006/main" flipH="0" flipV="0">
             <a:off x="4705350" y="1678186"/>
             <a:ext cx="6953250" cy="3911203"/>
           </a:xfrm>
@@ -4278,6 +4317,7 @@
           <a:lstStyle xmlns:a="http://schemas.openxmlformats.org/drawingml/2006/main"/>
           <a:p xmlns:a="http://schemas.openxmlformats.org/drawingml/2006/main">
             <a:pPr algn="l">
+              <a:buNone/>
               <a:defRPr sz="750" b="1">
                 <a:solidFill>
                   <a:srgbClr val="606662"/>
@@ -4330,6 +4370,7 @@
           <a:lstStyle xmlns:a="http://schemas.openxmlformats.org/drawingml/2006/main"/>
           <a:p xmlns:a="http://schemas.openxmlformats.org/drawingml/2006/main">
             <a:pPr algn="r">
+              <a:buNone/>
               <a:defRPr sz="750" b="1">
                 <a:solidFill>
                   <a:srgbClr val="606662"/>
@@ -4411,6 +4452,7 @@
           <a:lstStyle xmlns:a="http://schemas.openxmlformats.org/drawingml/2006/main"/>
           <a:p xmlns:a="http://schemas.openxmlformats.org/drawingml/2006/main">
             <a:pPr algn="l">
+              <a:buNone/>
               <a:defRPr sz="975" b="1">
                 <a:solidFill>
                   <a:srgbClr val="606662"/>
@@ -4463,6 +4505,7 @@
           <a:lstStyle xmlns:a="http://schemas.openxmlformats.org/drawingml/2006/main"/>
           <a:p xmlns:a="http://schemas.openxmlformats.org/drawingml/2006/main">
             <a:pPr algn="l">
+              <a:buNone/>
               <a:defRPr sz="2850" b="1">
                 <a:solidFill>
                   <a:srgbClr val="171918"/>
@@ -4475,7 +4518,7 @@
                   <a:srgbClr val="171918"/>
                 </a:solidFill>
               </a:rPr>
-              <a:t>One ledger separates model inference from clinical safety</a:t>
+              <a:t>One ledger separates model inference from deterministic safety</a:t>
             </a:r>
           </a:p>
         </p:txBody>
@@ -4581,6 +4624,7 @@
           <a:lstStyle xmlns:a="http://schemas.openxmlformats.org/drawingml/2006/main"/>
           <a:p xmlns:a="http://schemas.openxmlformats.org/drawingml/2006/main">
             <a:pPr algn="l">
+              <a:buNone/>
               <a:defRPr sz="975" b="1">
                 <a:solidFill>
                   <a:srgbClr val="606662"/>
@@ -4633,6 +4677,7 @@
           <a:lstStyle xmlns:a="http://schemas.openxmlformats.org/drawingml/2006/main"/>
           <a:p xmlns:a="http://schemas.openxmlformats.org/drawingml/2006/main">
             <a:pPr algn="l">
+              <a:buNone/>
               <a:defRPr sz="1875" b="1">
                 <a:solidFill>
                   <a:srgbClr val="171918"/>
@@ -4685,6 +4730,7 @@
           <a:lstStyle xmlns:a="http://schemas.openxmlformats.org/drawingml/2006/main"/>
           <a:p xmlns:a="http://schemas.openxmlformats.org/drawingml/2006/main">
             <a:pPr algn="l">
+              <a:buNone/>
               <a:defRPr sz="1275" b="0">
                 <a:solidFill>
                   <a:srgbClr val="606662"/>
@@ -4737,6 +4783,7 @@
           <a:lstStyle xmlns:a="http://schemas.openxmlformats.org/drawingml/2006/main"/>
           <a:p xmlns:a="http://schemas.openxmlformats.org/drawingml/2006/main">
             <a:pPr algn="ctr">
+              <a:buNone/>
               <a:defRPr sz="2100" b="1">
                 <a:solidFill>
                   <a:srgbClr val="B9BEB9"/>
@@ -4855,6 +4902,7 @@
           <a:lstStyle xmlns:a="http://schemas.openxmlformats.org/drawingml/2006/main"/>
           <a:p xmlns:a="http://schemas.openxmlformats.org/drawingml/2006/main">
             <a:pPr algn="l">
+              <a:buNone/>
               <a:defRPr sz="975" b="1">
                 <a:solidFill>
                   <a:srgbClr val="606662"/>
@@ -4907,6 +4955,7 @@
           <a:lstStyle xmlns:a="http://schemas.openxmlformats.org/drawingml/2006/main"/>
           <a:p xmlns:a="http://schemas.openxmlformats.org/drawingml/2006/main">
             <a:pPr algn="l">
+              <a:buNone/>
               <a:defRPr sz="1875" b="1">
                 <a:solidFill>
                   <a:srgbClr val="171918"/>
@@ -4959,6 +5008,7 @@
           <a:lstStyle xmlns:a="http://schemas.openxmlformats.org/drawingml/2006/main"/>
           <a:p xmlns:a="http://schemas.openxmlformats.org/drawingml/2006/main">
             <a:pPr algn="l">
+              <a:buNone/>
               <a:defRPr sz="1275" b="0">
                 <a:solidFill>
                   <a:srgbClr val="606662"/>
@@ -4971,7 +5021,7 @@
                   <a:srgbClr val="606662"/>
                 </a:solidFill>
               </a:rPr>
-              <a:t>Prospective score, support bounds, exact decomposition</a:t>
+              <a:t>Prospective score, marginal bounds, exact decomposition</a:t>
             </a:r>
           </a:p>
         </p:txBody>
@@ -5011,6 +5061,7 @@
           <a:lstStyle xmlns:a="http://schemas.openxmlformats.org/drawingml/2006/main"/>
           <a:p xmlns:a="http://schemas.openxmlformats.org/drawingml/2006/main">
             <a:pPr algn="ctr">
+              <a:buNone/>
               <a:defRPr sz="2100" b="1">
                 <a:solidFill>
                   <a:srgbClr val="B9BEB9"/>
@@ -5129,6 +5180,7 @@
           <a:lstStyle xmlns:a="http://schemas.openxmlformats.org/drawingml/2006/main"/>
           <a:p xmlns:a="http://schemas.openxmlformats.org/drawingml/2006/main">
             <a:pPr algn="l">
+              <a:buNone/>
               <a:defRPr sz="975" b="1">
                 <a:solidFill>
                   <a:srgbClr val="606662"/>
@@ -5181,6 +5233,7 @@
           <a:lstStyle xmlns:a="http://schemas.openxmlformats.org/drawingml/2006/main"/>
           <a:p xmlns:a="http://schemas.openxmlformats.org/drawingml/2006/main">
             <a:pPr algn="l">
+              <a:buNone/>
               <a:defRPr sz="1875" b="1">
                 <a:solidFill>
                   <a:srgbClr val="171918"/>
@@ -5233,6 +5286,7 @@
           <a:lstStyle xmlns:a="http://schemas.openxmlformats.org/drawingml/2006/main"/>
           <a:p xmlns:a="http://schemas.openxmlformats.org/drawingml/2006/main">
             <a:pPr algn="l">
+              <a:buNone/>
               <a:defRPr sz="1275" b="0">
                 <a:solidFill>
                   <a:srgbClr val="606662"/>
@@ -5285,6 +5339,7 @@
           <a:lstStyle xmlns:a="http://schemas.openxmlformats.org/drawingml/2006/main"/>
           <a:p xmlns:a="http://schemas.openxmlformats.org/drawingml/2006/main">
             <a:pPr algn="ctr">
+              <a:buNone/>
               <a:defRPr sz="2100" b="1">
                 <a:solidFill>
                   <a:srgbClr val="B9BEB9"/>
@@ -5403,6 +5458,7 @@
           <a:lstStyle xmlns:a="http://schemas.openxmlformats.org/drawingml/2006/main"/>
           <a:p xmlns:a="http://schemas.openxmlformats.org/drawingml/2006/main">
             <a:pPr algn="l">
+              <a:buNone/>
               <a:defRPr sz="975" b="1">
                 <a:solidFill>
                   <a:srgbClr val="606662"/>
@@ -5450,11 +5506,12 @@
         </p:spPr>
         <p:txBody>
           <a:bodyPr xmlns:a="http://schemas.openxmlformats.org/drawingml/2006/main" wrap="square" anchor="t">
-            <a:normAutofit fontScale="100000"/>
-          </a:bodyPr>
-          <a:lstStyle xmlns:a="http://schemas.openxmlformats.org/drawingml/2006/main"/>
-          <a:p xmlns:a="http://schemas.openxmlformats.org/drawingml/2006/main">
-            <a:pPr algn="l">
+            <a:normAutofit fontScale="99346"/>
+          </a:bodyPr>
+          <a:lstStyle xmlns:a="http://schemas.openxmlformats.org/drawingml/2006/main"/>
+          <a:p xmlns:a="http://schemas.openxmlformats.org/drawingml/2006/main">
+            <a:pPr algn="l">
+              <a:buNone/>
               <a:defRPr sz="1875" b="1">
                 <a:solidFill>
                   <a:srgbClr val="171918"/>
@@ -5467,7 +5524,7 @@
                   <a:srgbClr val="171918"/>
                 </a:solidFill>
               </a:rPr>
-              <a:t>Clinical handoff</a:t>
+              <a:t>Local review draft</a:t>
             </a:r>
           </a:p>
         </p:txBody>
@@ -5507,6 +5564,7 @@
           <a:lstStyle xmlns:a="http://schemas.openxmlformats.org/drawingml/2006/main"/>
           <a:p xmlns:a="http://schemas.openxmlformats.org/drawingml/2006/main">
             <a:pPr algn="l">
+              <a:buNone/>
               <a:defRPr sz="1275" b="0">
                 <a:solidFill>
                   <a:srgbClr val="606662"/>
@@ -5519,7 +5577,7 @@
                   <a:srgbClr val="606662"/>
                 </a:solidFill>
               </a:rPr>
-              <a:t>Rule trigger, draft state, owner, audit trail</a:t>
+              <a:t>Rule trigger, in-memory state, unsent draft, audit trail</a:t>
             </a:r>
           </a:p>
         </p:txBody>
@@ -5592,6 +5650,7 @@
           <a:lstStyle xmlns:a="http://schemas.openxmlformats.org/drawingml/2006/main"/>
           <a:p xmlns:a="http://schemas.openxmlformats.org/drawingml/2006/main">
             <a:pPr algn="l">
+              <a:buNone/>
               <a:defRPr sz="1050" b="1">
                 <a:solidFill>
                   <a:srgbClr val="B42318"/>
@@ -5644,6 +5703,7 @@
           <a:lstStyle xmlns:a="http://schemas.openxmlformats.org/drawingml/2006/main"/>
           <a:p xmlns:a="http://schemas.openxmlformats.org/drawingml/2006/main">
             <a:pPr algn="l">
+              <a:buNone/>
               <a:defRPr sz="1650" b="1">
                 <a:solidFill>
                   <a:srgbClr val="171918"/>
@@ -5729,6 +5789,7 @@
           <a:lstStyle xmlns:a="http://schemas.openxmlformats.org/drawingml/2006/main"/>
           <a:p xmlns:a="http://schemas.openxmlformats.org/drawingml/2006/main">
             <a:pPr algn="l">
+              <a:buNone/>
               <a:defRPr sz="750" b="1">
                 <a:solidFill>
                   <a:srgbClr val="606662"/>
@@ -5781,6 +5842,7 @@
           <a:lstStyle xmlns:a="http://schemas.openxmlformats.org/drawingml/2006/main"/>
           <a:p xmlns:a="http://schemas.openxmlformats.org/drawingml/2006/main">
             <a:pPr algn="r">
+              <a:buNone/>
               <a:defRPr sz="750" b="1">
                 <a:solidFill>
                   <a:srgbClr val="606662"/>
@@ -5862,6 +5924,7 @@
           <a:lstStyle xmlns:a="http://schemas.openxmlformats.org/drawingml/2006/main"/>
           <a:p xmlns:a="http://schemas.openxmlformats.org/drawingml/2006/main">
             <a:pPr algn="l">
+              <a:buNone/>
               <a:defRPr sz="975" b="1">
                 <a:solidFill>
                   <a:srgbClr val="606662"/>
@@ -5914,6 +5977,7 @@
           <a:lstStyle xmlns:a="http://schemas.openxmlformats.org/drawingml/2006/main"/>
           <a:p xmlns:a="http://schemas.openxmlformats.org/drawingml/2006/main">
             <a:pPr algn="l">
+              <a:buNone/>
               <a:defRPr sz="2850" b="1">
                 <a:solidFill>
                   <a:srgbClr val="171918"/>
@@ -5966,6 +6030,7 @@
           <a:lstStyle xmlns:a="http://schemas.openxmlformats.org/drawingml/2006/main"/>
           <a:p xmlns:a="http://schemas.openxmlformats.org/drawingml/2006/main">
             <a:pPr algn="l">
+              <a:buNone/>
               <a:defRPr sz="975" b="1">
                 <a:solidFill>
                   <a:srgbClr val="606662"/>
@@ -6051,6 +6116,7 @@
           <a:lstStyle xmlns:a="http://schemas.openxmlformats.org/drawingml/2006/main"/>
           <a:p xmlns:a="http://schemas.openxmlformats.org/drawingml/2006/main">
             <a:pPr algn="l">
+              <a:buNone/>
               <a:defRPr sz="1425" b="1">
                 <a:solidFill>
                   <a:srgbClr val="171918"/>
@@ -6103,6 +6169,7 @@
           <a:lstStyle xmlns:a="http://schemas.openxmlformats.org/drawingml/2006/main"/>
           <a:p xmlns:a="http://schemas.openxmlformats.org/drawingml/2006/main">
             <a:pPr algn="l">
+              <a:buNone/>
               <a:defRPr sz="1125" b="0">
                 <a:solidFill>
                   <a:srgbClr val="606662"/>
@@ -6155,6 +6222,7 @@
           <a:lstStyle xmlns:a="http://schemas.openxmlformats.org/drawingml/2006/main"/>
           <a:p xmlns:a="http://schemas.openxmlformats.org/drawingml/2006/main">
             <a:pPr algn="l">
+              <a:buNone/>
               <a:defRPr sz="1125" b="0">
                 <a:solidFill>
                   <a:srgbClr val="606662"/>
@@ -6214,11 +6282,11 @@
           <p:nvPr/>
         </p:nvPicPr>
         <p:blipFill>
-          <a:blip xmlns:r="http://schemas.openxmlformats.org/officeDocument/2006/relationships" xmlns:a="http://schemas.openxmlformats.org/drawingml/2006/main" r:embed="Rfcd26b2a5bce4861"/>
+          <a:blip xmlns:r="http://schemas.openxmlformats.org/officeDocument/2006/relationships" xmlns:a="http://schemas.openxmlformats.org/drawingml/2006/main" r:embed="R426ccfd52d11408a"/>
           <a:stretch xmlns:a="http://schemas.openxmlformats.org/drawingml/2006/main"/>
         </p:blipFill>
         <p:spPr>
-          <a:xfrm xmlns:a="http://schemas.openxmlformats.org/drawingml/2006/main">
+          <a:xfrm xmlns:a="http://schemas.openxmlformats.org/drawingml/2006/main" flipH="0" flipV="0">
             <a:off x="1847850" y="1257300"/>
             <a:ext cx="9753600" cy="5486400"/>
           </a:xfrm>
@@ -6291,6 +6359,7 @@
           <a:lstStyle xmlns:a="http://schemas.openxmlformats.org/drawingml/2006/main"/>
           <a:p xmlns:a="http://schemas.openxmlformats.org/drawingml/2006/main">
             <a:pPr algn="l">
+              <a:buNone/>
               <a:defRPr sz="975" b="1">
                 <a:solidFill>
                   <a:srgbClr val="606662"/>
@@ -6343,6 +6412,7 @@
           <a:lstStyle xmlns:a="http://schemas.openxmlformats.org/drawingml/2006/main"/>
           <a:p xmlns:a="http://schemas.openxmlformats.org/drawingml/2006/main">
             <a:pPr algn="l">
+              <a:buNone/>
               <a:defRPr sz="2850" b="1">
                 <a:solidFill>
                   <a:srgbClr val="171918"/>
@@ -6395,6 +6465,7 @@
           <a:lstStyle xmlns:a="http://schemas.openxmlformats.org/drawingml/2006/main"/>
           <a:p xmlns:a="http://schemas.openxmlformats.org/drawingml/2006/main">
             <a:pPr algn="l">
+              <a:buNone/>
               <a:defRPr sz="975" b="1">
                 <a:solidFill>
                   <a:srgbClr val="606662"/>
@@ -6480,6 +6551,7 @@
           <a:lstStyle xmlns:a="http://schemas.openxmlformats.org/drawingml/2006/main"/>
           <a:p xmlns:a="http://schemas.openxmlformats.org/drawingml/2006/main">
             <a:pPr algn="l">
+              <a:buNone/>
               <a:defRPr sz="1425" b="1">
                 <a:solidFill>
                   <a:srgbClr val="171918"/>
@@ -6532,6 +6604,7 @@
           <a:lstStyle xmlns:a="http://schemas.openxmlformats.org/drawingml/2006/main"/>
           <a:p xmlns:a="http://schemas.openxmlformats.org/drawingml/2006/main">
             <a:pPr algn="l">
+              <a:buNone/>
               <a:defRPr sz="1125" b="0">
                 <a:solidFill>
                   <a:srgbClr val="606662"/>
@@ -6584,6 +6657,7 @@
           <a:lstStyle xmlns:a="http://schemas.openxmlformats.org/drawingml/2006/main"/>
           <a:p xmlns:a="http://schemas.openxmlformats.org/drawingml/2006/main">
             <a:pPr algn="l">
+              <a:buNone/>
               <a:defRPr sz="1125" b="0">
                 <a:solidFill>
                   <a:srgbClr val="606662"/>
@@ -6643,11 +6717,11 @@
           <p:nvPr/>
         </p:nvPicPr>
         <p:blipFill>
-          <a:blip xmlns:r="http://schemas.openxmlformats.org/officeDocument/2006/relationships" xmlns:a="http://schemas.openxmlformats.org/drawingml/2006/main" r:embed="R0430879b48054cd1"/>
+          <a:blip xmlns:r="http://schemas.openxmlformats.org/officeDocument/2006/relationships" xmlns:a="http://schemas.openxmlformats.org/drawingml/2006/main" r:embed="Rf1faa1d082c74b8d"/>
           <a:stretch xmlns:a="http://schemas.openxmlformats.org/drawingml/2006/main"/>
         </p:blipFill>
         <p:spPr>
-          <a:xfrm xmlns:a="http://schemas.openxmlformats.org/drawingml/2006/main">
+          <a:xfrm xmlns:a="http://schemas.openxmlformats.org/drawingml/2006/main" flipH="0" flipV="0">
             <a:off x="1847850" y="1257300"/>
             <a:ext cx="9753600" cy="5486400"/>
           </a:xfrm>
@@ -6720,6 +6794,7 @@
           <a:lstStyle xmlns:a="http://schemas.openxmlformats.org/drawingml/2006/main"/>
           <a:p xmlns:a="http://schemas.openxmlformats.org/drawingml/2006/main">
             <a:pPr algn="l">
+              <a:buNone/>
               <a:defRPr sz="975" b="1">
                 <a:solidFill>
                   <a:srgbClr val="606662"/>
@@ -6772,6 +6847,7 @@
           <a:lstStyle xmlns:a="http://schemas.openxmlformats.org/drawingml/2006/main"/>
           <a:p xmlns:a="http://schemas.openxmlformats.org/drawingml/2006/main">
             <a:pPr algn="l">
+              <a:buNone/>
               <a:defRPr sz="2850" b="1">
                 <a:solidFill>
                   <a:srgbClr val="171918"/>
@@ -6824,6 +6900,7 @@
           <a:lstStyle xmlns:a="http://schemas.openxmlformats.org/drawingml/2006/main"/>
           <a:p xmlns:a="http://schemas.openxmlformats.org/drawingml/2006/main">
             <a:pPr algn="l">
+              <a:buNone/>
               <a:defRPr sz="975" b="1">
                 <a:solidFill>
                   <a:srgbClr val="606662"/>
@@ -6909,6 +6986,7 @@
           <a:lstStyle xmlns:a="http://schemas.openxmlformats.org/drawingml/2006/main"/>
           <a:p xmlns:a="http://schemas.openxmlformats.org/drawingml/2006/main">
             <a:pPr algn="l">
+              <a:buNone/>
               <a:defRPr sz="1425" b="1">
                 <a:solidFill>
                   <a:srgbClr val="171918"/>
@@ -6961,6 +7039,7 @@
           <a:lstStyle xmlns:a="http://schemas.openxmlformats.org/drawingml/2006/main"/>
           <a:p xmlns:a="http://schemas.openxmlformats.org/drawingml/2006/main">
             <a:pPr algn="l">
+              <a:buNone/>
               <a:defRPr sz="1125" b="0">
                 <a:solidFill>
                   <a:srgbClr val="606662"/>
@@ -7013,6 +7092,7 @@
           <a:lstStyle xmlns:a="http://schemas.openxmlformats.org/drawingml/2006/main"/>
           <a:p xmlns:a="http://schemas.openxmlformats.org/drawingml/2006/main">
             <a:pPr algn="l">
+              <a:buNone/>
               <a:defRPr sz="1125" b="0">
                 <a:solidFill>
                   <a:srgbClr val="606662"/>
@@ -7025,7 +7105,7 @@
                   <a:srgbClr val="606662"/>
                 </a:solidFill>
               </a:rPr>
-              <a:t>Inside support only</a:t>
+              <a:t>Marginal bounds only</a:t>
             </a:r>
           </a:p>
         </p:txBody>
@@ -7072,11 +7152,11 @@
           <p:nvPr/>
         </p:nvPicPr>
         <p:blipFill>
-          <a:blip xmlns:r="http://schemas.openxmlformats.org/officeDocument/2006/relationships" xmlns:a="http://schemas.openxmlformats.org/drawingml/2006/main" r:embed="R9533b6ee3d2e44cd"/>
+          <a:blip xmlns:r="http://schemas.openxmlformats.org/officeDocument/2006/relationships" xmlns:a="http://schemas.openxmlformats.org/drawingml/2006/main" r:embed="R00122b5048894809"/>
           <a:stretch xmlns:a="http://schemas.openxmlformats.org/drawingml/2006/main"/>
         </p:blipFill>
         <p:spPr>
-          <a:xfrm xmlns:a="http://schemas.openxmlformats.org/drawingml/2006/main">
+          <a:xfrm xmlns:a="http://schemas.openxmlformats.org/drawingml/2006/main" flipH="0" flipV="0">
             <a:off x="1847850" y="1257300"/>
             <a:ext cx="9753600" cy="5486400"/>
           </a:xfrm>
@@ -7149,6 +7229,7 @@
           <a:lstStyle xmlns:a="http://schemas.openxmlformats.org/drawingml/2006/main"/>
           <a:p xmlns:a="http://schemas.openxmlformats.org/drawingml/2006/main">
             <a:pPr algn="l">
+              <a:buNone/>
               <a:defRPr sz="975" b="1">
                 <a:solidFill>
                   <a:srgbClr val="606662"/>
@@ -7201,6 +7282,7 @@
           <a:lstStyle xmlns:a="http://schemas.openxmlformats.org/drawingml/2006/main"/>
           <a:p xmlns:a="http://schemas.openxmlformats.org/drawingml/2006/main">
             <a:pPr algn="l">
+              <a:buNone/>
               <a:defRPr sz="2850" b="1">
                 <a:solidFill>
                   <a:srgbClr val="171918"/>
@@ -7253,6 +7335,7 @@
           <a:lstStyle xmlns:a="http://schemas.openxmlformats.org/drawingml/2006/main"/>
           <a:p xmlns:a="http://schemas.openxmlformats.org/drawingml/2006/main">
             <a:pPr algn="l">
+              <a:buNone/>
               <a:defRPr sz="975" b="1">
                 <a:solidFill>
                   <a:srgbClr val="606662"/>
@@ -7338,6 +7421,7 @@
           <a:lstStyle xmlns:a="http://schemas.openxmlformats.org/drawingml/2006/main"/>
           <a:p xmlns:a="http://schemas.openxmlformats.org/drawingml/2006/main">
             <a:pPr algn="l">
+              <a:buNone/>
               <a:defRPr sz="1425" b="1">
                 <a:solidFill>
                   <a:srgbClr val="171918"/>
@@ -7390,6 +7474,7 @@
           <a:lstStyle xmlns:a="http://schemas.openxmlformats.org/drawingml/2006/main"/>
           <a:p xmlns:a="http://schemas.openxmlformats.org/drawingml/2006/main">
             <a:pPr algn="l">
+              <a:buNone/>
               <a:defRPr sz="1125" b="0">
                 <a:solidFill>
                   <a:srgbClr val="606662"/>
@@ -7442,6 +7527,7 @@
           <a:lstStyle xmlns:a="http://schemas.openxmlformats.org/drawingml/2006/main"/>
           <a:p xmlns:a="http://schemas.openxmlformats.org/drawingml/2006/main">
             <a:pPr algn="l">
+              <a:buNone/>
               <a:defRPr sz="1125" b="0">
                 <a:solidFill>
                   <a:srgbClr val="606662"/>
@@ -7454,7 +7540,7 @@
                   <a:srgbClr val="606662"/>
                 </a:solidFill>
               </a:rPr>
-              <a:t>Clinician handoff</a:t>
+              <a:t>Local review draft</a:t>
             </a:r>
           </a:p>
         </p:txBody>
@@ -7501,11 +7587,11 @@
           <p:nvPr/>
         </p:nvPicPr>
         <p:blipFill>
-          <a:blip xmlns:r="http://schemas.openxmlformats.org/officeDocument/2006/relationships" xmlns:a="http://schemas.openxmlformats.org/drawingml/2006/main" r:embed="R006f2b4425f74f84"/>
+          <a:blip xmlns:r="http://schemas.openxmlformats.org/officeDocument/2006/relationships" xmlns:a="http://schemas.openxmlformats.org/drawingml/2006/main" r:embed="Rb09321ca98a547e2"/>
           <a:stretch xmlns:a="http://schemas.openxmlformats.org/drawingml/2006/main"/>
         </p:blipFill>
         <p:spPr>
-          <a:xfrm xmlns:a="http://schemas.openxmlformats.org/drawingml/2006/main">
+          <a:xfrm xmlns:a="http://schemas.openxmlformats.org/drawingml/2006/main" flipH="0" flipV="0">
             <a:off x="1847850" y="1257300"/>
             <a:ext cx="9753600" cy="5486400"/>
           </a:xfrm>
@@ -7578,6 +7664,7 @@
           <a:lstStyle xmlns:a="http://schemas.openxmlformats.org/drawingml/2006/main"/>
           <a:p xmlns:a="http://schemas.openxmlformats.org/drawingml/2006/main">
             <a:pPr algn="l">
+              <a:buNone/>
               <a:defRPr sz="975" b="1">
                 <a:solidFill>
                   <a:srgbClr val="606662"/>
@@ -7630,6 +7717,7 @@
           <a:lstStyle xmlns:a="http://schemas.openxmlformats.org/drawingml/2006/main"/>
           <a:p xmlns:a="http://schemas.openxmlformats.org/drawingml/2006/main">
             <a:pPr algn="l">
+              <a:buNone/>
               <a:defRPr sz="2850" b="1">
                 <a:solidFill>
                   <a:srgbClr val="171918"/>
@@ -7642,7 +7730,7 @@
                   <a:srgbClr val="171918"/>
                 </a:solidFill>
               </a:rPr>
-              <a:t>The system prepares a review task; it does not send or prescribe</a:t>
+              <a:t>A local review draft is prepared, never sent or prescribed</a:t>
             </a:r>
           </a:p>
         </p:txBody>
@@ -7682,6 +7770,7 @@
           <a:lstStyle xmlns:a="http://schemas.openxmlformats.org/drawingml/2006/main"/>
           <a:p xmlns:a="http://schemas.openxmlformats.org/drawingml/2006/main">
             <a:pPr algn="l">
+              <a:buNone/>
               <a:defRPr sz="975" b="1">
                 <a:solidFill>
                   <a:srgbClr val="606662"/>
@@ -7767,6 +7856,7 @@
           <a:lstStyle xmlns:a="http://schemas.openxmlformats.org/drawingml/2006/main"/>
           <a:p xmlns:a="http://schemas.openxmlformats.org/drawingml/2006/main">
             <a:pPr algn="l">
+              <a:buNone/>
               <a:defRPr sz="1425" b="1">
                 <a:solidFill>
                   <a:srgbClr val="171918"/>
@@ -7779,7 +7869,7 @@
                   <a:srgbClr val="171918"/>
                 </a:solidFill>
               </a:rPr>
-              <a:t>Pending review</a:t>
+              <a:t>Rule match</a:t>
             </a:r>
           </a:p>
         </p:txBody>
@@ -7819,6 +7909,7 @@
           <a:lstStyle xmlns:a="http://schemas.openxmlformats.org/drawingml/2006/main"/>
           <a:p xmlns:a="http://schemas.openxmlformats.org/drawingml/2006/main">
             <a:pPr algn="l">
+              <a:buNone/>
               <a:defRPr sz="1125" b="0">
                 <a:solidFill>
                   <a:srgbClr val="606662"/>
@@ -7831,7 +7922,7 @@
                   <a:srgbClr val="606662"/>
                 </a:solidFill>
               </a:rPr>
-              <a:t>Unassigned owner</a:t>
+              <a:t>In-memory only</a:t>
             </a:r>
           </a:p>
         </p:txBody>
@@ -7871,6 +7962,7 @@
           <a:lstStyle xmlns:a="http://schemas.openxmlformats.org/drawingml/2006/main"/>
           <a:p xmlns:a="http://schemas.openxmlformats.org/drawingml/2006/main">
             <a:pPr algn="l">
+              <a:buNone/>
               <a:defRPr sz="1125" b="0">
                 <a:solidFill>
                   <a:srgbClr val="606662"/>
@@ -7883,7 +7975,7 @@
                   <a:srgbClr val="606662"/>
                 </a:solidFill>
               </a:rPr>
-              <a:t>Draft only / not sent</a:t>
+              <a:t>Not sent</a:t>
             </a:r>
           </a:p>
         </p:txBody>
@@ -7930,11 +8022,11 @@
           <p:nvPr/>
         </p:nvPicPr>
         <p:blipFill>
-          <a:blip xmlns:r="http://schemas.openxmlformats.org/officeDocument/2006/relationships" xmlns:a="http://schemas.openxmlformats.org/drawingml/2006/main" r:embed="Ra32f31e0c4284685"/>
+          <a:blip xmlns:r="http://schemas.openxmlformats.org/officeDocument/2006/relationships" xmlns:a="http://schemas.openxmlformats.org/drawingml/2006/main" r:embed="Rbda9cbf270da4512"/>
           <a:stretch xmlns:a="http://schemas.openxmlformats.org/drawingml/2006/main"/>
         </p:blipFill>
         <p:spPr>
-          <a:xfrm xmlns:a="http://schemas.openxmlformats.org/drawingml/2006/main">
+          <a:xfrm xmlns:a="http://schemas.openxmlformats.org/drawingml/2006/main" flipH="0" flipV="0">
             <a:off x="1847850" y="1257300"/>
             <a:ext cx="9753600" cy="5486400"/>
           </a:xfrm>
@@ -8007,6 +8099,7 @@
           <a:lstStyle xmlns:a="http://schemas.openxmlformats.org/drawingml/2006/main"/>
           <a:p xmlns:a="http://schemas.openxmlformats.org/drawingml/2006/main">
             <a:pPr algn="l">
+              <a:buNone/>
               <a:defRPr sz="975" b="1">
                 <a:solidFill>
                   <a:srgbClr val="606662"/>
@@ -8059,6 +8152,7 @@
           <a:lstStyle xmlns:a="http://schemas.openxmlformats.org/drawingml/2006/main"/>
           <a:p xmlns:a="http://schemas.openxmlformats.org/drawingml/2006/main">
             <a:pPr algn="l">
+              <a:buNone/>
               <a:defRPr sz="2850" b="1">
                 <a:solidFill>
                   <a:srgbClr val="171918"/>
@@ -8111,6 +8205,7 @@
           <a:lstStyle xmlns:a="http://schemas.openxmlformats.org/drawingml/2006/main"/>
           <a:p xmlns:a="http://schemas.openxmlformats.org/drawingml/2006/main">
             <a:pPr algn="l">
+              <a:buNone/>
               <a:defRPr sz="975" b="1">
                 <a:solidFill>
                   <a:srgbClr val="606662"/>
@@ -8196,6 +8291,7 @@
           <a:lstStyle xmlns:a="http://schemas.openxmlformats.org/drawingml/2006/main"/>
           <a:p xmlns:a="http://schemas.openxmlformats.org/drawingml/2006/main">
             <a:pPr algn="l">
+              <a:buNone/>
               <a:defRPr sz="1425" b="1">
                 <a:solidFill>
                   <a:srgbClr val="171918"/>
@@ -8208,7 +8304,7 @@
                   <a:srgbClr val="171918"/>
                 </a:solidFill>
               </a:rPr>
-              <a:t>14 features</a:t>
+              <a:t>80% test recall</a:t>
             </a:r>
           </a:p>
         </p:txBody>
@@ -8248,6 +8344,7 @@
           <a:lstStyle xmlns:a="http://schemas.openxmlformats.org/drawingml/2006/main"/>
           <a:p xmlns:a="http://schemas.openxmlformats.org/drawingml/2006/main">
             <a:pPr algn="l">
+              <a:buNone/>
               <a:defRPr sz="1125" b="0">
                 <a:solidFill>
                   <a:srgbClr val="606662"/>
@@ -8260,7 +8357,7 @@
                   <a:srgbClr val="606662"/>
                 </a:solidFill>
               </a:rPr>
-              <a:t>16 bootstrap members</a:t>
+              <a:t>32% test precision</a:t>
             </a:r>
           </a:p>
         </p:txBody>
@@ -8300,6 +8397,7 @@
           <a:lstStyle xmlns:a="http://schemas.openxmlformats.org/drawingml/2006/main"/>
           <a:p xmlns:a="http://schemas.openxmlformats.org/drawingml/2006/main">
             <a:pPr algn="l">
+              <a:buNone/>
               <a:defRPr sz="1125" b="0">
                 <a:solidFill>
                   <a:srgbClr val="606662"/>
@@ -8312,7 +8410,7 @@
                   <a:srgbClr val="606662"/>
                 </a:solidFill>
               </a:rPr>
-              <a:t>Exact attribution</a:t>
+              <a:t>42% rows flagged</a:t>
             </a:r>
           </a:p>
         </p:txBody>
@@ -8359,11 +8457,11 @@
           <p:nvPr/>
         </p:nvPicPr>
         <p:blipFill>
-          <a:blip xmlns:r="http://schemas.openxmlformats.org/officeDocument/2006/relationships" xmlns:a="http://schemas.openxmlformats.org/drawingml/2006/main" r:embed="Rc0b4473947c54c08"/>
+          <a:blip xmlns:r="http://schemas.openxmlformats.org/officeDocument/2006/relationships" xmlns:a="http://schemas.openxmlformats.org/drawingml/2006/main" r:embed="R17f198ec848446c1"/>
           <a:stretch xmlns:a="http://schemas.openxmlformats.org/drawingml/2006/main"/>
         </p:blipFill>
         <p:spPr>
-          <a:xfrm xmlns:a="http://schemas.openxmlformats.org/drawingml/2006/main">
+          <a:xfrm xmlns:a="http://schemas.openxmlformats.org/drawingml/2006/main" flipH="0" flipV="0">
             <a:off x="1847850" y="1257300"/>
             <a:ext cx="9753600" cy="5486400"/>
           </a:xfrm>

</xml_diff>

<commit_message>
Refine the care-ledger demo experience
</commit_message>
<xml_diff>
--- a/outputs/adherence-os-demo.pptx
+++ b/outputs/adherence-os-demo.pptx
@@ -2,22 +2,22 @@
 <file path=ppt/presentation.xml><?xml version="1.0" encoding="utf-8"?>
 <p:presentation xmlns:p="http://schemas.openxmlformats.org/presentationml/2006/main">
   <p:sldMasterIdLst>
-    <p:sldMasterId xmlns:r="http://schemas.openxmlformats.org/officeDocument/2006/relationships" id="2147483648" r:id="R0d829058331f4295"/>
+    <p:sldMasterId xmlns:r="http://schemas.openxmlformats.org/officeDocument/2006/relationships" id="2147483648" r:id="R0135ee64c83c4073"/>
   </p:sldMasterIdLst>
   <p:notesMasterIdLst>
-    <p:notesMasterId xmlns:r="http://schemas.openxmlformats.org/officeDocument/2006/relationships" r:id="R039ff5c09f774ca7"/>
+    <p:notesMasterId xmlns:r="http://schemas.openxmlformats.org/officeDocument/2006/relationships" r:id="R16a44fd93111425e"/>
   </p:notesMasterIdLst>
   <p:sldIdLst>
-    <p:sldId xmlns:r="http://schemas.openxmlformats.org/officeDocument/2006/relationships" id="256" r:id="R73548eb4a80844fd"/>
-    <p:sldId xmlns:r="http://schemas.openxmlformats.org/officeDocument/2006/relationships" id="257" r:id="R204bb8c9252745c4"/>
-    <p:sldId xmlns:r="http://schemas.openxmlformats.org/officeDocument/2006/relationships" id="258" r:id="R9e6377fb93d04d5a"/>
-    <p:sldId xmlns:r="http://schemas.openxmlformats.org/officeDocument/2006/relationships" id="259" r:id="Rdb11769debb7462b"/>
-    <p:sldId xmlns:r="http://schemas.openxmlformats.org/officeDocument/2006/relationships" id="260" r:id="R839ccd251f924a22"/>
-    <p:sldId xmlns:r="http://schemas.openxmlformats.org/officeDocument/2006/relationships" id="261" r:id="R5014c395b73b477a"/>
-    <p:sldId xmlns:r="http://schemas.openxmlformats.org/officeDocument/2006/relationships" id="262" r:id="R45f0c5362dba4f94"/>
-    <p:sldId xmlns:r="http://schemas.openxmlformats.org/officeDocument/2006/relationships" id="263" r:id="R219a8b6c5aa64377"/>
-    <p:sldId xmlns:r="http://schemas.openxmlformats.org/officeDocument/2006/relationships" id="264" r:id="R8989c647789e4342"/>
-    <p:sldId xmlns:r="http://schemas.openxmlformats.org/officeDocument/2006/relationships" id="265" r:id="Rb8fbffdee6c540c4"/>
+    <p:sldId xmlns:r="http://schemas.openxmlformats.org/officeDocument/2006/relationships" id="256" r:id="R33610fee40e54443"/>
+    <p:sldId xmlns:r="http://schemas.openxmlformats.org/officeDocument/2006/relationships" id="257" r:id="Red86e0d3ac454954"/>
+    <p:sldId xmlns:r="http://schemas.openxmlformats.org/officeDocument/2006/relationships" id="258" r:id="R4d4bef340c504021"/>
+    <p:sldId xmlns:r="http://schemas.openxmlformats.org/officeDocument/2006/relationships" id="259" r:id="Rb5fc31b2ec6240da"/>
+    <p:sldId xmlns:r="http://schemas.openxmlformats.org/officeDocument/2006/relationships" id="260" r:id="R6b61fc8961764f6a"/>
+    <p:sldId xmlns:r="http://schemas.openxmlformats.org/officeDocument/2006/relationships" id="261" r:id="R4cb6219affd1489c"/>
+    <p:sldId xmlns:r="http://schemas.openxmlformats.org/officeDocument/2006/relationships" id="262" r:id="Rf6db507e893e4bfd"/>
+    <p:sldId xmlns:r="http://schemas.openxmlformats.org/officeDocument/2006/relationships" id="263" r:id="R12fc326d56e442d6"/>
+    <p:sldId xmlns:r="http://schemas.openxmlformats.org/officeDocument/2006/relationships" id="264" r:id="Re7a13c20e8354580"/>
+    <p:sldId xmlns:r="http://schemas.openxmlformats.org/officeDocument/2006/relationships" id="265" r:id="Rc4650ce35b114ee6"/>
   </p:sldIdLst>
   <p:sldSz cx="12192000" cy="6858000"/>
   <p:notesSz cx="6858000" cy="9144000"/>
@@ -1204,7 +1204,7 @@
   </p:cSld>
   <p:clrMap bg1="lt1" tx1="dk1" bg2="lt2" tx2="dk2" accent1="accent1" accent2="accent2" accent3="accent3" accent4="accent4" accent5="accent5" accent6="accent6" hlink="hlink" folHlink="folHlink"/>
   <p:sldLayoutIdLst>
-    <p:sldLayoutId xmlns:r="http://schemas.openxmlformats.org/officeDocument/2006/relationships" id="2147483649" r:id="Rb2da8cbf749f4585"/>
+    <p:sldLayoutId xmlns:r="http://schemas.openxmlformats.org/officeDocument/2006/relationships" id="2147483649" r:id="R35100e8d0d9a4760"/>
   </p:sldLayoutIdLst>
   <p:txStyles>
     <p:titleStyle>
@@ -3330,7 +3330,7 @@
                   <a:srgbClr val="171918"/>
                 </a:solidFill>
               </a:rPr>
-              <a:t>Switch from coaching to a local, unsent review draft in one click.</a:t>
+              <a:t>Switch from a supported coaching case to a local, unsent safety draft in one click.</a:t>
             </a:r>
           </a:p>
         </p:txBody>
@@ -3377,7 +3377,7 @@
           <p:nvPr/>
         </p:nvPicPr>
         <p:blipFill>
-          <a:blip xmlns:r="http://schemas.openxmlformats.org/officeDocument/2006/relationships" xmlns:a="http://schemas.openxmlformats.org/drawingml/2006/main" r:embed="R96010832befe4531"/>
+          <a:blip xmlns:r="http://schemas.openxmlformats.org/officeDocument/2006/relationships" xmlns:a="http://schemas.openxmlformats.org/drawingml/2006/main" r:embed="Rfcbec3fb6a7a4a23"/>
           <a:stretch xmlns:a="http://schemas.openxmlformats.org/drawingml/2006/main"/>
         </p:blipFill>
         <p:spPr>
@@ -4236,7 +4236,7 @@
           <p:nvPr/>
         </p:nvPicPr>
         <p:blipFill>
-          <a:blip xmlns:r="http://schemas.openxmlformats.org/officeDocument/2006/relationships" xmlns:a="http://schemas.openxmlformats.org/drawingml/2006/main" r:embed="R6b12589f91e944a4"/>
+          <a:blip xmlns:r="http://schemas.openxmlformats.org/officeDocument/2006/relationships" xmlns:a="http://schemas.openxmlformats.org/drawingml/2006/main" r:embed="R6b7dc08405ac4916"/>
           <a:stretch xmlns:a="http://schemas.openxmlformats.org/drawingml/2006/main"/>
         </p:blipFill>
         <p:spPr>
@@ -6111,7 +6111,7 @@
         </p:spPr>
         <p:txBody>
           <a:bodyPr xmlns:a="http://schemas.openxmlformats.org/drawingml/2006/main" wrap="square" anchor="t">
-            <a:normAutofit fontScale="100000"/>
+            <a:normAutofit fontScale="79532"/>
           </a:bodyPr>
           <a:lstStyle xmlns:a="http://schemas.openxmlformats.org/drawingml/2006/main"/>
           <a:p xmlns:a="http://schemas.openxmlformats.org/drawingml/2006/main">
@@ -6129,7 +6129,7 @@
                   <a:srgbClr val="171918"/>
                 </a:solidFill>
               </a:rPr>
-              <a:t>5% local score</a:t>
+              <a:t>46% supported score</a:t>
             </a:r>
           </a:p>
         </p:txBody>
@@ -6182,7 +6182,7 @@
                   <a:srgbClr val="606662"/>
                 </a:solidFill>
               </a:rPr>
-              <a:t>Context signal visible</a:t>
+              <a:t>Risk-raising signal visible</a:t>
             </a:r>
           </a:p>
         </p:txBody>
@@ -6235,7 +6235,7 @@
                   <a:srgbClr val="606662"/>
                 </a:solidFill>
               </a:rPr>
-              <a:t>Coaching permitted</a:t>
+              <a:t>Watch / no handoff</a:t>
             </a:r>
           </a:p>
         </p:txBody>
@@ -6282,7 +6282,7 @@
           <p:nvPr/>
         </p:nvPicPr>
         <p:blipFill>
-          <a:blip xmlns:r="http://schemas.openxmlformats.org/officeDocument/2006/relationships" xmlns:a="http://schemas.openxmlformats.org/drawingml/2006/main" r:embed="R426ccfd52d11408a"/>
+          <a:blip xmlns:r="http://schemas.openxmlformats.org/officeDocument/2006/relationships" xmlns:a="http://schemas.openxmlformats.org/drawingml/2006/main" r:embed="R256ad90baf544275"/>
           <a:stretch xmlns:a="http://schemas.openxmlformats.org/drawingml/2006/main"/>
         </p:blipFill>
         <p:spPr>
@@ -6564,7 +6564,7 @@
                   <a:srgbClr val="171918"/>
                 </a:solidFill>
               </a:rPr>
-              <a:t>Context signal</a:t>
+              <a:t>Appetite + energy</a:t>
             </a:r>
           </a:p>
         </p:txBody>
@@ -6617,7 +6617,7 @@
                   <a:srgbClr val="606662"/>
                 </a:solidFill>
               </a:rPr>
-              <a:t>Model contributor</a:t>
+              <a:t>Nausea burden</a:t>
             </a:r>
           </a:p>
         </p:txBody>
@@ -6717,7 +6717,7 @@
           <p:nvPr/>
         </p:nvPicPr>
         <p:blipFill>
-          <a:blip xmlns:r="http://schemas.openxmlformats.org/officeDocument/2006/relationships" xmlns:a="http://schemas.openxmlformats.org/drawingml/2006/main" r:embed="Rf1faa1d082c74b8d"/>
+          <a:blip xmlns:r="http://schemas.openxmlformats.org/officeDocument/2006/relationships" xmlns:a="http://schemas.openxmlformats.org/drawingml/2006/main" r:embed="R973d81c199a4486a"/>
           <a:stretch xmlns:a="http://schemas.openxmlformats.org/drawingml/2006/main"/>
         </p:blipFill>
         <p:spPr>
@@ -6999,7 +6999,7 @@
                   <a:srgbClr val="171918"/>
                 </a:solidFill>
               </a:rPr>
-              <a:t>Hydration nudge</a:t>
+              <a:t>Meal timing</a:t>
             </a:r>
           </a:p>
         </p:txBody>
@@ -7052,7 +7052,7 @@
                   <a:srgbClr val="606662"/>
                 </a:solidFill>
               </a:rPr>
-              <a:t>−2 pp scenario score</a:t>
+              <a:t>−19 pp scenario score</a:t>
             </a:r>
           </a:p>
         </p:txBody>
@@ -7152,7 +7152,7 @@
           <p:nvPr/>
         </p:nvPicPr>
         <p:blipFill>
-          <a:blip xmlns:r="http://schemas.openxmlformats.org/officeDocument/2006/relationships" xmlns:a="http://schemas.openxmlformats.org/drawingml/2006/main" r:embed="R00122b5048894809"/>
+          <a:blip xmlns:r="http://schemas.openxmlformats.org/officeDocument/2006/relationships" xmlns:a="http://schemas.openxmlformats.org/drawingml/2006/main" r:embed="R7f96b910e98a41c5"/>
           <a:stretch xmlns:a="http://schemas.openxmlformats.org/drawingml/2006/main"/>
         </p:blipFill>
         <p:spPr>
@@ -7330,7 +7330,7 @@
         </p:spPr>
         <p:txBody>
           <a:bodyPr xmlns:a="http://schemas.openxmlformats.org/drawingml/2006/main" wrap="square" anchor="t">
-            <a:normAutofit fontScale="92308"/>
+            <a:normAutofit fontScale="88227"/>
           </a:bodyPr>
           <a:lstStyle xmlns:a="http://schemas.openxmlformats.org/drawingml/2006/main"/>
           <a:p xmlns:a="http://schemas.openxmlformats.org/drawingml/2006/main">
@@ -7348,7 +7348,7 @@
                   <a:srgbClr val="606662"/>
                 </a:solidFill>
               </a:rPr>
-              <a:t>04 / ESCALATION</a:t>
+              <a:t>04 / SAFETY CASE</a:t>
             </a:r>
           </a:p>
         </p:txBody>
@@ -7587,7 +7587,7 @@
           <p:nvPr/>
         </p:nvPicPr>
         <p:blipFill>
-          <a:blip xmlns:r="http://schemas.openxmlformats.org/officeDocument/2006/relationships" xmlns:a="http://schemas.openxmlformats.org/drawingml/2006/main" r:embed="Rb09321ca98a547e2"/>
+          <a:blip xmlns:r="http://schemas.openxmlformats.org/officeDocument/2006/relationships" xmlns:a="http://schemas.openxmlformats.org/drawingml/2006/main" r:embed="R193d9d7371b8493c"/>
           <a:stretch xmlns:a="http://schemas.openxmlformats.org/drawingml/2006/main"/>
         </p:blipFill>
         <p:spPr>
@@ -8022,7 +8022,7 @@
           <p:nvPr/>
         </p:nvPicPr>
         <p:blipFill>
-          <a:blip xmlns:r="http://schemas.openxmlformats.org/officeDocument/2006/relationships" xmlns:a="http://schemas.openxmlformats.org/drawingml/2006/main" r:embed="Rbda9cbf270da4512"/>
+          <a:blip xmlns:r="http://schemas.openxmlformats.org/officeDocument/2006/relationships" xmlns:a="http://schemas.openxmlformats.org/drawingml/2006/main" r:embed="R67d6f0b4d0b54e30"/>
           <a:stretch xmlns:a="http://schemas.openxmlformats.org/drawingml/2006/main"/>
         </p:blipFill>
         <p:spPr>
@@ -8457,7 +8457,7 @@
           <p:nvPr/>
         </p:nvPicPr>
         <p:blipFill>
-          <a:blip xmlns:r="http://schemas.openxmlformats.org/officeDocument/2006/relationships" xmlns:a="http://schemas.openxmlformats.org/drawingml/2006/main" r:embed="R17f198ec848446c1"/>
+          <a:blip xmlns:r="http://schemas.openxmlformats.org/officeDocument/2006/relationships" xmlns:a="http://schemas.openxmlformats.org/drawingml/2006/main" r:embed="Re553b94f69ee4504"/>
           <a:stretch xmlns:a="http://schemas.openxmlformats.org/drawingml/2006/main"/>
         </p:blipFill>
         <p:spPr>

</xml_diff>

<commit_message>
chore: refresh verified demo evidence
</commit_message>
<xml_diff>
--- a/outputs/adherence-os-demo.pptx
+++ b/outputs/adherence-os-demo.pptx
@@ -2,22 +2,22 @@
 <file path=ppt/presentation.xml><?xml version="1.0" encoding="utf-8"?>
 <p:presentation xmlns:p="http://schemas.openxmlformats.org/presentationml/2006/main">
   <p:sldMasterIdLst>
-    <p:sldMasterId xmlns:r="http://schemas.openxmlformats.org/officeDocument/2006/relationships" id="2147483648" r:id="R0135ee64c83c4073"/>
+    <p:sldMasterId xmlns:r="http://schemas.openxmlformats.org/officeDocument/2006/relationships" id="2147483648" r:id="Rd850e5d4f9414768"/>
   </p:sldMasterIdLst>
   <p:notesMasterIdLst>
-    <p:notesMasterId xmlns:r="http://schemas.openxmlformats.org/officeDocument/2006/relationships" r:id="R16a44fd93111425e"/>
+    <p:notesMasterId xmlns:r="http://schemas.openxmlformats.org/officeDocument/2006/relationships" r:id="R892414c82d804c4f"/>
   </p:notesMasterIdLst>
   <p:sldIdLst>
-    <p:sldId xmlns:r="http://schemas.openxmlformats.org/officeDocument/2006/relationships" id="256" r:id="R33610fee40e54443"/>
-    <p:sldId xmlns:r="http://schemas.openxmlformats.org/officeDocument/2006/relationships" id="257" r:id="Red86e0d3ac454954"/>
-    <p:sldId xmlns:r="http://schemas.openxmlformats.org/officeDocument/2006/relationships" id="258" r:id="R4d4bef340c504021"/>
-    <p:sldId xmlns:r="http://schemas.openxmlformats.org/officeDocument/2006/relationships" id="259" r:id="Rb5fc31b2ec6240da"/>
-    <p:sldId xmlns:r="http://schemas.openxmlformats.org/officeDocument/2006/relationships" id="260" r:id="R6b61fc8961764f6a"/>
-    <p:sldId xmlns:r="http://schemas.openxmlformats.org/officeDocument/2006/relationships" id="261" r:id="R4cb6219affd1489c"/>
-    <p:sldId xmlns:r="http://schemas.openxmlformats.org/officeDocument/2006/relationships" id="262" r:id="Rf6db507e893e4bfd"/>
-    <p:sldId xmlns:r="http://schemas.openxmlformats.org/officeDocument/2006/relationships" id="263" r:id="R12fc326d56e442d6"/>
-    <p:sldId xmlns:r="http://schemas.openxmlformats.org/officeDocument/2006/relationships" id="264" r:id="Re7a13c20e8354580"/>
-    <p:sldId xmlns:r="http://schemas.openxmlformats.org/officeDocument/2006/relationships" id="265" r:id="Rc4650ce35b114ee6"/>
+    <p:sldId xmlns:r="http://schemas.openxmlformats.org/officeDocument/2006/relationships" id="256" r:id="Rc4e656caca7d477d"/>
+    <p:sldId xmlns:r="http://schemas.openxmlformats.org/officeDocument/2006/relationships" id="257" r:id="R5ed970f194ba4c03"/>
+    <p:sldId xmlns:r="http://schemas.openxmlformats.org/officeDocument/2006/relationships" id="258" r:id="Rb3e100e16b534b4b"/>
+    <p:sldId xmlns:r="http://schemas.openxmlformats.org/officeDocument/2006/relationships" id="259" r:id="Rdc4162653afc4d54"/>
+    <p:sldId xmlns:r="http://schemas.openxmlformats.org/officeDocument/2006/relationships" id="260" r:id="Rcfc9513da0ff46ee"/>
+    <p:sldId xmlns:r="http://schemas.openxmlformats.org/officeDocument/2006/relationships" id="261" r:id="R47ec009811cd4a51"/>
+    <p:sldId xmlns:r="http://schemas.openxmlformats.org/officeDocument/2006/relationships" id="262" r:id="R599428c688844c49"/>
+    <p:sldId xmlns:r="http://schemas.openxmlformats.org/officeDocument/2006/relationships" id="263" r:id="R3205bacef686417c"/>
+    <p:sldId xmlns:r="http://schemas.openxmlformats.org/officeDocument/2006/relationships" id="264" r:id="R7e6a5a0fb62e40ea"/>
+    <p:sldId xmlns:r="http://schemas.openxmlformats.org/officeDocument/2006/relationships" id="265" r:id="R032dedefbbcd4901"/>
   </p:sldIdLst>
   <p:sldSz cx="12192000" cy="6858000"/>
   <p:notesSz cx="6858000" cy="9144000"/>
@@ -1204,7 +1204,7 @@
   </p:cSld>
   <p:clrMap bg1="lt1" tx1="dk1" bg2="lt2" tx2="dk2" accent1="accent1" accent2="accent2" accent3="accent3" accent4="accent4" accent5="accent5" accent6="accent6" hlink="hlink" folHlink="folHlink"/>
   <p:sldLayoutIdLst>
-    <p:sldLayoutId xmlns:r="http://schemas.openxmlformats.org/officeDocument/2006/relationships" id="2147483649" r:id="R35100e8d0d9a4760"/>
+    <p:sldLayoutId xmlns:r="http://schemas.openxmlformats.org/officeDocument/2006/relationships" id="2147483649" r:id="R355feba1562e4525"/>
   </p:sldLayoutIdLst>
   <p:txStyles>
     <p:titleStyle>
@@ -3377,7 +3377,7 @@
           <p:nvPr/>
         </p:nvPicPr>
         <p:blipFill>
-          <a:blip xmlns:r="http://schemas.openxmlformats.org/officeDocument/2006/relationships" xmlns:a="http://schemas.openxmlformats.org/drawingml/2006/main" r:embed="Rfcbec3fb6a7a4a23"/>
+          <a:blip xmlns:r="http://schemas.openxmlformats.org/officeDocument/2006/relationships" xmlns:a="http://schemas.openxmlformats.org/drawingml/2006/main" r:embed="Rd94b102da6754895"/>
           <a:stretch xmlns:a="http://schemas.openxmlformats.org/drawingml/2006/main"/>
         </p:blipFill>
         <p:spPr>
@@ -4236,7 +4236,7 @@
           <p:nvPr/>
         </p:nvPicPr>
         <p:blipFill>
-          <a:blip xmlns:r="http://schemas.openxmlformats.org/officeDocument/2006/relationships" xmlns:a="http://schemas.openxmlformats.org/drawingml/2006/main" r:embed="R6b7dc08405ac4916"/>
+          <a:blip xmlns:r="http://schemas.openxmlformats.org/officeDocument/2006/relationships" xmlns:a="http://schemas.openxmlformats.org/drawingml/2006/main" r:embed="R641671a7a6114e03"/>
           <a:stretch xmlns:a="http://schemas.openxmlformats.org/drawingml/2006/main"/>
         </p:blipFill>
         <p:spPr>
@@ -6129,7 +6129,7 @@
                   <a:srgbClr val="171918"/>
                 </a:solidFill>
               </a:rPr>
-              <a:t>46% supported score</a:t>
+              <a:t>42% supported score</a:t>
             </a:r>
           </a:p>
         </p:txBody>
@@ -6282,7 +6282,7 @@
           <p:nvPr/>
         </p:nvPicPr>
         <p:blipFill>
-          <a:blip xmlns:r="http://schemas.openxmlformats.org/officeDocument/2006/relationships" xmlns:a="http://schemas.openxmlformats.org/drawingml/2006/main" r:embed="R256ad90baf544275"/>
+          <a:blip xmlns:r="http://schemas.openxmlformats.org/officeDocument/2006/relationships" xmlns:a="http://schemas.openxmlformats.org/drawingml/2006/main" r:embed="R5eb0bf3b99ca4a2c"/>
           <a:stretch xmlns:a="http://schemas.openxmlformats.org/drawingml/2006/main"/>
         </p:blipFill>
         <p:spPr>
@@ -6717,7 +6717,7 @@
           <p:nvPr/>
         </p:nvPicPr>
         <p:blipFill>
-          <a:blip xmlns:r="http://schemas.openxmlformats.org/officeDocument/2006/relationships" xmlns:a="http://schemas.openxmlformats.org/drawingml/2006/main" r:embed="R973d81c199a4486a"/>
+          <a:blip xmlns:r="http://schemas.openxmlformats.org/officeDocument/2006/relationships" xmlns:a="http://schemas.openxmlformats.org/drawingml/2006/main" r:embed="R30b7f9b071be45b6"/>
           <a:stretch xmlns:a="http://schemas.openxmlformats.org/drawingml/2006/main"/>
         </p:blipFill>
         <p:spPr>
@@ -7052,7 +7052,7 @@
                   <a:srgbClr val="606662"/>
                 </a:solidFill>
               </a:rPr>
-              <a:t>−19 pp scenario score</a:t>
+              <a:t>−16 pp scenario score</a:t>
             </a:r>
           </a:p>
         </p:txBody>
@@ -7152,7 +7152,7 @@
           <p:nvPr/>
         </p:nvPicPr>
         <p:blipFill>
-          <a:blip xmlns:r="http://schemas.openxmlformats.org/officeDocument/2006/relationships" xmlns:a="http://schemas.openxmlformats.org/drawingml/2006/main" r:embed="R7f96b910e98a41c5"/>
+          <a:blip xmlns:r="http://schemas.openxmlformats.org/officeDocument/2006/relationships" xmlns:a="http://schemas.openxmlformats.org/drawingml/2006/main" r:embed="Rd53be6ceefee48b2"/>
           <a:stretch xmlns:a="http://schemas.openxmlformats.org/drawingml/2006/main"/>
         </p:blipFill>
         <p:spPr>
@@ -7587,7 +7587,7 @@
           <p:nvPr/>
         </p:nvPicPr>
         <p:blipFill>
-          <a:blip xmlns:r="http://schemas.openxmlformats.org/officeDocument/2006/relationships" xmlns:a="http://schemas.openxmlformats.org/drawingml/2006/main" r:embed="R193d9d7371b8493c"/>
+          <a:blip xmlns:r="http://schemas.openxmlformats.org/officeDocument/2006/relationships" xmlns:a="http://schemas.openxmlformats.org/drawingml/2006/main" r:embed="R9044a346020d401e"/>
           <a:stretch xmlns:a="http://schemas.openxmlformats.org/drawingml/2006/main"/>
         </p:blipFill>
         <p:spPr>
@@ -8022,7 +8022,7 @@
           <p:nvPr/>
         </p:nvPicPr>
         <p:blipFill>
-          <a:blip xmlns:r="http://schemas.openxmlformats.org/officeDocument/2006/relationships" xmlns:a="http://schemas.openxmlformats.org/drawingml/2006/main" r:embed="R67d6f0b4d0b54e30"/>
+          <a:blip xmlns:r="http://schemas.openxmlformats.org/officeDocument/2006/relationships" xmlns:a="http://schemas.openxmlformats.org/drawingml/2006/main" r:embed="R1b183c4fed7d4333"/>
           <a:stretch xmlns:a="http://schemas.openxmlformats.org/drawingml/2006/main"/>
         </p:blipFill>
         <p:spPr>
@@ -8286,7 +8286,7 @@
         </p:spPr>
         <p:txBody>
           <a:bodyPr xmlns:a="http://schemas.openxmlformats.org/drawingml/2006/main" wrap="square" anchor="t">
-            <a:normAutofit fontScale="100000"/>
+            <a:normAutofit fontScale="88250"/>
           </a:bodyPr>
           <a:lstStyle xmlns:a="http://schemas.openxmlformats.org/drawingml/2006/main"/>
           <a:p xmlns:a="http://schemas.openxmlformats.org/drawingml/2006/main">
@@ -8304,7 +8304,7 @@
                   <a:srgbClr val="171918"/>
                 </a:solidFill>
               </a:rPr>
-              <a:t>80% test recall</a:t>
+              <a:t>AUPRC 0.517 / 0.237</a:t>
             </a:r>
           </a:p>
         </p:txBody>
@@ -8357,7 +8357,7 @@
                   <a:srgbClr val="606662"/>
                 </a:solidFill>
               </a:rPr>
-              <a:t>32% test precision</a:t>
+              <a:t>Rows flagged 33% / 57%</a:t>
             </a:r>
           </a:p>
         </p:txBody>
@@ -8410,7 +8410,7 @@
                   <a:srgbClr val="606662"/>
                 </a:solidFill>
               </a:rPr>
-              <a:t>42% rows flagged</a:t>
+              <a:t>Runtime coverage 90%</a:t>
             </a:r>
           </a:p>
         </p:txBody>
@@ -8457,7 +8457,7 @@
           <p:nvPr/>
         </p:nvPicPr>
         <p:blipFill>
-          <a:blip xmlns:r="http://schemas.openxmlformats.org/officeDocument/2006/relationships" xmlns:a="http://schemas.openxmlformats.org/drawingml/2006/main" r:embed="Re553b94f69ee4504"/>
+          <a:blip xmlns:r="http://schemas.openxmlformats.org/officeDocument/2006/relationships" xmlns:a="http://schemas.openxmlformats.org/drawingml/2006/main" r:embed="Ra4eae015b79b4d64"/>
           <a:stretch xmlns:a="http://schemas.openxmlformats.org/drawingml/2006/main"/>
         </p:blipFill>
         <p:spPr>

</xml_diff>